<commit_message>
Add speaker notes to module decks
Add instructor speaker notes to each generated PowerPoint deck using module outlines, lab context, and Microsoft Learn source references.

Co-authored-by: Copilot <223556219+Copilot@users.noreply.github.com>
</commit_message>
<xml_diff>
--- a/modules/01-advanced-semantic-modeling/assets/advanced-semantic-modeling.pptx
+++ b/modules/01-advanced-semantic-modeling/assets/advanced-semantic-modeling.pptx
@@ -133,6 +133,1631 @@
     </p:ext>
   </p:extLst>
 </p:presentation>
+</file>
+
+<file path=ppt/notesMasters/notesMaster1.xml><?xml version="1.0" encoding="utf-8"?>
+<p:notesMaster xmlns:a="http://schemas.openxmlformats.org/drawingml/2006/main" xmlns:p="http://schemas.openxmlformats.org/presentationml/2006/main" xmlns:r="http://schemas.openxmlformats.org/officeDocument/2006/relationships">
+  <p:cSld>
+    <p:bg>
+      <p:bgRef idx="1001">
+        <a:schemeClr val="bg1"/>
+      </p:bgRef>
+    </p:bg>
+    <p:spTree>
+      <p:nvGrpSpPr>
+        <p:cNvPr id="1" name=""/>
+        <p:cNvGrpSpPr/>
+        <p:nvPr/>
+      </p:nvGrpSpPr>
+      <p:grpSpPr>
+        <a:xfrm>
+          <a:off x="0" y="0"/>
+          <a:ext cx="0" cy="0"/>
+          <a:chOff x="0" y="0"/>
+          <a:chExt cx="0" cy="0"/>
+        </a:xfrm>
+      </p:grpSpPr>
+      <p:sp>
+        <p:nvSpPr>
+          <p:cNvPr id="2" name="Header Placeholder 1"/>
+          <p:cNvSpPr>
+            <a:spLocks noGrp="1"/>
+          </p:cNvSpPr>
+          <p:nvPr>
+            <p:ph type="hdr" sz="quarter"/>
+          </p:nvPr>
+        </p:nvSpPr>
+        <p:spPr>
+          <a:xfrm>
+            <a:off x="0" y="0"/>
+            <a:ext cx="2971800" cy="457200"/>
+          </a:xfrm>
+          <a:prstGeom prst="rect">
+            <a:avLst/>
+          </a:prstGeom>
+        </p:spPr>
+        <p:txBody>
+          <a:bodyPr vert="horz" lIns="91440" tIns="45720" rIns="91440" bIns="45720" rtlCol="0"/>
+          <a:lstStyle>
+            <a:lvl1pPr algn="l">
+              <a:defRPr sz="1200"/>
+            </a:lvl1pPr>
+          </a:lstStyle>
+          <a:p>
+            <a:endParaRPr lang="en-US"/>
+          </a:p>
+        </p:txBody>
+      </p:sp>
+      <p:sp>
+        <p:nvSpPr>
+          <p:cNvPr id="3" name="Date Placeholder 2"/>
+          <p:cNvSpPr>
+            <a:spLocks noGrp="1"/>
+          </p:cNvSpPr>
+          <p:nvPr>
+            <p:ph type="dt" idx="1"/>
+          </p:nvPr>
+        </p:nvSpPr>
+        <p:spPr>
+          <a:xfrm>
+            <a:off x="3884613" y="0"/>
+            <a:ext cx="2971800" cy="457200"/>
+          </a:xfrm>
+          <a:prstGeom prst="rect">
+            <a:avLst/>
+          </a:prstGeom>
+        </p:spPr>
+        <p:txBody>
+          <a:bodyPr vert="horz" lIns="91440" tIns="45720" rIns="91440" bIns="45720" rtlCol="0"/>
+          <a:lstStyle>
+            <a:lvl1pPr algn="r">
+              <a:defRPr sz="1200"/>
+            </a:lvl1pPr>
+          </a:lstStyle>
+          <a:p>
+            <a:fld id="{0F89C1C7-3DCD-1040-A9CF-14679D8B5DDD}" type="datetimeFigureOut">
+              <a:rPr lang="en-US" smtClean="0"/>
+              <a:t>10/17/16</a:t>
+            </a:fld>
+            <a:endParaRPr lang="en-US"/>
+          </a:p>
+        </p:txBody>
+      </p:sp>
+      <p:sp>
+        <p:nvSpPr>
+          <p:cNvPr id="4" name="Slide Image Placeholder 3"/>
+          <p:cNvSpPr>
+            <a:spLocks noGrp="1" noRot="1" noChangeAspect="1"/>
+          </p:cNvSpPr>
+          <p:nvPr>
+            <p:ph type="sldImg" idx="2"/>
+          </p:nvPr>
+        </p:nvSpPr>
+        <p:spPr>
+          <a:xfrm>
+            <a:off x="1143000" y="685800"/>
+            <a:ext cx="4572000" cy="3429000"/>
+          </a:xfrm>
+          <a:prstGeom prst="rect">
+            <a:avLst/>
+          </a:prstGeom>
+          <a:noFill/>
+          <a:ln w="12700">
+            <a:solidFill>
+              <a:prstClr val="black"/>
+            </a:solidFill>
+          </a:ln>
+        </p:spPr>
+        <p:txBody>
+          <a:bodyPr vert="horz" lIns="91440" tIns="45720" rIns="91440" bIns="45720" rtlCol="0" anchor="ctr"/>
+          <a:lstStyle/>
+          <a:p>
+            <a:endParaRPr lang="en-US"/>
+          </a:p>
+        </p:txBody>
+      </p:sp>
+      <p:sp>
+        <p:nvSpPr>
+          <p:cNvPr id="5" name="Notes Placeholder 4"/>
+          <p:cNvSpPr>
+            <a:spLocks noGrp="1"/>
+          </p:cNvSpPr>
+          <p:nvPr>
+            <p:ph type="body" sz="quarter" idx="3"/>
+          </p:nvPr>
+        </p:nvSpPr>
+        <p:spPr>
+          <a:xfrm>
+            <a:off x="685800" y="4343400"/>
+            <a:ext cx="5486400" cy="4114800"/>
+          </a:xfrm>
+          <a:prstGeom prst="rect">
+            <a:avLst/>
+          </a:prstGeom>
+        </p:spPr>
+        <p:txBody>
+          <a:bodyPr vert="horz" lIns="91440" tIns="45720" rIns="91440" bIns="45720" rtlCol="0"/>
+          <a:lstStyle/>
+          <a:p>
+            <a:pPr lvl="0"/>
+            <a:r>
+              <a:rPr lang="en-US" smtClean="0"/>
+              <a:t>Click to edit Master text styles</a:t>
+            </a:r>
+          </a:p>
+          <a:p>
+            <a:pPr lvl="1"/>
+            <a:r>
+              <a:rPr lang="en-US" smtClean="0"/>
+              <a:t>Second level</a:t>
+            </a:r>
+          </a:p>
+          <a:p>
+            <a:pPr lvl="2"/>
+            <a:r>
+              <a:rPr lang="en-US" smtClean="0"/>
+              <a:t>Third level</a:t>
+            </a:r>
+          </a:p>
+          <a:p>
+            <a:pPr lvl="3"/>
+            <a:r>
+              <a:rPr lang="en-US" smtClean="0"/>
+              <a:t>Fourth level</a:t>
+            </a:r>
+          </a:p>
+          <a:p>
+            <a:pPr lvl="4"/>
+            <a:r>
+              <a:rPr lang="en-US" smtClean="0"/>
+              <a:t>Fifth level</a:t>
+            </a:r>
+            <a:endParaRPr lang="en-US"/>
+          </a:p>
+        </p:txBody>
+      </p:sp>
+      <p:sp>
+        <p:nvSpPr>
+          <p:cNvPr id="6" name="Footer Placeholder 5"/>
+          <p:cNvSpPr>
+            <a:spLocks noGrp="1"/>
+          </p:cNvSpPr>
+          <p:nvPr>
+            <p:ph type="ftr" sz="quarter" idx="4"/>
+          </p:nvPr>
+        </p:nvSpPr>
+        <p:spPr>
+          <a:xfrm>
+            <a:off x="0" y="8685213"/>
+            <a:ext cx="2971800" cy="457200"/>
+          </a:xfrm>
+          <a:prstGeom prst="rect">
+            <a:avLst/>
+          </a:prstGeom>
+        </p:spPr>
+        <p:txBody>
+          <a:bodyPr vert="horz" lIns="91440" tIns="45720" rIns="91440" bIns="45720" rtlCol="0" anchor="b"/>
+          <a:lstStyle>
+            <a:lvl1pPr algn="l">
+              <a:defRPr sz="1200"/>
+            </a:lvl1pPr>
+          </a:lstStyle>
+          <a:p>
+            <a:endParaRPr lang="en-US"/>
+          </a:p>
+        </p:txBody>
+      </p:sp>
+      <p:sp>
+        <p:nvSpPr>
+          <p:cNvPr id="7" name="Slide Number Placeholder 6"/>
+          <p:cNvSpPr>
+            <a:spLocks noGrp="1"/>
+          </p:cNvSpPr>
+          <p:nvPr>
+            <p:ph type="sldNum" sz="quarter" idx="5"/>
+          </p:nvPr>
+        </p:nvSpPr>
+        <p:spPr>
+          <a:xfrm>
+            <a:off x="3884613" y="8685213"/>
+            <a:ext cx="2971800" cy="457200"/>
+          </a:xfrm>
+          <a:prstGeom prst="rect">
+            <a:avLst/>
+          </a:prstGeom>
+        </p:spPr>
+        <p:txBody>
+          <a:bodyPr vert="horz" lIns="91440" tIns="45720" rIns="91440" bIns="45720" rtlCol="0" anchor="b"/>
+          <a:lstStyle>
+            <a:lvl1pPr algn="r">
+              <a:defRPr sz="1200"/>
+            </a:lvl1pPr>
+          </a:lstStyle>
+          <a:p>
+            <a:fld id="{BB5E49A5-4136-284D-997B-48E1D791AD67}" type="slidenum">
+              <a:rPr lang="en-US" smtClean="0"/>
+              <a:t>‹#›</a:t>
+            </a:fld>
+            <a:endParaRPr lang="en-US"/>
+          </a:p>
+        </p:txBody>
+      </p:sp>
+    </p:spTree>
+    <p:extLst>
+      <p:ext uri="{BB962C8B-B14F-4D97-AF65-F5344CB8AC3E}">
+        <p14:creationId xmlns:p14="http://schemas.microsoft.com/office/powerpoint/2010/main" val="2623252185"/>
+      </p:ext>
+    </p:extLst>
+  </p:cSld>
+  <p:clrMap bg1="lt1" tx1="dk1" bg2="lt2" tx2="dk2" accent1="accent1" accent2="accent2" accent3="accent3" accent4="accent4" accent5="accent5" accent6="accent6" hlink="hlink" folHlink="folHlink"/>
+  <p:notesStyle>
+    <a:lvl1pPr marL="0" algn="l" defTabSz="457200" rtl="0" eaLnBrk="1" latinLnBrk="0" hangingPunct="1">
+      <a:defRPr sz="1200" kern="1200">
+        <a:solidFill>
+          <a:schemeClr val="tx1"/>
+        </a:solidFill>
+        <a:latin typeface="+mn-lt"/>
+        <a:ea typeface="+mn-ea"/>
+        <a:cs typeface="+mn-cs"/>
+      </a:defRPr>
+    </a:lvl1pPr>
+    <a:lvl2pPr marL="457200" algn="l" defTabSz="457200" rtl="0" eaLnBrk="1" latinLnBrk="0" hangingPunct="1">
+      <a:defRPr sz="1200" kern="1200">
+        <a:solidFill>
+          <a:schemeClr val="tx1"/>
+        </a:solidFill>
+        <a:latin typeface="+mn-lt"/>
+        <a:ea typeface="+mn-ea"/>
+        <a:cs typeface="+mn-cs"/>
+      </a:defRPr>
+    </a:lvl2pPr>
+    <a:lvl3pPr marL="914400" algn="l" defTabSz="457200" rtl="0" eaLnBrk="1" latinLnBrk="0" hangingPunct="1">
+      <a:defRPr sz="1200" kern="1200">
+        <a:solidFill>
+          <a:schemeClr val="tx1"/>
+        </a:solidFill>
+        <a:latin typeface="+mn-lt"/>
+        <a:ea typeface="+mn-ea"/>
+        <a:cs typeface="+mn-cs"/>
+      </a:defRPr>
+    </a:lvl3pPr>
+    <a:lvl4pPr marL="1371600" algn="l" defTabSz="457200" rtl="0" eaLnBrk="1" latinLnBrk="0" hangingPunct="1">
+      <a:defRPr sz="1200" kern="1200">
+        <a:solidFill>
+          <a:schemeClr val="tx1"/>
+        </a:solidFill>
+        <a:latin typeface="+mn-lt"/>
+        <a:ea typeface="+mn-ea"/>
+        <a:cs typeface="+mn-cs"/>
+      </a:defRPr>
+    </a:lvl4pPr>
+    <a:lvl5pPr marL="1828800" algn="l" defTabSz="457200" rtl="0" eaLnBrk="1" latinLnBrk="0" hangingPunct="1">
+      <a:defRPr sz="1200" kern="1200">
+        <a:solidFill>
+          <a:schemeClr val="tx1"/>
+        </a:solidFill>
+        <a:latin typeface="+mn-lt"/>
+        <a:ea typeface="+mn-ea"/>
+        <a:cs typeface="+mn-cs"/>
+      </a:defRPr>
+    </a:lvl5pPr>
+    <a:lvl6pPr marL="2286000" algn="l" defTabSz="457200" rtl="0" eaLnBrk="1" latinLnBrk="0" hangingPunct="1">
+      <a:defRPr sz="1200" kern="1200">
+        <a:solidFill>
+          <a:schemeClr val="tx1"/>
+        </a:solidFill>
+        <a:latin typeface="+mn-lt"/>
+        <a:ea typeface="+mn-ea"/>
+        <a:cs typeface="+mn-cs"/>
+      </a:defRPr>
+    </a:lvl6pPr>
+    <a:lvl7pPr marL="2743200" algn="l" defTabSz="457200" rtl="0" eaLnBrk="1" latinLnBrk="0" hangingPunct="1">
+      <a:defRPr sz="1200" kern="1200">
+        <a:solidFill>
+          <a:schemeClr val="tx1"/>
+        </a:solidFill>
+        <a:latin typeface="+mn-lt"/>
+        <a:ea typeface="+mn-ea"/>
+        <a:cs typeface="+mn-cs"/>
+      </a:defRPr>
+    </a:lvl7pPr>
+    <a:lvl8pPr marL="3200400" algn="l" defTabSz="457200" rtl="0" eaLnBrk="1" latinLnBrk="0" hangingPunct="1">
+      <a:defRPr sz="1200" kern="1200">
+        <a:solidFill>
+          <a:schemeClr val="tx1"/>
+        </a:solidFill>
+        <a:latin typeface="+mn-lt"/>
+        <a:ea typeface="+mn-ea"/>
+        <a:cs typeface="+mn-cs"/>
+      </a:defRPr>
+    </a:lvl8pPr>
+    <a:lvl9pPr marL="3657600" algn="l" defTabSz="457200" rtl="0" eaLnBrk="1" latinLnBrk="0" hangingPunct="1">
+      <a:defRPr sz="1200" kern="1200">
+        <a:solidFill>
+          <a:schemeClr val="tx1"/>
+        </a:solidFill>
+        <a:latin typeface="+mn-lt"/>
+        <a:ea typeface="+mn-ea"/>
+        <a:cs typeface="+mn-cs"/>
+      </a:defRPr>
+    </a:lvl9pPr>
+  </p:notesStyle>
+</p:notesMaster>
+</file>
+
+<file path=ppt/notesSlides/notesSlide1.xml><?xml version="1.0" encoding="utf-8"?>
+<p:notes xmlns:a="http://schemas.openxmlformats.org/drawingml/2006/main" xmlns:p="http://schemas.openxmlformats.org/presentationml/2006/main" xmlns:r="http://schemas.openxmlformats.org/officeDocument/2006/relationships">
+  <p:cSld>
+    <p:spTree>
+      <p:nvGrpSpPr>
+        <p:cNvPr id="1" name=""/>
+        <p:cNvGrpSpPr/>
+        <p:nvPr/>
+      </p:nvGrpSpPr>
+      <p:grpSpPr>
+        <a:xfrm>
+          <a:off x="0" y="0"/>
+          <a:ext cx="0" cy="0"/>
+          <a:chOff x="0" y="0"/>
+          <a:chExt cx="0" cy="0"/>
+        </a:xfrm>
+      </p:grpSpPr>
+      <p:sp>
+        <p:nvSpPr>
+          <p:cNvPr id="2" name="Slide Image Placeholder 1"/>
+          <p:cNvSpPr>
+            <a:spLocks noGrp="1"/>
+          </p:cNvSpPr>
+          <p:nvPr>
+            <p:ph type="sldImg" idx="2"/>
+          </p:nvPr>
+        </p:nvSpPr>
+        <p:spPr/>
+      </p:sp>
+      <p:sp>
+        <p:nvSpPr>
+          <p:cNvPr id="3" name="Notes Placeholder 2"/>
+          <p:cNvSpPr>
+            <a:spLocks noGrp="1"/>
+          </p:cNvSpPr>
+          <p:nvPr>
+            <p:ph type="body" idx="3" sz="quarter"/>
+          </p:nvPr>
+        </p:nvSpPr>
+        <p:spPr/>
+        <p:txBody>
+          <a:bodyPr/>
+          <a:lstStyle/>
+          <a:p>
+            <a:r>
+              <a:t>Opening talk track: Welcome students to this module and explain that the goal is not to memorize features. The goal is to understand when a pattern helps authors build more trustworthy, maintainable, user-friendly Power BI solutions.</a:t>
+            </a:r>
+          </a:p>
+          <a:p>
+            <a:r>
+              <a:t>Module framing: Frame this module as the foundation: a good model makes DAX, security, UX, and performance easier. Keep returning to grain, keys, and relationship direction.</a:t>
+            </a:r>
+          </a:p>
+          <a:p>
+            <a:r>
+              <a:t>Set expectations: presentation will introduce the theme, then the lab will let learners build or evaluate the pattern hands-on. Encourage questions about tradeoffs, not just button clicks.</a:t>
+            </a:r>
+          </a:p>
+          <a:p>
+            <a:r>
+              <a:t>Further learning: Star schema guidance: https://learn.microsoft.com/power-bi/guidance/star-schema | Model relationships: https://learn.microsoft.com/power-bi/transform-model/desktop-relationships-understand | Power BI Desktop modeling: https://learn.microsoft.com/power-bi/transform-model/</a:t>
+            </a:r>
+          </a:p>
+        </p:txBody>
+      </p:sp>
+      <p:sp>
+        <p:nvSpPr>
+          <p:cNvPr id="4" name="Slide Number Placeholder 3"/>
+          <p:cNvSpPr>
+            <a:spLocks noGrp="1"/>
+          </p:cNvSpPr>
+          <p:nvPr>
+            <p:ph type="sldNum" idx="5" sz="quarter"/>
+          </p:nvPr>
+        </p:nvSpPr>
+        <p:spPr/>
+      </p:sp>
+    </p:spTree>
+  </p:cSld>
+  <p:clrMapOvr>
+    <a:masterClrMapping/>
+  </p:clrMapOvr>
+</p:notes>
+</file>
+
+<file path=ppt/notesSlides/notesSlide10.xml><?xml version="1.0" encoding="utf-8"?>
+<p:notes xmlns:a="http://schemas.openxmlformats.org/drawingml/2006/main" xmlns:p="http://schemas.openxmlformats.org/presentationml/2006/main" xmlns:r="http://schemas.openxmlformats.org/officeDocument/2006/relationships">
+  <p:cSld>
+    <p:spTree>
+      <p:nvGrpSpPr>
+        <p:cNvPr id="1" name=""/>
+        <p:cNvGrpSpPr/>
+        <p:nvPr/>
+      </p:nvGrpSpPr>
+      <p:grpSpPr>
+        <a:xfrm>
+          <a:off x="0" y="0"/>
+          <a:ext cx="0" cy="0"/>
+          <a:chOff x="0" y="0"/>
+          <a:chExt cx="0" cy="0"/>
+        </a:xfrm>
+      </p:grpSpPr>
+      <p:sp>
+        <p:nvSpPr>
+          <p:cNvPr id="2" name="Slide Image Placeholder 1"/>
+          <p:cNvSpPr>
+            <a:spLocks noGrp="1"/>
+          </p:cNvSpPr>
+          <p:nvPr>
+            <p:ph type="sldImg" idx="2"/>
+          </p:nvPr>
+        </p:nvSpPr>
+        <p:spPr/>
+      </p:sp>
+      <p:sp>
+        <p:nvSpPr>
+          <p:cNvPr id="3" name="Notes Placeholder 2"/>
+          <p:cNvSpPr>
+            <a:spLocks noGrp="1"/>
+          </p:cNvSpPr>
+          <p:nvPr>
+            <p:ph type="body" idx="3" sz="quarter"/>
+          </p:nvPr>
+        </p:nvSpPr>
+        <p:spPr/>
+        <p:txBody>
+          <a:bodyPr/>
+          <a:lstStyle/>
+          <a:p>
+            <a:r>
+              <a:t>Core message: 8. Large semantic model considerations.</a:t>
+            </a:r>
+          </a:p>
+          <a:p>
+            <a:r>
+              <a:t>Talking points to expand: Talking points, learner value, and lab connection Talking points • Cardinality reduction • Aggregations • Incremental refresh Why it helps • Capacity and tenant settings • Gov validation requirements Lab connection Coverage: Covered. Use the lab README to demonstrate or discuss this topic. Review terms: aggregations, capacity, considerations, incremental, reduction. 10</a:t>
+            </a:r>
+          </a:p>
+          <a:p>
+            <a:r>
+              <a:t>Why it matters: Frame this module as the foundation: a good model makes DAX, security, UX, and performance easier. Keep returning to grain, keys, and relationship direction.</a:t>
+            </a:r>
+          </a:p>
+          <a:p>
+            <a:r>
+              <a:t>How it helps users: connect the technical pattern to clearer decisions, fewer confusing report interactions, better trust in results, or easier support.</a:t>
+            </a:r>
+          </a:p>
+          <a:p>
+            <a:r>
+              <a:t>How it builds on prior lessons: reference the previous layer in the workshop, such as prepared data, a clean model, tested measures, or report UX conventions.</a:t>
+            </a:r>
+          </a:p>
+          <a:p>
+            <a:r>
+              <a:t>Lab connection: Show where this concept appears in the module lab. If the lab path is conceptual or Verify for Gov, explain what learners should document instead of building hands-on.</a:t>
+            </a:r>
+          </a:p>
+          <a:p>
+            <a:r>
+              <a:t>Instructor prompt: Ask one learner to describe the risk of skipping this pattern or using it without validation.</a:t>
+            </a:r>
+          </a:p>
+          <a:p>
+            <a:r>
+              <a:t>Further learning: Star schema guidance: https://learn.microsoft.com/power-bi/guidance/star-schema | Model relationships: https://learn.microsoft.com/power-bi/transform-model/desktop-relationships-understand | Power BI Desktop modeling: https://learn.microsoft.com/power-bi/transform-model/</a:t>
+            </a:r>
+          </a:p>
+        </p:txBody>
+      </p:sp>
+      <p:sp>
+        <p:nvSpPr>
+          <p:cNvPr id="4" name="Slide Number Placeholder 3"/>
+          <p:cNvSpPr>
+            <a:spLocks noGrp="1"/>
+          </p:cNvSpPr>
+          <p:nvPr>
+            <p:ph type="sldNum" idx="5" sz="quarter"/>
+          </p:nvPr>
+        </p:nvSpPr>
+        <p:spPr/>
+      </p:sp>
+    </p:spTree>
+  </p:cSld>
+  <p:clrMapOvr>
+    <a:masterClrMapping/>
+  </p:clrMapOvr>
+</p:notes>
+</file>
+
+<file path=ppt/notesSlides/notesSlide11.xml><?xml version="1.0" encoding="utf-8"?>
+<p:notes xmlns:a="http://schemas.openxmlformats.org/drawingml/2006/main" xmlns:p="http://schemas.openxmlformats.org/presentationml/2006/main" xmlns:r="http://schemas.openxmlformats.org/officeDocument/2006/relationships">
+  <p:cSld>
+    <p:spTree>
+      <p:nvGrpSpPr>
+        <p:cNvPr id="1" name=""/>
+        <p:cNvGrpSpPr/>
+        <p:nvPr/>
+      </p:nvGrpSpPr>
+      <p:grpSpPr>
+        <a:xfrm>
+          <a:off x="0" y="0"/>
+          <a:ext cx="0" cy="0"/>
+          <a:chOff x="0" y="0"/>
+          <a:chExt cx="0" cy="0"/>
+        </a:xfrm>
+      </p:grpSpPr>
+      <p:sp>
+        <p:nvSpPr>
+          <p:cNvPr id="2" name="Slide Image Placeholder 1"/>
+          <p:cNvSpPr>
+            <a:spLocks noGrp="1"/>
+          </p:cNvSpPr>
+          <p:nvPr>
+            <p:ph type="sldImg" idx="2"/>
+          </p:nvPr>
+        </p:nvSpPr>
+        <p:spPr/>
+      </p:sp>
+      <p:sp>
+        <p:nvSpPr>
+          <p:cNvPr id="3" name="Notes Placeholder 2"/>
+          <p:cNvSpPr>
+            <a:spLocks noGrp="1"/>
+          </p:cNvSpPr>
+          <p:nvPr>
+            <p:ph type="body" idx="3" sz="quarter"/>
+          </p:nvPr>
+        </p:nvSpPr>
+        <p:spPr/>
+        <p:txBody>
+          <a:bodyPr/>
+          <a:lstStyle/>
+          <a:p>
+            <a:r>
+              <a:t>Core message: 9. Module lab walkthrough.</a:t>
+            </a:r>
+          </a:p>
+          <a:p>
+            <a:r>
+              <a:t>Talking points to expand: Talking points, learner value, and lab connection Talking points • Data overview • Target model Why it helps • Validation checks • Optional commercial-enhanced path Lab connection Coverage: Partial. Use the lab README to demonstrate or discuss this topic. Review terms: checks, commercial, enhanced, overview, walkthrough. 11</a:t>
+            </a:r>
+          </a:p>
+          <a:p>
+            <a:r>
+              <a:t>Why it matters: Frame this module as the foundation: a good model makes DAX, security, UX, and performance easier. Keep returning to grain, keys, and relationship direction.</a:t>
+            </a:r>
+          </a:p>
+          <a:p>
+            <a:r>
+              <a:t>How it helps users: connect the technical pattern to clearer decisions, fewer confusing report interactions, better trust in results, or easier support.</a:t>
+            </a:r>
+          </a:p>
+          <a:p>
+            <a:r>
+              <a:t>How it builds on prior lessons: reference the previous layer in the workshop, such as prepared data, a clean model, tested measures, or report UX conventions.</a:t>
+            </a:r>
+          </a:p>
+          <a:p>
+            <a:r>
+              <a:t>Lab connection: Show where this concept appears in the module lab. If the lab path is conceptual or Verify for Gov, explain what learners should document instead of building hands-on.</a:t>
+            </a:r>
+          </a:p>
+          <a:p>
+            <a:r>
+              <a:t>Instructor prompt: Ask one learner to describe the risk of skipping this pattern or using it without validation.</a:t>
+            </a:r>
+          </a:p>
+          <a:p>
+            <a:r>
+              <a:t>Further learning: Star schema guidance: https://learn.microsoft.com/power-bi/guidance/star-schema | Model relationships: https://learn.microsoft.com/power-bi/transform-model/desktop-relationships-understand | Power BI Desktop modeling: https://learn.microsoft.com/power-bi/transform-model/</a:t>
+            </a:r>
+          </a:p>
+        </p:txBody>
+      </p:sp>
+      <p:sp>
+        <p:nvSpPr>
+          <p:cNvPr id="4" name="Slide Number Placeholder 3"/>
+          <p:cNvSpPr>
+            <a:spLocks noGrp="1"/>
+          </p:cNvSpPr>
+          <p:nvPr>
+            <p:ph type="sldNum" idx="5" sz="quarter"/>
+          </p:nvPr>
+        </p:nvSpPr>
+        <p:spPr/>
+      </p:sp>
+    </p:spTree>
+  </p:cSld>
+  <p:clrMapOvr>
+    <a:masterClrMapping/>
+  </p:clrMapOvr>
+</p:notes>
+</file>
+
+<file path=ppt/notesSlides/notesSlide12.xml><?xml version="1.0" encoding="utf-8"?>
+<p:notes xmlns:a="http://schemas.openxmlformats.org/drawingml/2006/main" xmlns:p="http://schemas.openxmlformats.org/presentationml/2006/main" xmlns:r="http://schemas.openxmlformats.org/officeDocument/2006/relationships">
+  <p:cSld>
+    <p:spTree>
+      <p:nvGrpSpPr>
+        <p:cNvPr id="1" name=""/>
+        <p:cNvGrpSpPr/>
+        <p:nvPr/>
+      </p:nvGrpSpPr>
+      <p:grpSpPr>
+        <a:xfrm>
+          <a:off x="0" y="0"/>
+          <a:ext cx="0" cy="0"/>
+          <a:chOff x="0" y="0"/>
+          <a:chExt cx="0" cy="0"/>
+        </a:xfrm>
+      </p:grpSpPr>
+      <p:sp>
+        <p:nvSpPr>
+          <p:cNvPr id="2" name="Slide Image Placeholder 1"/>
+          <p:cNvSpPr>
+            <a:spLocks noGrp="1"/>
+          </p:cNvSpPr>
+          <p:nvPr>
+            <p:ph type="sldImg" idx="2"/>
+          </p:nvPr>
+        </p:nvSpPr>
+        <p:spPr/>
+      </p:sp>
+      <p:sp>
+        <p:nvSpPr>
+          <p:cNvPr id="3" name="Notes Placeholder 2"/>
+          <p:cNvSpPr>
+            <a:spLocks noGrp="1"/>
+          </p:cNvSpPr>
+          <p:nvPr>
+            <p:ph type="body" idx="3" sz="quarter"/>
+          </p:nvPr>
+        </p:nvSpPr>
+        <p:spPr/>
+        <p:txBody>
+          <a:bodyPr/>
+          <a:lstStyle/>
+          <a:p>
+            <a:r>
+              <a:t>Speaker guidance: Treat this as a checkpoint. Ask learners to explain the pattern in their own words and identify where they would use it in a real report.</a:t>
+            </a:r>
+          </a:p>
+          <a:p>
+            <a:r>
+              <a:t>Validation prompt: What would prove this worked? Look for a simple visual, expected filter behavior, or a documented before/after result.</a:t>
+            </a:r>
+          </a:p>
+          <a:p>
+            <a:r>
+              <a:t>Further learning: Star schema guidance: https://learn.microsoft.com/power-bi/guidance/star-schema | Model relationships: https://learn.microsoft.com/power-bi/transform-model/desktop-relationships-understand | Power BI Desktop modeling: https://learn.microsoft.com/power-bi/transform-model/</a:t>
+            </a:r>
+          </a:p>
+        </p:txBody>
+      </p:sp>
+      <p:sp>
+        <p:nvSpPr>
+          <p:cNvPr id="4" name="Slide Number Placeholder 3"/>
+          <p:cNvSpPr>
+            <a:spLocks noGrp="1"/>
+          </p:cNvSpPr>
+          <p:nvPr>
+            <p:ph type="sldNum" idx="5" sz="quarter"/>
+          </p:nvPr>
+        </p:nvSpPr>
+        <p:spPr/>
+      </p:sp>
+    </p:spTree>
+  </p:cSld>
+  <p:clrMapOvr>
+    <a:masterClrMapping/>
+  </p:clrMapOvr>
+</p:notes>
+</file>
+
+<file path=ppt/notesSlides/notesSlide13.xml><?xml version="1.0" encoding="utf-8"?>
+<p:notes xmlns:a="http://schemas.openxmlformats.org/drawingml/2006/main" xmlns:p="http://schemas.openxmlformats.org/presentationml/2006/main" xmlns:r="http://schemas.openxmlformats.org/officeDocument/2006/relationships">
+  <p:cSld>
+    <p:spTree>
+      <p:nvGrpSpPr>
+        <p:cNvPr id="1" name=""/>
+        <p:cNvGrpSpPr/>
+        <p:nvPr/>
+      </p:nvGrpSpPr>
+      <p:grpSpPr>
+        <a:xfrm>
+          <a:off x="0" y="0"/>
+          <a:ext cx="0" cy="0"/>
+          <a:chOff x="0" y="0"/>
+          <a:chExt cx="0" cy="0"/>
+        </a:xfrm>
+      </p:grpSpPr>
+      <p:sp>
+        <p:nvSpPr>
+          <p:cNvPr id="2" name="Slide Image Placeholder 1"/>
+          <p:cNvSpPr>
+            <a:spLocks noGrp="1"/>
+          </p:cNvSpPr>
+          <p:nvPr>
+            <p:ph type="sldImg" idx="2"/>
+          </p:nvPr>
+        </p:nvSpPr>
+        <p:spPr/>
+      </p:sp>
+      <p:sp>
+        <p:nvSpPr>
+          <p:cNvPr id="3" name="Notes Placeholder 2"/>
+          <p:cNvSpPr>
+            <a:spLocks noGrp="1"/>
+          </p:cNvSpPr>
+          <p:nvPr>
+            <p:ph type="body" idx="3" sz="quarter"/>
+          </p:nvPr>
+        </p:nvSpPr>
+        <p:spPr/>
+        <p:txBody>
+          <a:bodyPr/>
+          <a:lstStyle/>
+          <a:p>
+            <a:r>
+              <a:t>Speaker guidance: Use this slide as the handoff for self-study. Do not read every link aloud. Point out which source is most relevant to the lab just completed and which source helps learners go deeper after class.</a:t>
+            </a:r>
+          </a:p>
+          <a:p>
+            <a:r>
+              <a:t>Suggested prompt: Ask learners to bookmark the source that best matches the skill they want to improve next.</a:t>
+            </a:r>
+          </a:p>
+          <a:p>
+            <a:r>
+              <a:t>Further learning: Star schema guidance: https://learn.microsoft.com/power-bi/guidance/star-schema | Model relationships: https://learn.microsoft.com/power-bi/transform-model/desktop-relationships-understand | Power BI Desktop modeling: https://learn.microsoft.com/power-bi/transform-model/</a:t>
+            </a:r>
+          </a:p>
+        </p:txBody>
+      </p:sp>
+      <p:sp>
+        <p:nvSpPr>
+          <p:cNvPr id="4" name="Slide Number Placeholder 3"/>
+          <p:cNvSpPr>
+            <a:spLocks noGrp="1"/>
+          </p:cNvSpPr>
+          <p:nvPr>
+            <p:ph type="sldNum" idx="5" sz="quarter"/>
+          </p:nvPr>
+        </p:nvSpPr>
+        <p:spPr/>
+      </p:sp>
+    </p:spTree>
+  </p:cSld>
+  <p:clrMapOvr>
+    <a:masterClrMapping/>
+  </p:clrMapOvr>
+</p:notes>
+</file>
+
+<file path=ppt/notesSlides/notesSlide2.xml><?xml version="1.0" encoding="utf-8"?>
+<p:notes xmlns:a="http://schemas.openxmlformats.org/drawingml/2006/main" xmlns:p="http://schemas.openxmlformats.org/presentationml/2006/main" xmlns:r="http://schemas.openxmlformats.org/officeDocument/2006/relationships">
+  <p:cSld>
+    <p:spTree>
+      <p:nvGrpSpPr>
+        <p:cNvPr id="1" name=""/>
+        <p:cNvGrpSpPr/>
+        <p:nvPr/>
+      </p:nvGrpSpPr>
+      <p:grpSpPr>
+        <a:xfrm>
+          <a:off x="0" y="0"/>
+          <a:ext cx="0" cy="0"/>
+          <a:chOff x="0" y="0"/>
+          <a:chExt cx="0" cy="0"/>
+        </a:xfrm>
+      </p:grpSpPr>
+      <p:sp>
+        <p:nvSpPr>
+          <p:cNvPr id="2" name="Slide Image Placeholder 1"/>
+          <p:cNvSpPr>
+            <a:spLocks noGrp="1"/>
+          </p:cNvSpPr>
+          <p:nvPr>
+            <p:ph type="sldImg" idx="2"/>
+          </p:nvPr>
+        </p:nvSpPr>
+        <p:spPr/>
+      </p:sp>
+      <p:sp>
+        <p:nvSpPr>
+          <p:cNvPr id="3" name="Notes Placeholder 2"/>
+          <p:cNvSpPr>
+            <a:spLocks noGrp="1"/>
+          </p:cNvSpPr>
+          <p:nvPr>
+            <p:ph type="body" idx="3" sz="quarter"/>
+          </p:nvPr>
+        </p:nvSpPr>
+        <p:spPr/>
+        <p:txBody>
+          <a:bodyPr/>
+          <a:lstStyle/>
+          <a:p>
+            <a:r>
+              <a:t>Speaker guidance: Emphasize sequence and dependency. Explain what students should already know from prior modules and what this module adds on top.</a:t>
+            </a:r>
+          </a:p>
+          <a:p>
+            <a:r>
+              <a:t>Module framing: Frame this module as the foundation: a good model makes DAX, security, UX, and performance easier. Keep returning to grain, keys, and relationship direction.</a:t>
+            </a:r>
+          </a:p>
+          <a:p>
+            <a:r>
+              <a:t>Transition: After this slide, move from the concept map into the specific pattern or lab activity.</a:t>
+            </a:r>
+          </a:p>
+          <a:p>
+            <a:r>
+              <a:t>Further learning: Star schema guidance: https://learn.microsoft.com/power-bi/guidance/star-schema | Model relationships: https://learn.microsoft.com/power-bi/transform-model/desktop-relationships-understand | Power BI Desktop modeling: https://learn.microsoft.com/power-bi/transform-model/</a:t>
+            </a:r>
+          </a:p>
+        </p:txBody>
+      </p:sp>
+      <p:sp>
+        <p:nvSpPr>
+          <p:cNvPr id="4" name="Slide Number Placeholder 3"/>
+          <p:cNvSpPr>
+            <a:spLocks noGrp="1"/>
+          </p:cNvSpPr>
+          <p:nvPr>
+            <p:ph type="sldNum" idx="5" sz="quarter"/>
+          </p:nvPr>
+        </p:nvSpPr>
+        <p:spPr/>
+      </p:sp>
+    </p:spTree>
+  </p:cSld>
+  <p:clrMapOvr>
+    <a:masterClrMapping/>
+  </p:clrMapOvr>
+</p:notes>
+</file>
+
+<file path=ppt/notesSlides/notesSlide3.xml><?xml version="1.0" encoding="utf-8"?>
+<p:notes xmlns:a="http://schemas.openxmlformats.org/drawingml/2006/main" xmlns:p="http://schemas.openxmlformats.org/presentationml/2006/main" xmlns:r="http://schemas.openxmlformats.org/officeDocument/2006/relationships">
+  <p:cSld>
+    <p:spTree>
+      <p:nvGrpSpPr>
+        <p:cNvPr id="1" name=""/>
+        <p:cNvGrpSpPr/>
+        <p:nvPr/>
+      </p:nvGrpSpPr>
+      <p:grpSpPr>
+        <a:xfrm>
+          <a:off x="0" y="0"/>
+          <a:ext cx="0" cy="0"/>
+          <a:chOff x="0" y="0"/>
+          <a:chExt cx="0" cy="0"/>
+        </a:xfrm>
+      </p:grpSpPr>
+      <p:sp>
+        <p:nvSpPr>
+          <p:cNvPr id="2" name="Slide Image Placeholder 1"/>
+          <p:cNvSpPr>
+            <a:spLocks noGrp="1"/>
+          </p:cNvSpPr>
+          <p:nvPr>
+            <p:ph type="sldImg" idx="2"/>
+          </p:nvPr>
+        </p:nvSpPr>
+        <p:spPr/>
+      </p:sp>
+      <p:sp>
+        <p:nvSpPr>
+          <p:cNvPr id="3" name="Notes Placeholder 2"/>
+          <p:cNvSpPr>
+            <a:spLocks noGrp="1"/>
+          </p:cNvSpPr>
+          <p:nvPr>
+            <p:ph type="body" idx="3" sz="quarter"/>
+          </p:nvPr>
+        </p:nvSpPr>
+        <p:spPr/>
+        <p:txBody>
+          <a:bodyPr/>
+          <a:lstStyle/>
+          <a:p>
+            <a:r>
+              <a:t>Core message: 1. Why semantic modeling matters.</a:t>
+            </a:r>
+          </a:p>
+          <a:p>
+            <a:r>
+              <a:t>Talking points to expand: Talking points, learner value, and lab connection Talking points • Advanced Power BI starts with the model. • Poor models create slow reports, complex DAX, and inconsistent metrics. Why it helps • Enterprise models should be reusable, governed, and understandable. Lab connection Coverage: Covered. Use the lab README to demonstrate or discuss this topic. Review terms: complex, governed, inconsistent, matters, reports. 03</a:t>
+            </a:r>
+          </a:p>
+          <a:p>
+            <a:r>
+              <a:t>Why it matters: Frame this module as the foundation: a good model makes DAX, security, UX, and performance easier. Keep returning to grain, keys, and relationship direction.</a:t>
+            </a:r>
+          </a:p>
+          <a:p>
+            <a:r>
+              <a:t>How it helps users: connect the technical pattern to clearer decisions, fewer confusing report interactions, better trust in results, or easier support.</a:t>
+            </a:r>
+          </a:p>
+          <a:p>
+            <a:r>
+              <a:t>How it builds on prior lessons: reference the previous layer in the workshop, such as prepared data, a clean model, tested measures, or report UX conventions.</a:t>
+            </a:r>
+          </a:p>
+          <a:p>
+            <a:r>
+              <a:t>Lab connection: Show where this concept appears in the module lab. If the lab path is conceptual or Verify for Gov, explain what learners should document instead of building hands-on.</a:t>
+            </a:r>
+          </a:p>
+          <a:p>
+            <a:r>
+              <a:t>Instructor prompt: Ask one learner to describe the risk of skipping this pattern or using it without validation.</a:t>
+            </a:r>
+          </a:p>
+          <a:p>
+            <a:r>
+              <a:t>Further learning: Star schema guidance: https://learn.microsoft.com/power-bi/guidance/star-schema | Model relationships: https://learn.microsoft.com/power-bi/transform-model/desktop-relationships-understand | Power BI Desktop modeling: https://learn.microsoft.com/power-bi/transform-model/</a:t>
+            </a:r>
+          </a:p>
+        </p:txBody>
+      </p:sp>
+      <p:sp>
+        <p:nvSpPr>
+          <p:cNvPr id="4" name="Slide Number Placeholder 3"/>
+          <p:cNvSpPr>
+            <a:spLocks noGrp="1"/>
+          </p:cNvSpPr>
+          <p:nvPr>
+            <p:ph type="sldNum" idx="5" sz="quarter"/>
+          </p:nvPr>
+        </p:nvSpPr>
+        <p:spPr/>
+      </p:sp>
+    </p:spTree>
+  </p:cSld>
+  <p:clrMapOvr>
+    <a:masterClrMapping/>
+  </p:clrMapOvr>
+</p:notes>
+</file>
+
+<file path=ppt/notesSlides/notesSlide4.xml><?xml version="1.0" encoding="utf-8"?>
+<p:notes xmlns:a="http://schemas.openxmlformats.org/drawingml/2006/main" xmlns:p="http://schemas.openxmlformats.org/presentationml/2006/main" xmlns:r="http://schemas.openxmlformats.org/officeDocument/2006/relationships">
+  <p:cSld>
+    <p:spTree>
+      <p:nvGrpSpPr>
+        <p:cNvPr id="1" name=""/>
+        <p:cNvGrpSpPr/>
+        <p:nvPr/>
+      </p:nvGrpSpPr>
+      <p:grpSpPr>
+        <a:xfrm>
+          <a:off x="0" y="0"/>
+          <a:ext cx="0" cy="0"/>
+          <a:chOff x="0" y="0"/>
+          <a:chExt cx="0" cy="0"/>
+        </a:xfrm>
+      </p:grpSpPr>
+      <p:sp>
+        <p:nvSpPr>
+          <p:cNvPr id="2" name="Slide Image Placeholder 1"/>
+          <p:cNvSpPr>
+            <a:spLocks noGrp="1"/>
+          </p:cNvSpPr>
+          <p:nvPr>
+            <p:ph type="sldImg" idx="2"/>
+          </p:nvPr>
+        </p:nvSpPr>
+        <p:spPr/>
+      </p:sp>
+      <p:sp>
+        <p:nvSpPr>
+          <p:cNvPr id="3" name="Notes Placeholder 2"/>
+          <p:cNvSpPr>
+            <a:spLocks noGrp="1"/>
+          </p:cNvSpPr>
+          <p:nvPr>
+            <p:ph type="body" idx="3" sz="quarter"/>
+          </p:nvPr>
+        </p:nvSpPr>
+        <p:spPr/>
+        <p:txBody>
+          <a:bodyPr/>
+          <a:lstStyle/>
+          <a:p>
+            <a:r>
+              <a:t>Core message: 2. From flat files to analytical models.</a:t>
+            </a:r>
+          </a:p>
+          <a:p>
+            <a:r>
+              <a:t>Talking points to expand: Talking points, learner value, and lab connection Talking points • Reporting exports vs. analytical models • Repeated text attributes Why it helps • Hidden grain problems • Fact and dimension separation Lab connection Coverage: Partial. Use the lab README to demonstrate or discuss this topic. Review terms: analytical, exports, hidden, problems, repeated. 04</a:t>
+            </a:r>
+          </a:p>
+          <a:p>
+            <a:r>
+              <a:t>Why it matters: Frame this module as the foundation: a good model makes DAX, security, UX, and performance easier. Keep returning to grain, keys, and relationship direction.</a:t>
+            </a:r>
+          </a:p>
+          <a:p>
+            <a:r>
+              <a:t>How it helps users: connect the technical pattern to clearer decisions, fewer confusing report interactions, better trust in results, or easier support.</a:t>
+            </a:r>
+          </a:p>
+          <a:p>
+            <a:r>
+              <a:t>How it builds on prior lessons: reference the previous layer in the workshop, such as prepared data, a clean model, tested measures, or report UX conventions.</a:t>
+            </a:r>
+          </a:p>
+          <a:p>
+            <a:r>
+              <a:t>Lab connection: Show where this concept appears in the module lab. If the lab path is conceptual or Verify for Gov, explain what learners should document instead of building hands-on.</a:t>
+            </a:r>
+          </a:p>
+          <a:p>
+            <a:r>
+              <a:t>Instructor prompt: Ask one learner to describe the risk of skipping this pattern or using it without validation.</a:t>
+            </a:r>
+          </a:p>
+          <a:p>
+            <a:r>
+              <a:t>Further learning: Star schema guidance: https://learn.microsoft.com/power-bi/guidance/star-schema | Model relationships: https://learn.microsoft.com/power-bi/transform-model/desktop-relationships-understand | Power BI Desktop modeling: https://learn.microsoft.com/power-bi/transform-model/</a:t>
+            </a:r>
+          </a:p>
+        </p:txBody>
+      </p:sp>
+      <p:sp>
+        <p:nvSpPr>
+          <p:cNvPr id="4" name="Slide Number Placeholder 3"/>
+          <p:cNvSpPr>
+            <a:spLocks noGrp="1"/>
+          </p:cNvSpPr>
+          <p:nvPr>
+            <p:ph type="sldNum" idx="5" sz="quarter"/>
+          </p:nvPr>
+        </p:nvSpPr>
+        <p:spPr/>
+      </p:sp>
+    </p:spTree>
+  </p:cSld>
+  <p:clrMapOvr>
+    <a:masterClrMapping/>
+  </p:clrMapOvr>
+</p:notes>
+</file>
+
+<file path=ppt/notesSlides/notesSlide5.xml><?xml version="1.0" encoding="utf-8"?>
+<p:notes xmlns:a="http://schemas.openxmlformats.org/drawingml/2006/main" xmlns:p="http://schemas.openxmlformats.org/presentationml/2006/main" xmlns:r="http://schemas.openxmlformats.org/officeDocument/2006/relationships">
+  <p:cSld>
+    <p:spTree>
+      <p:nvGrpSpPr>
+        <p:cNvPr id="1" name=""/>
+        <p:cNvGrpSpPr/>
+        <p:nvPr/>
+      </p:nvGrpSpPr>
+      <p:grpSpPr>
+        <a:xfrm>
+          <a:off x="0" y="0"/>
+          <a:ext cx="0" cy="0"/>
+          <a:chOff x="0" y="0"/>
+          <a:chExt cx="0" cy="0"/>
+        </a:xfrm>
+      </p:grpSpPr>
+      <p:sp>
+        <p:nvSpPr>
+          <p:cNvPr id="2" name="Slide Image Placeholder 1"/>
+          <p:cNvSpPr>
+            <a:spLocks noGrp="1"/>
+          </p:cNvSpPr>
+          <p:nvPr>
+            <p:ph type="sldImg" idx="2"/>
+          </p:nvPr>
+        </p:nvSpPr>
+        <p:spPr/>
+      </p:sp>
+      <p:sp>
+        <p:nvSpPr>
+          <p:cNvPr id="3" name="Notes Placeholder 2"/>
+          <p:cNvSpPr>
+            <a:spLocks noGrp="1"/>
+          </p:cNvSpPr>
+          <p:nvPr>
+            <p:ph type="body" idx="3" sz="quarter"/>
+          </p:nvPr>
+        </p:nvSpPr>
+        <p:spPr/>
+        <p:txBody>
+          <a:bodyPr/>
+          <a:lstStyle/>
+          <a:p>
+            <a:r>
+              <a:t>Core message: 3. Star schema design.</a:t>
+            </a:r>
+          </a:p>
+          <a:p>
+            <a:r>
+              <a:t>Talking points to expand: Talking points, learner value, and lab connection Talking points • Fact table grain • Dimension attributes • Surrogate/business keys Why it helps • Conformed dimensions • Model readability Lab connection Coverage: Covered. Use the lab README to demonstrate or discuss this topic. Review terms: conformed, readability, surrogate. 05</a:t>
+            </a:r>
+          </a:p>
+          <a:p>
+            <a:r>
+              <a:t>Why it matters: Frame this module as the foundation: a good model makes DAX, security, UX, and performance easier. Keep returning to grain, keys, and relationship direction.</a:t>
+            </a:r>
+          </a:p>
+          <a:p>
+            <a:r>
+              <a:t>How it helps users: connect the technical pattern to clearer decisions, fewer confusing report interactions, better trust in results, or easier support.</a:t>
+            </a:r>
+          </a:p>
+          <a:p>
+            <a:r>
+              <a:t>How it builds on prior lessons: reference the previous layer in the workshop, such as prepared data, a clean model, tested measures, or report UX conventions.</a:t>
+            </a:r>
+          </a:p>
+          <a:p>
+            <a:r>
+              <a:t>Lab connection: Show where this concept appears in the module lab. If the lab path is conceptual or Verify for Gov, explain what learners should document instead of building hands-on.</a:t>
+            </a:r>
+          </a:p>
+          <a:p>
+            <a:r>
+              <a:t>Instructor prompt: Ask one learner to describe the risk of skipping this pattern or using it without validation.</a:t>
+            </a:r>
+          </a:p>
+          <a:p>
+            <a:r>
+              <a:t>Further learning: Star schema guidance: https://learn.microsoft.com/power-bi/guidance/star-schema | Model relationships: https://learn.microsoft.com/power-bi/transform-model/desktop-relationships-understand | Power BI Desktop modeling: https://learn.microsoft.com/power-bi/transform-model/</a:t>
+            </a:r>
+          </a:p>
+        </p:txBody>
+      </p:sp>
+      <p:sp>
+        <p:nvSpPr>
+          <p:cNvPr id="4" name="Slide Number Placeholder 3"/>
+          <p:cNvSpPr>
+            <a:spLocks noGrp="1"/>
+          </p:cNvSpPr>
+          <p:nvPr>
+            <p:ph type="sldNum" idx="5" sz="quarter"/>
+          </p:nvPr>
+        </p:nvSpPr>
+        <p:spPr/>
+      </p:sp>
+    </p:spTree>
+  </p:cSld>
+  <p:clrMapOvr>
+    <a:masterClrMapping/>
+  </p:clrMapOvr>
+</p:notes>
+</file>
+
+<file path=ppt/notesSlides/notesSlide6.xml><?xml version="1.0" encoding="utf-8"?>
+<p:notes xmlns:a="http://schemas.openxmlformats.org/drawingml/2006/main" xmlns:p="http://schemas.openxmlformats.org/presentationml/2006/main" xmlns:r="http://schemas.openxmlformats.org/officeDocument/2006/relationships">
+  <p:cSld>
+    <p:spTree>
+      <p:nvGrpSpPr>
+        <p:cNvPr id="1" name=""/>
+        <p:cNvGrpSpPr/>
+        <p:nvPr/>
+      </p:nvGrpSpPr>
+      <p:grpSpPr>
+        <a:xfrm>
+          <a:off x="0" y="0"/>
+          <a:ext cx="0" cy="0"/>
+          <a:chOff x="0" y="0"/>
+          <a:chExt cx="0" cy="0"/>
+        </a:xfrm>
+      </p:grpSpPr>
+      <p:sp>
+        <p:nvSpPr>
+          <p:cNvPr id="2" name="Slide Image Placeholder 1"/>
+          <p:cNvSpPr>
+            <a:spLocks noGrp="1"/>
+          </p:cNvSpPr>
+          <p:nvPr>
+            <p:ph type="sldImg" idx="2"/>
+          </p:nvPr>
+        </p:nvSpPr>
+        <p:spPr/>
+      </p:sp>
+      <p:sp>
+        <p:nvSpPr>
+          <p:cNvPr id="3" name="Notes Placeholder 2"/>
+          <p:cNvSpPr>
+            <a:spLocks noGrp="1"/>
+          </p:cNvSpPr>
+          <p:nvPr>
+            <p:ph type="body" idx="3" sz="quarter"/>
+          </p:nvPr>
+        </p:nvSpPr>
+        <p:spPr/>
+        <p:txBody>
+          <a:bodyPr/>
+          <a:lstStyle/>
+          <a:p>
+            <a:r>
+              <a:t>Core message: 4. Relationship design.</a:t>
+            </a:r>
+          </a:p>
+          <a:p>
+            <a:r>
+              <a:t>Talking points to expand: Talking points, learner value, and lab connection Talking points • One-to-many relationships • Cardinality • Single-direction filtering Why it helps • Ambiguity and bi-directional filters • Many-to-many risks Lab connection Coverage: Covered. Use the lab README to demonstrate or discuss this topic. Review terms: risks. 06</a:t>
+            </a:r>
+          </a:p>
+          <a:p>
+            <a:r>
+              <a:t>Why it matters: Frame this module as the foundation: a good model makes DAX, security, UX, and performance easier. Keep returning to grain, keys, and relationship direction.</a:t>
+            </a:r>
+          </a:p>
+          <a:p>
+            <a:r>
+              <a:t>How it helps users: connect the technical pattern to clearer decisions, fewer confusing report interactions, better trust in results, or easier support.</a:t>
+            </a:r>
+          </a:p>
+          <a:p>
+            <a:r>
+              <a:t>How it builds on prior lessons: reference the previous layer in the workshop, such as prepared data, a clean model, tested measures, or report UX conventions.</a:t>
+            </a:r>
+          </a:p>
+          <a:p>
+            <a:r>
+              <a:t>Lab connection: Show where this concept appears in the module lab. If the lab path is conceptual or Verify for Gov, explain what learners should document instead of building hands-on.</a:t>
+            </a:r>
+          </a:p>
+          <a:p>
+            <a:r>
+              <a:t>Instructor prompt: Ask one learner to describe the risk of skipping this pattern or using it without validation.</a:t>
+            </a:r>
+          </a:p>
+          <a:p>
+            <a:r>
+              <a:t>Further learning: Star schema guidance: https://learn.microsoft.com/power-bi/guidance/star-schema | Model relationships: https://learn.microsoft.com/power-bi/transform-model/desktop-relationships-understand | Power BI Desktop modeling: https://learn.microsoft.com/power-bi/transform-model/</a:t>
+            </a:r>
+          </a:p>
+        </p:txBody>
+      </p:sp>
+      <p:sp>
+        <p:nvSpPr>
+          <p:cNvPr id="4" name="Slide Number Placeholder 3"/>
+          <p:cNvSpPr>
+            <a:spLocks noGrp="1"/>
+          </p:cNvSpPr>
+          <p:nvPr>
+            <p:ph type="sldNum" idx="5" sz="quarter"/>
+          </p:nvPr>
+        </p:nvSpPr>
+        <p:spPr/>
+      </p:sp>
+    </p:spTree>
+  </p:cSld>
+  <p:clrMapOvr>
+    <a:masterClrMapping/>
+  </p:clrMapOvr>
+</p:notes>
+</file>
+
+<file path=ppt/notesSlides/notesSlide7.xml><?xml version="1.0" encoding="utf-8"?>
+<p:notes xmlns:a="http://schemas.openxmlformats.org/drawingml/2006/main" xmlns:p="http://schemas.openxmlformats.org/presentationml/2006/main" xmlns:r="http://schemas.openxmlformats.org/officeDocument/2006/relationships">
+  <p:cSld>
+    <p:spTree>
+      <p:nvGrpSpPr>
+        <p:cNvPr id="1" name=""/>
+        <p:cNvGrpSpPr/>
+        <p:nvPr/>
+      </p:nvGrpSpPr>
+      <p:grpSpPr>
+        <a:xfrm>
+          <a:off x="0" y="0"/>
+          <a:ext cx="0" cy="0"/>
+          <a:chOff x="0" y="0"/>
+          <a:chExt cx="0" cy="0"/>
+        </a:xfrm>
+      </p:grpSpPr>
+      <p:sp>
+        <p:nvSpPr>
+          <p:cNvPr id="2" name="Slide Image Placeholder 1"/>
+          <p:cNvSpPr>
+            <a:spLocks noGrp="1"/>
+          </p:cNvSpPr>
+          <p:nvPr>
+            <p:ph type="sldImg" idx="2"/>
+          </p:nvPr>
+        </p:nvSpPr>
+        <p:spPr/>
+      </p:sp>
+      <p:sp>
+        <p:nvSpPr>
+          <p:cNvPr id="3" name="Notes Placeholder 2"/>
+          <p:cNvSpPr>
+            <a:spLocks noGrp="1"/>
+          </p:cNvSpPr>
+          <p:nvPr>
+            <p:ph type="body" idx="3" sz="quarter"/>
+          </p:nvPr>
+        </p:nvSpPr>
+        <p:spPr/>
+        <p:txBody>
+          <a:bodyPr/>
+          <a:lstStyle/>
+          <a:p>
+            <a:r>
+              <a:t>Core message: 5. Role-playing dimensions.</a:t>
+            </a:r>
+          </a:p>
+          <a:p>
+            <a:r>
+              <a:t>Talking points to expand: Talking points, learner value, and lab connection Talking points • Order date, ship date, invoice date • Duplicated dimensions vs. inactive relationships Why it helps • `USERELATIONSHIP` pattern overview Lab connection Coverage: Covered. Use the lab README to demonstrate or discuss this topic. Review terms: duplicated, inactive, overview, userelationship. 07</a:t>
+            </a:r>
+          </a:p>
+          <a:p>
+            <a:r>
+              <a:t>Why it matters: Frame this module as the foundation: a good model makes DAX, security, UX, and performance easier. Keep returning to grain, keys, and relationship direction.</a:t>
+            </a:r>
+          </a:p>
+          <a:p>
+            <a:r>
+              <a:t>How it helps users: connect the technical pattern to clearer decisions, fewer confusing report interactions, better trust in results, or easier support.</a:t>
+            </a:r>
+          </a:p>
+          <a:p>
+            <a:r>
+              <a:t>How it builds on prior lessons: reference the previous layer in the workshop, such as prepared data, a clean model, tested measures, or report UX conventions.</a:t>
+            </a:r>
+          </a:p>
+          <a:p>
+            <a:r>
+              <a:t>Lab connection: Show where this concept appears in the module lab. If the lab path is conceptual or Verify for Gov, explain what learners should document instead of building hands-on.</a:t>
+            </a:r>
+          </a:p>
+          <a:p>
+            <a:r>
+              <a:t>Instructor prompt: Ask one learner to describe the risk of skipping this pattern or using it without validation.</a:t>
+            </a:r>
+          </a:p>
+          <a:p>
+            <a:r>
+              <a:t>Further learning: Star schema guidance: https://learn.microsoft.com/power-bi/guidance/star-schema | Model relationships: https://learn.microsoft.com/power-bi/transform-model/desktop-relationships-understand | Power BI Desktop modeling: https://learn.microsoft.com/power-bi/transform-model/</a:t>
+            </a:r>
+          </a:p>
+        </p:txBody>
+      </p:sp>
+      <p:sp>
+        <p:nvSpPr>
+          <p:cNvPr id="4" name="Slide Number Placeholder 3"/>
+          <p:cNvSpPr>
+            <a:spLocks noGrp="1"/>
+          </p:cNvSpPr>
+          <p:nvPr>
+            <p:ph type="sldNum" idx="5" sz="quarter"/>
+          </p:nvPr>
+        </p:nvSpPr>
+        <p:spPr/>
+      </p:sp>
+    </p:spTree>
+  </p:cSld>
+  <p:clrMapOvr>
+    <a:masterClrMapping/>
+  </p:clrMapOvr>
+</p:notes>
+</file>
+
+<file path=ppt/notesSlides/notesSlide8.xml><?xml version="1.0" encoding="utf-8"?>
+<p:notes xmlns:a="http://schemas.openxmlformats.org/drawingml/2006/main" xmlns:p="http://schemas.openxmlformats.org/presentationml/2006/main" xmlns:r="http://schemas.openxmlformats.org/officeDocument/2006/relationships">
+  <p:cSld>
+    <p:spTree>
+      <p:nvGrpSpPr>
+        <p:cNvPr id="1" name=""/>
+        <p:cNvGrpSpPr/>
+        <p:nvPr/>
+      </p:nvGrpSpPr>
+      <p:grpSpPr>
+        <a:xfrm>
+          <a:off x="0" y="0"/>
+          <a:ext cx="0" cy="0"/>
+          <a:chOff x="0" y="0"/>
+          <a:chExt cx="0" cy="0"/>
+        </a:xfrm>
+      </p:grpSpPr>
+      <p:sp>
+        <p:nvSpPr>
+          <p:cNvPr id="2" name="Slide Image Placeholder 1"/>
+          <p:cNvSpPr>
+            <a:spLocks noGrp="1"/>
+          </p:cNvSpPr>
+          <p:nvPr>
+            <p:ph type="sldImg" idx="2"/>
+          </p:nvPr>
+        </p:nvSpPr>
+        <p:spPr/>
+      </p:sp>
+      <p:sp>
+        <p:nvSpPr>
+          <p:cNvPr id="3" name="Notes Placeholder 2"/>
+          <p:cNvSpPr>
+            <a:spLocks noGrp="1"/>
+          </p:cNvSpPr>
+          <p:nvPr>
+            <p:ph type="body" idx="3" sz="quarter"/>
+          </p:nvPr>
+        </p:nvSpPr>
+        <p:spPr/>
+        <p:txBody>
+          <a:bodyPr/>
+          <a:lstStyle/>
+          <a:p>
+            <a:r>
+              <a:t>Core message: 6. Bridge tables.</a:t>
+            </a:r>
+          </a:p>
+          <a:p>
+            <a:r>
+              <a:t>Talking points to expand: Talking points, learner value, and lab connection Talking points • Multi-valued attributes • Customer-to-segment example Why it helps • Bridge table grain • Filter direction considerations Lab connection Coverage: Covered. Use the lab README to demonstrate or discuss this topic. Review terms: considerations. 08</a:t>
+            </a:r>
+          </a:p>
+          <a:p>
+            <a:r>
+              <a:t>Why it matters: Frame this module as the foundation: a good model makes DAX, security, UX, and performance easier. Keep returning to grain, keys, and relationship direction.</a:t>
+            </a:r>
+          </a:p>
+          <a:p>
+            <a:r>
+              <a:t>How it helps users: connect the technical pattern to clearer decisions, fewer confusing report interactions, better trust in results, or easier support.</a:t>
+            </a:r>
+          </a:p>
+          <a:p>
+            <a:r>
+              <a:t>How it builds on prior lessons: reference the previous layer in the workshop, such as prepared data, a clean model, tested measures, or report UX conventions.</a:t>
+            </a:r>
+          </a:p>
+          <a:p>
+            <a:r>
+              <a:t>Lab connection: Show where this concept appears in the module lab. If the lab path is conceptual or Verify for Gov, explain what learners should document instead of building hands-on.</a:t>
+            </a:r>
+          </a:p>
+          <a:p>
+            <a:r>
+              <a:t>Instructor prompt: Ask one learner to describe the risk of skipping this pattern or using it without validation.</a:t>
+            </a:r>
+          </a:p>
+          <a:p>
+            <a:r>
+              <a:t>Further learning: Star schema guidance: https://learn.microsoft.com/power-bi/guidance/star-schema | Model relationships: https://learn.microsoft.com/power-bi/transform-model/desktop-relationships-understand | Power BI Desktop modeling: https://learn.microsoft.com/power-bi/transform-model/</a:t>
+            </a:r>
+          </a:p>
+        </p:txBody>
+      </p:sp>
+      <p:sp>
+        <p:nvSpPr>
+          <p:cNvPr id="4" name="Slide Number Placeholder 3"/>
+          <p:cNvSpPr>
+            <a:spLocks noGrp="1"/>
+          </p:cNvSpPr>
+          <p:nvPr>
+            <p:ph type="sldNum" idx="5" sz="quarter"/>
+          </p:nvPr>
+        </p:nvSpPr>
+        <p:spPr/>
+      </p:sp>
+    </p:spTree>
+  </p:cSld>
+  <p:clrMapOvr>
+    <a:masterClrMapping/>
+  </p:clrMapOvr>
+</p:notes>
+</file>
+
+<file path=ppt/notesSlides/notesSlide9.xml><?xml version="1.0" encoding="utf-8"?>
+<p:notes xmlns:a="http://schemas.openxmlformats.org/drawingml/2006/main" xmlns:p="http://schemas.openxmlformats.org/presentationml/2006/main" xmlns:r="http://schemas.openxmlformats.org/officeDocument/2006/relationships">
+  <p:cSld>
+    <p:spTree>
+      <p:nvGrpSpPr>
+        <p:cNvPr id="1" name=""/>
+        <p:cNvGrpSpPr/>
+        <p:nvPr/>
+      </p:nvGrpSpPr>
+      <p:grpSpPr>
+        <a:xfrm>
+          <a:off x="0" y="0"/>
+          <a:ext cx="0" cy="0"/>
+          <a:chOff x="0" y="0"/>
+          <a:chExt cx="0" cy="0"/>
+        </a:xfrm>
+      </p:grpSpPr>
+      <p:sp>
+        <p:nvSpPr>
+          <p:cNvPr id="2" name="Slide Image Placeholder 1"/>
+          <p:cNvSpPr>
+            <a:spLocks noGrp="1"/>
+          </p:cNvSpPr>
+          <p:nvPr>
+            <p:ph type="sldImg" idx="2"/>
+          </p:nvPr>
+        </p:nvSpPr>
+        <p:spPr/>
+      </p:sp>
+      <p:sp>
+        <p:nvSpPr>
+          <p:cNvPr id="3" name="Notes Placeholder 2"/>
+          <p:cNvSpPr>
+            <a:spLocks noGrp="1"/>
+          </p:cNvSpPr>
+          <p:nvPr>
+            <p:ph type="body" idx="3" sz="quarter"/>
+          </p:nvPr>
+        </p:nvSpPr>
+        <p:spPr/>
+        <p:txBody>
+          <a:bodyPr/>
+          <a:lstStyle/>
+          <a:p>
+            <a:r>
+              <a:t>Core message: 7. Composite models and storage modes.</a:t>
+            </a:r>
+          </a:p>
+          <a:p>
+            <a:r>
+              <a:t>Talking points to expand: Talking points, learner value, and lab connection Talking points • Import • DirectQuery • Dual Why it helps • Composite models • Hybrid table concept Lab connection Coverage: Covered. Use the lab README to demonstrate or discuss this topic. Review terms: modes, requirements. 09</a:t>
+            </a:r>
+          </a:p>
+          <a:p>
+            <a:r>
+              <a:t>Why it matters: Frame this module as the foundation: a good model makes DAX, security, UX, and performance easier. Keep returning to grain, keys, and relationship direction.</a:t>
+            </a:r>
+          </a:p>
+          <a:p>
+            <a:r>
+              <a:t>How it helps users: connect the technical pattern to clearer decisions, fewer confusing report interactions, better trust in results, or easier support.</a:t>
+            </a:r>
+          </a:p>
+          <a:p>
+            <a:r>
+              <a:t>How it builds on prior lessons: reference the previous layer in the workshop, such as prepared data, a clean model, tested measures, or report UX conventions.</a:t>
+            </a:r>
+          </a:p>
+          <a:p>
+            <a:r>
+              <a:t>Lab connection: Show where this concept appears in the module lab. If the lab path is conceptual or Verify for Gov, explain what learners should document instead of building hands-on.</a:t>
+            </a:r>
+          </a:p>
+          <a:p>
+            <a:r>
+              <a:t>Instructor prompt: Ask one learner to describe the risk of skipping this pattern or using it without validation.</a:t>
+            </a:r>
+          </a:p>
+          <a:p>
+            <a:r>
+              <a:t>Further learning: Star schema guidance: https://learn.microsoft.com/power-bi/guidance/star-schema | Model relationships: https://learn.microsoft.com/power-bi/transform-model/desktop-relationships-understand | Power BI Desktop modeling: https://learn.microsoft.com/power-bi/transform-model/</a:t>
+            </a:r>
+          </a:p>
+        </p:txBody>
+      </p:sp>
+      <p:sp>
+        <p:nvSpPr>
+          <p:cNvPr id="4" name="Slide Number Placeholder 3"/>
+          <p:cNvSpPr>
+            <a:spLocks noGrp="1"/>
+          </p:cNvSpPr>
+          <p:nvPr>
+            <p:ph type="sldNum" idx="5" sz="quarter"/>
+          </p:nvPr>
+        </p:nvSpPr>
+        <p:spPr/>
+      </p:sp>
+    </p:spTree>
+  </p:cSld>
+  <p:clrMapOvr>
+    <a:masterClrMapping/>
+  </p:clrMapOvr>
+</p:notes>
 </file>
 
 <file path=ppt/slideLayouts/slideLayout1.xml><?xml version="1.0" encoding="utf-8"?>
@@ -12277,6 +13902,326 @@
 </a:theme>
 </file>
 
+<file path=ppt/theme/theme2.xml><?xml version="1.0" encoding="utf-8"?>
+<a:theme xmlns:a="http://schemas.openxmlformats.org/drawingml/2006/main" name="Office Theme">
+  <a:themeElements>
+    <a:clrScheme name="Office">
+      <a:dk1>
+        <a:sysClr val="windowText" lastClr="000000"/>
+      </a:dk1>
+      <a:lt1>
+        <a:sysClr val="window" lastClr="FFFFFF"/>
+      </a:lt1>
+      <a:dk2>
+        <a:srgbClr val="1F497D"/>
+      </a:dk2>
+      <a:lt2>
+        <a:srgbClr val="EEECE1"/>
+      </a:lt2>
+      <a:accent1>
+        <a:srgbClr val="4F81BD"/>
+      </a:accent1>
+      <a:accent2>
+        <a:srgbClr val="C0504D"/>
+      </a:accent2>
+      <a:accent3>
+        <a:srgbClr val="9BBB59"/>
+      </a:accent3>
+      <a:accent4>
+        <a:srgbClr val="8064A2"/>
+      </a:accent4>
+      <a:accent5>
+        <a:srgbClr val="4BACC6"/>
+      </a:accent5>
+      <a:accent6>
+        <a:srgbClr val="F79646"/>
+      </a:accent6>
+      <a:hlink>
+        <a:srgbClr val="0000FF"/>
+      </a:hlink>
+      <a:folHlink>
+        <a:srgbClr val="800080"/>
+      </a:folHlink>
+    </a:clrScheme>
+    <a:fontScheme name="Office">
+      <a:majorFont>
+        <a:latin typeface="Calibri"/>
+        <a:ea typeface=""/>
+        <a:cs typeface=""/>
+        <a:font script="Jpan" typeface="ＭＳ Ｐゴシック"/>
+        <a:font script="Hang" typeface="맑은 고딕"/>
+        <a:font script="Hans" typeface="宋体"/>
+        <a:font script="Hant" typeface="新細明體"/>
+        <a:font script="Arab" typeface="Times New Roman"/>
+        <a:font script="Hebr" typeface="Times New Roman"/>
+        <a:font script="Thai" typeface="Angsana New"/>
+        <a:font script="Ethi" typeface="Nyala"/>
+        <a:font script="Beng" typeface="Vrinda"/>
+        <a:font script="Gujr" typeface="Shruti"/>
+        <a:font script="Khmr" typeface="MoolBoran"/>
+        <a:font script="Knda" typeface="Tunga"/>
+        <a:font script="Guru" typeface="Raavi"/>
+        <a:font script="Cans" typeface="Euphemia"/>
+        <a:font script="Cher" typeface="Plantagenet Cherokee"/>
+        <a:font script="Yiii" typeface="Microsoft Yi Baiti"/>
+        <a:font script="Tibt" typeface="Microsoft Himalaya"/>
+        <a:font script="Thaa" typeface="MV Boli"/>
+        <a:font script="Deva" typeface="Mangal"/>
+        <a:font script="Telu" typeface="Gautami"/>
+        <a:font script="Taml" typeface="Latha"/>
+        <a:font script="Syrc" typeface="Estrangelo Edessa"/>
+        <a:font script="Orya" typeface="Kalinga"/>
+        <a:font script="Mlym" typeface="Kartika"/>
+        <a:font script="Laoo" typeface="DokChampa"/>
+        <a:font script="Sinh" typeface="Iskoola Pota"/>
+        <a:font script="Mong" typeface="Mongolian Baiti"/>
+        <a:font script="Viet" typeface="Times New Roman"/>
+        <a:font script="Uigh" typeface="Microsoft Uighur"/>
+        <a:font script="Geor" typeface="Sylfaen"/>
+      </a:majorFont>
+      <a:minorFont>
+        <a:latin typeface="Calibri"/>
+        <a:ea typeface=""/>
+        <a:cs typeface=""/>
+        <a:font script="Jpan" typeface="ＭＳ Ｐゴシック"/>
+        <a:font script="Hang" typeface="맑은 고딕"/>
+        <a:font script="Hans" typeface="宋体"/>
+        <a:font script="Hant" typeface="新細明體"/>
+        <a:font script="Arab" typeface="Arial"/>
+        <a:font script="Hebr" typeface="Arial"/>
+        <a:font script="Thai" typeface="Cordia New"/>
+        <a:font script="Ethi" typeface="Nyala"/>
+        <a:font script="Beng" typeface="Vrinda"/>
+        <a:font script="Gujr" typeface="Shruti"/>
+        <a:font script="Khmr" typeface="DaunPenh"/>
+        <a:font script="Knda" typeface="Tunga"/>
+        <a:font script="Guru" typeface="Raavi"/>
+        <a:font script="Cans" typeface="Euphemia"/>
+        <a:font script="Cher" typeface="Plantagenet Cherokee"/>
+        <a:font script="Yiii" typeface="Microsoft Yi Baiti"/>
+        <a:font script="Tibt" typeface="Microsoft Himalaya"/>
+        <a:font script="Thaa" typeface="MV Boli"/>
+        <a:font script="Deva" typeface="Mangal"/>
+        <a:font script="Telu" typeface="Gautami"/>
+        <a:font script="Taml" typeface="Latha"/>
+        <a:font script="Syrc" typeface="Estrangelo Edessa"/>
+        <a:font script="Orya" typeface="Kalinga"/>
+        <a:font script="Mlym" typeface="Kartika"/>
+        <a:font script="Laoo" typeface="DokChampa"/>
+        <a:font script="Sinh" typeface="Iskoola Pota"/>
+        <a:font script="Mong" typeface="Mongolian Baiti"/>
+        <a:font script="Viet" typeface="Arial"/>
+        <a:font script="Uigh" typeface="Microsoft Uighur"/>
+        <a:font script="Geor" typeface="Sylfaen"/>
+      </a:minorFont>
+    </a:fontScheme>
+    <a:fmtScheme name="Office">
+      <a:fillStyleLst>
+        <a:solidFill>
+          <a:schemeClr val="phClr"/>
+        </a:solidFill>
+        <a:gradFill rotWithShape="1">
+          <a:gsLst>
+            <a:gs pos="0">
+              <a:schemeClr val="phClr">
+                <a:tint val="50000"/>
+                <a:satMod val="300000"/>
+              </a:schemeClr>
+            </a:gs>
+            <a:gs pos="35000">
+              <a:schemeClr val="phClr">
+                <a:tint val="37000"/>
+                <a:satMod val="300000"/>
+              </a:schemeClr>
+            </a:gs>
+            <a:gs pos="100000">
+              <a:schemeClr val="phClr">
+                <a:tint val="15000"/>
+                <a:satMod val="350000"/>
+              </a:schemeClr>
+            </a:gs>
+          </a:gsLst>
+          <a:lin ang="16200000" scaled="1"/>
+        </a:gradFill>
+        <a:gradFill rotWithShape="1">
+          <a:gsLst>
+            <a:gs pos="0">
+              <a:schemeClr val="phClr">
+                <a:tint val="100000"/>
+                <a:shade val="100000"/>
+                <a:satMod val="130000"/>
+              </a:schemeClr>
+            </a:gs>
+            <a:gs pos="100000">
+              <a:schemeClr val="phClr">
+                <a:tint val="50000"/>
+                <a:shade val="100000"/>
+                <a:satMod val="350000"/>
+              </a:schemeClr>
+            </a:gs>
+          </a:gsLst>
+          <a:lin ang="16200000" scaled="0"/>
+        </a:gradFill>
+      </a:fillStyleLst>
+      <a:lnStyleLst>
+        <a:ln w="9525" cap="flat" cmpd="sng" algn="ctr">
+          <a:solidFill>
+            <a:schemeClr val="phClr">
+              <a:shade val="95000"/>
+              <a:satMod val="105000"/>
+            </a:schemeClr>
+          </a:solidFill>
+          <a:prstDash val="solid"/>
+        </a:ln>
+        <a:ln w="25400" cap="flat" cmpd="sng" algn="ctr">
+          <a:solidFill>
+            <a:schemeClr val="phClr"/>
+          </a:solidFill>
+          <a:prstDash val="solid"/>
+        </a:ln>
+        <a:ln w="38100" cap="flat" cmpd="sng" algn="ctr">
+          <a:solidFill>
+            <a:schemeClr val="phClr"/>
+          </a:solidFill>
+          <a:prstDash val="solid"/>
+        </a:ln>
+      </a:lnStyleLst>
+      <a:effectStyleLst>
+        <a:effectStyle>
+          <a:effectLst>
+            <a:outerShdw blurRad="40000" dist="20000" dir="5400000" rotWithShape="0">
+              <a:srgbClr val="000000">
+                <a:alpha val="38000"/>
+              </a:srgbClr>
+            </a:outerShdw>
+          </a:effectLst>
+        </a:effectStyle>
+        <a:effectStyle>
+          <a:effectLst>
+            <a:outerShdw blurRad="40000" dist="23000" dir="5400000" rotWithShape="0">
+              <a:srgbClr val="000000">
+                <a:alpha val="35000"/>
+              </a:srgbClr>
+            </a:outerShdw>
+          </a:effectLst>
+        </a:effectStyle>
+        <a:effectStyle>
+          <a:effectLst>
+            <a:outerShdw blurRad="40000" dist="23000" dir="5400000" rotWithShape="0">
+              <a:srgbClr val="000000">
+                <a:alpha val="35000"/>
+              </a:srgbClr>
+            </a:outerShdw>
+          </a:effectLst>
+          <a:scene3d>
+            <a:camera prst="orthographicFront">
+              <a:rot lat="0" lon="0" rev="0"/>
+            </a:camera>
+            <a:lightRig rig="threePt" dir="t">
+              <a:rot lat="0" lon="0" rev="1200000"/>
+            </a:lightRig>
+          </a:scene3d>
+          <a:sp3d>
+            <a:bevelT w="63500" h="25400"/>
+          </a:sp3d>
+        </a:effectStyle>
+      </a:effectStyleLst>
+      <a:bgFillStyleLst>
+        <a:solidFill>
+          <a:schemeClr val="phClr"/>
+        </a:solidFill>
+        <a:gradFill rotWithShape="1">
+          <a:gsLst>
+            <a:gs pos="0">
+              <a:schemeClr val="phClr">
+                <a:tint val="40000"/>
+                <a:satMod val="350000"/>
+              </a:schemeClr>
+            </a:gs>
+            <a:gs pos="40000">
+              <a:schemeClr val="phClr">
+                <a:tint val="45000"/>
+                <a:shade val="99000"/>
+                <a:satMod val="350000"/>
+              </a:schemeClr>
+            </a:gs>
+            <a:gs pos="100000">
+              <a:schemeClr val="phClr">
+                <a:shade val="20000"/>
+                <a:satMod val="255000"/>
+              </a:schemeClr>
+            </a:gs>
+          </a:gsLst>
+          <a:path path="circle">
+            <a:fillToRect l="50000" t="-80000" r="50000" b="180000"/>
+          </a:path>
+        </a:gradFill>
+        <a:gradFill rotWithShape="1">
+          <a:gsLst>
+            <a:gs pos="0">
+              <a:schemeClr val="phClr">
+                <a:tint val="80000"/>
+                <a:satMod val="300000"/>
+              </a:schemeClr>
+            </a:gs>
+            <a:gs pos="100000">
+              <a:schemeClr val="phClr">
+                <a:shade val="30000"/>
+                <a:satMod val="200000"/>
+              </a:schemeClr>
+            </a:gs>
+          </a:gsLst>
+          <a:path path="circle">
+            <a:fillToRect l="50000" t="50000" r="50000" b="50000"/>
+          </a:path>
+        </a:gradFill>
+      </a:bgFillStyleLst>
+    </a:fmtScheme>
+  </a:themeElements>
+  <a:objectDefaults>
+    <a:spDef>
+      <a:spPr/>
+      <a:bodyPr/>
+      <a:lstStyle/>
+      <a:style>
+        <a:lnRef idx="1">
+          <a:schemeClr val="accent1"/>
+        </a:lnRef>
+        <a:fillRef idx="3">
+          <a:schemeClr val="accent1"/>
+        </a:fillRef>
+        <a:effectRef idx="2">
+          <a:schemeClr val="accent1"/>
+        </a:effectRef>
+        <a:fontRef idx="minor">
+          <a:schemeClr val="lt1"/>
+        </a:fontRef>
+      </a:style>
+    </a:spDef>
+    <a:lnDef>
+      <a:spPr/>
+      <a:bodyPr/>
+      <a:lstStyle/>
+      <a:style>
+        <a:lnRef idx="2">
+          <a:schemeClr val="accent1"/>
+        </a:lnRef>
+        <a:fillRef idx="0">
+          <a:schemeClr val="accent1"/>
+        </a:fillRef>
+        <a:effectRef idx="1">
+          <a:schemeClr val="accent1"/>
+        </a:effectRef>
+        <a:fontRef idx="minor">
+          <a:schemeClr val="tx1"/>
+        </a:fontRef>
+      </a:style>
+    </a:lnDef>
+  </a:objectDefaults>
+  <a:extraClrSchemeLst/>
+</a:theme>
+</file>
+
 <file path=docMetadata/LabelInfo.xml><?xml version="1.0" encoding="utf-8"?>
 <clbl:labelList xmlns:clbl="http://schemas.microsoft.com/office/2020/mipLabelMetadata">
   <clbl:label id="{f42aa342-8706-4288-bd11-ebb85995028c}" enabled="1" method="Standard" siteId="{72f988bf-86f1-41af-91ab-2d7cd011db47}" contentBits="0" removed="0"/>

</xml_diff>

<commit_message>
Clean student-facing deck text
Remove instructor-facing meta subtitles and coverage text from visible slides while preserving speaker notes.

Co-authored-by: Copilot <223556219+Copilot@users.noreply.github.com>
</commit_message>
<xml_diff>
--- a/modules/01-advanced-semantic-modeling/assets/advanced-semantic-modeling.pptx
+++ b/modules/01-advanced-semantic-modeling/assets/advanced-semantic-modeling.pptx
@@ -4838,7 +4838,7 @@
               </a:defRPr>
             </a:pPr>
             <a:r>
-              <a:t>Power BI Advanced Factory teaching deck</a:t>
+              <a:t>Student module overview</a:t>
             </a:r>
           </a:p>
         </p:txBody>
@@ -5376,42 +5376,6 @@
       </p:sp>
       <p:sp>
         <p:nvSpPr>
-          <p:cNvPr id="4" name="TextBox 3"/>
-          <p:cNvSpPr txBox="1"/>
-          <p:nvPr/>
-        </p:nvSpPr>
-        <p:spPr>
-          <a:xfrm>
-            <a:off x="530352" y="914400"/>
-            <a:ext cx="10515600" cy="320040"/>
-          </a:xfrm>
-          <a:prstGeom prst="rect">
-            <a:avLst/>
-          </a:prstGeom>
-          <a:noFill/>
-        </p:spPr>
-        <p:txBody>
-          <a:bodyPr wrap="none">
-            <a:spAutoFit/>
-          </a:bodyPr>
-          <a:lstStyle/>
-          <a:p>
-            <a:pPr>
-              <a:defRPr sz="1200">
-                <a:solidFill>
-                  <a:srgbClr val="5C5C5C"/>
-                </a:solidFill>
-                <a:latin typeface="Aptos"/>
-              </a:defRPr>
-            </a:pPr>
-            <a:r>
-              <a:t>Talking points, learner value, and lab connection</a:t>
-            </a:r>
-          </a:p>
-        </p:txBody>
-      </p:sp>
-      <p:sp>
-        <p:nvSpPr>
           <p:cNvPr id="5" name="Rounded Rectangle 4"/>
           <p:cNvSpPr/>
           <p:nvPr/>
@@ -5531,7 +5495,145 @@
               </a:defRPr>
             </a:pPr>
             <a:r>
-              <a:t>Talking points</a:t>
+              <a:t>Key ideas</a:t>
+            </a:r>
+            <a:br/>
+            <a:r>
+              <a:t>• Cardinality reduction</a:t>
+            </a:r>
+            <a:br/>
+            <a:r>
+              <a:t>• Aggregations</a:t>
+            </a:r>
+            <a:br/>
+            <a:r>
+              <a:t>• Incremental refresh</a:t>
+            </a:r>
+          </a:p>
+        </p:txBody>
+      </p:sp>
+      <p:sp>
+        <p:nvSpPr>
+          <p:cNvPr id="8" name="Rounded Rectangle 7"/>
+          <p:cNvSpPr/>
+          <p:nvPr/>
+        </p:nvSpPr>
+        <p:spPr>
+          <a:xfrm>
+            <a:off x="6263640" y="1234440"/>
+            <a:ext cx="5303520" cy="1828800"/>
+          </a:xfrm>
+          <a:prstGeom prst="roundRect">
+            <a:avLst/>
+          </a:prstGeom>
+          <a:solidFill>
+            <a:srgbClr val="FFFFFF"/>
+          </a:solidFill>
+          <a:ln>
+            <a:solidFill>
+              <a:srgbClr val="DCDCDC"/>
+            </a:solidFill>
+          </a:ln>
+        </p:spPr>
+        <p:style>
+          <a:lnRef idx="1">
+            <a:schemeClr val="accent1"/>
+          </a:lnRef>
+          <a:fillRef idx="3">
+            <a:schemeClr val="accent1"/>
+          </a:fillRef>
+          <a:effectRef idx="2">
+            <a:schemeClr val="accent1"/>
+          </a:effectRef>
+          <a:fontRef idx="minor">
+            <a:schemeClr val="lt1"/>
+          </a:fontRef>
+        </p:style>
+        <p:txBody>
+          <a:bodyPr rtlCol="0" anchor="ctr"/>
+          <a:lstStyle/>
+          <a:p>
+            <a:pPr algn="ctr"/>
+            <a:endParaRPr/>
+          </a:p>
+        </p:txBody>
+      </p:sp>
+      <p:sp>
+        <p:nvSpPr>
+          <p:cNvPr id="9" name="Rectangle 8"/>
+          <p:cNvSpPr/>
+          <p:nvPr/>
+        </p:nvSpPr>
+        <p:spPr>
+          <a:xfrm>
+            <a:off x="6263640" y="1234440"/>
+            <a:ext cx="91440" cy="1828800"/>
+          </a:xfrm>
+          <a:prstGeom prst="rect">
+            <a:avLst/>
+          </a:prstGeom>
+          <a:solidFill>
+            <a:srgbClr val="02C39A"/>
+          </a:solidFill>
+          <a:ln>
+            <a:noFill/>
+          </a:ln>
+        </p:spPr>
+        <p:style>
+          <a:lnRef idx="1">
+            <a:schemeClr val="accent1"/>
+          </a:lnRef>
+          <a:fillRef idx="3">
+            <a:schemeClr val="accent1"/>
+          </a:fillRef>
+          <a:effectRef idx="2">
+            <a:schemeClr val="accent1"/>
+          </a:effectRef>
+          <a:fontRef idx="minor">
+            <a:schemeClr val="lt1"/>
+          </a:fontRef>
+        </p:style>
+        <p:txBody>
+          <a:bodyPr rtlCol="0" anchor="ctr"/>
+          <a:lstStyle/>
+          <a:p>
+            <a:pPr algn="ctr"/>
+            <a:endParaRPr/>
+          </a:p>
+        </p:txBody>
+      </p:sp>
+      <p:sp>
+        <p:nvSpPr>
+          <p:cNvPr id="10" name="TextBox 9"/>
+          <p:cNvSpPr txBox="1"/>
+          <p:nvPr/>
+        </p:nvSpPr>
+        <p:spPr>
+          <a:xfrm>
+            <a:off x="6446520" y="1344168"/>
+            <a:ext cx="4983480" cy="1664208"/>
+          </a:xfrm>
+          <a:prstGeom prst="rect">
+            <a:avLst/>
+          </a:prstGeom>
+          <a:noFill/>
+        </p:spPr>
+        <p:txBody>
+          <a:bodyPr wrap="square" lIns="0" rIns="0">
+            <a:spAutoFit/>
+          </a:bodyPr>
+          <a:lstStyle/>
+          <a:p>
+            <a:pPr>
+              <a:defRPr sz="1500" b="1">
+                <a:solidFill>
+                  <a:srgbClr val="1E2761"/>
+                </a:solidFill>
+                <a:latin typeface="Aptos Display"/>
+              </a:defRPr>
+            </a:pPr>
+            <a:r>
+              <a:t>Why it helps</a:t>
             </a:r>
           </a:p>
           <a:p>
@@ -5547,29 +5649,25 @@
               </a:defRPr>
             </a:pPr>
             <a:r>
-              <a:t>• Cardinality reduction</a:t>
+              <a:t>• Capacity and tenant settings</a:t>
             </a:r>
             <a:br/>
             <a:r>
-              <a:t>• Aggregations</a:t>
-            </a:r>
-            <a:br/>
-            <a:r>
-              <a:t>• Incremental refresh</a:t>
-            </a:r>
-          </a:p>
-        </p:txBody>
-      </p:sp>
-      <p:sp>
-        <p:nvSpPr>
-          <p:cNvPr id="8" name="Rounded Rectangle 7"/>
+              <a:t>• Gov validation requirements</a:t>
+            </a:r>
+          </a:p>
+        </p:txBody>
+      </p:sp>
+      <p:sp>
+        <p:nvSpPr>
+          <p:cNvPr id="11" name="Rounded Rectangle 10"/>
           <p:cNvSpPr/>
           <p:nvPr/>
         </p:nvSpPr>
         <p:spPr>
           <a:xfrm>
-            <a:off x="6263640" y="1234440"/>
-            <a:ext cx="5303520" cy="1828800"/>
+            <a:off x="822960" y="4160520"/>
+            <a:ext cx="10424160" cy="868680"/>
           </a:xfrm>
           <a:prstGeom prst="roundRect">
             <a:avLst/>
@@ -5608,20 +5706,20 @@
       </p:sp>
       <p:sp>
         <p:nvSpPr>
-          <p:cNvPr id="9" name="Rectangle 8"/>
+          <p:cNvPr id="12" name="Rectangle 11"/>
           <p:cNvSpPr/>
           <p:nvPr/>
         </p:nvSpPr>
         <p:spPr>
           <a:xfrm>
-            <a:off x="6263640" y="1234440"/>
-            <a:ext cx="91440" cy="1828800"/>
+            <a:off x="822960" y="4160520"/>
+            <a:ext cx="91440" cy="868680"/>
           </a:xfrm>
           <a:prstGeom prst="rect">
             <a:avLst/>
           </a:prstGeom>
           <a:solidFill>
-            <a:srgbClr val="02C39A"/>
+            <a:srgbClr val="F9B700"/>
           </a:solidFill>
           <a:ln>
             <a:noFill/>
@@ -5652,14 +5750,14 @@
       </p:sp>
       <p:sp>
         <p:nvSpPr>
-          <p:cNvPr id="10" name="TextBox 9"/>
+          <p:cNvPr id="13" name="TextBox 12"/>
           <p:cNvSpPr txBox="1"/>
           <p:nvPr/>
         </p:nvSpPr>
         <p:spPr>
           <a:xfrm>
-            <a:off x="6446520" y="1344168"/>
-            <a:ext cx="4983480" cy="1664208"/>
+            <a:off x="1005840" y="4270248"/>
+            <a:ext cx="10104120" cy="704088"/>
           </a:xfrm>
           <a:prstGeom prst="rect">
             <a:avLst/>
@@ -5681,169 +5779,7 @@
               </a:defRPr>
             </a:pPr>
             <a:r>
-              <a:t>Why it helps</a:t>
-            </a:r>
-          </a:p>
-          <a:p>
-            <a:pPr>
-              <a:spcBef>
-                <a:spcPts val="400"/>
-              </a:spcBef>
-              <a:defRPr sz="1050">
-                <a:solidFill>
-                  <a:srgbClr val="242424"/>
-                </a:solidFill>
-                <a:latin typeface="Aptos"/>
-              </a:defRPr>
-            </a:pPr>
-            <a:r>
-              <a:t>• Capacity and tenant settings</a:t>
-            </a:r>
-            <a:br/>
-            <a:r>
-              <a:t>• Gov validation requirements</a:t>
-            </a:r>
-          </a:p>
-        </p:txBody>
-      </p:sp>
-      <p:sp>
-        <p:nvSpPr>
-          <p:cNvPr id="11" name="Rounded Rectangle 10"/>
-          <p:cNvSpPr/>
-          <p:nvPr/>
-        </p:nvSpPr>
-        <p:spPr>
-          <a:xfrm>
-            <a:off x="822960" y="4160520"/>
-            <a:ext cx="10424160" cy="868680"/>
-          </a:xfrm>
-          <a:prstGeom prst="roundRect">
-            <a:avLst/>
-          </a:prstGeom>
-          <a:solidFill>
-            <a:srgbClr val="FFFFFF"/>
-          </a:solidFill>
-          <a:ln>
-            <a:solidFill>
-              <a:srgbClr val="DCDCDC"/>
-            </a:solidFill>
-          </a:ln>
-        </p:spPr>
-        <p:style>
-          <a:lnRef idx="1">
-            <a:schemeClr val="accent1"/>
-          </a:lnRef>
-          <a:fillRef idx="3">
-            <a:schemeClr val="accent1"/>
-          </a:fillRef>
-          <a:effectRef idx="2">
-            <a:schemeClr val="accent1"/>
-          </a:effectRef>
-          <a:fontRef idx="minor">
-            <a:schemeClr val="lt1"/>
-          </a:fontRef>
-        </p:style>
-        <p:txBody>
-          <a:bodyPr rtlCol="0" anchor="ctr"/>
-          <a:lstStyle/>
-          <a:p>
-            <a:pPr algn="ctr"/>
-            <a:endParaRPr/>
-          </a:p>
-        </p:txBody>
-      </p:sp>
-      <p:sp>
-        <p:nvSpPr>
-          <p:cNvPr id="12" name="Rectangle 11"/>
-          <p:cNvSpPr/>
-          <p:nvPr/>
-        </p:nvSpPr>
-        <p:spPr>
-          <a:xfrm>
-            <a:off x="822960" y="4160520"/>
-            <a:ext cx="91440" cy="868680"/>
-          </a:xfrm>
-          <a:prstGeom prst="rect">
-            <a:avLst/>
-          </a:prstGeom>
-          <a:solidFill>
-            <a:srgbClr val="F9B700"/>
-          </a:solidFill>
-          <a:ln>
-            <a:noFill/>
-          </a:ln>
-        </p:spPr>
-        <p:style>
-          <a:lnRef idx="1">
-            <a:schemeClr val="accent1"/>
-          </a:lnRef>
-          <a:fillRef idx="3">
-            <a:schemeClr val="accent1"/>
-          </a:fillRef>
-          <a:effectRef idx="2">
-            <a:schemeClr val="accent1"/>
-          </a:effectRef>
-          <a:fontRef idx="minor">
-            <a:schemeClr val="lt1"/>
-          </a:fontRef>
-        </p:style>
-        <p:txBody>
-          <a:bodyPr rtlCol="0" anchor="ctr"/>
-          <a:lstStyle/>
-          <a:p>
-            <a:pPr algn="ctr"/>
-            <a:endParaRPr/>
-          </a:p>
-        </p:txBody>
-      </p:sp>
-      <p:sp>
-        <p:nvSpPr>
-          <p:cNvPr id="13" name="TextBox 12"/>
-          <p:cNvSpPr txBox="1"/>
-          <p:nvPr/>
-        </p:nvSpPr>
-        <p:spPr>
-          <a:xfrm>
-            <a:off x="1005840" y="4270248"/>
-            <a:ext cx="10104120" cy="704088"/>
-          </a:xfrm>
-          <a:prstGeom prst="rect">
-            <a:avLst/>
-          </a:prstGeom>
-          <a:noFill/>
-        </p:spPr>
-        <p:txBody>
-          <a:bodyPr wrap="square" lIns="0" rIns="0">
-            <a:spAutoFit/>
-          </a:bodyPr>
-          <a:lstStyle/>
-          <a:p>
-            <a:pPr>
-              <a:defRPr sz="1500" b="1">
-                <a:solidFill>
-                  <a:srgbClr val="1E2761"/>
-                </a:solidFill>
-                <a:latin typeface="Aptos Display"/>
-              </a:defRPr>
-            </a:pPr>
-            <a:r>
-              <a:t>Lab connection</a:t>
-            </a:r>
-          </a:p>
-          <a:p>
-            <a:pPr>
-              <a:spcBef>
-                <a:spcPts val="400"/>
-              </a:spcBef>
-              <a:defRPr sz="1050">
-                <a:solidFill>
-                  <a:srgbClr val="242424"/>
-                </a:solidFill>
-                <a:latin typeface="Aptos"/>
-              </a:defRPr>
-            </a:pPr>
-            <a:r>
-              <a:t>Coverage: Covered. Use the lab README to demonstrate or discuss this topic. Review terms: aggregations, capacity, considerations, incremental, reduction.</a:t>
+              <a:t>In the lab, you will apply this pattern, validate the expected behavior, and discuss where it fits in a real Power BI solution.</a:t>
             </a:r>
           </a:p>
         </p:txBody>
@@ -5990,42 +5926,6 @@
       </p:sp>
       <p:sp>
         <p:nvSpPr>
-          <p:cNvPr id="4" name="TextBox 3"/>
-          <p:cNvSpPr txBox="1"/>
-          <p:nvPr/>
-        </p:nvSpPr>
-        <p:spPr>
-          <a:xfrm>
-            <a:off x="530352" y="914400"/>
-            <a:ext cx="10515600" cy="320040"/>
-          </a:xfrm>
-          <a:prstGeom prst="rect">
-            <a:avLst/>
-          </a:prstGeom>
-          <a:noFill/>
-        </p:spPr>
-        <p:txBody>
-          <a:bodyPr wrap="none">
-            <a:spAutoFit/>
-          </a:bodyPr>
-          <a:lstStyle/>
-          <a:p>
-            <a:pPr>
-              <a:defRPr sz="1200">
-                <a:solidFill>
-                  <a:srgbClr val="5C5C5C"/>
-                </a:solidFill>
-                <a:latin typeface="Aptos"/>
-              </a:defRPr>
-            </a:pPr>
-            <a:r>
-              <a:t>Talking points, learner value, and lab connection</a:t>
-            </a:r>
-          </a:p>
-        </p:txBody>
-      </p:sp>
-      <p:sp>
-        <p:nvSpPr>
           <p:cNvPr id="5" name="Rounded Rectangle 4"/>
           <p:cNvSpPr/>
           <p:nvPr/>
@@ -6145,7 +6045,141 @@
               </a:defRPr>
             </a:pPr>
             <a:r>
-              <a:t>Talking points</a:t>
+              <a:t>Key ideas</a:t>
+            </a:r>
+            <a:br/>
+            <a:r>
+              <a:t>• Data overview</a:t>
+            </a:r>
+            <a:br/>
+            <a:r>
+              <a:t>• Target model</a:t>
+            </a:r>
+          </a:p>
+        </p:txBody>
+      </p:sp>
+      <p:sp>
+        <p:nvSpPr>
+          <p:cNvPr id="8" name="Rounded Rectangle 7"/>
+          <p:cNvSpPr/>
+          <p:nvPr/>
+        </p:nvSpPr>
+        <p:spPr>
+          <a:xfrm>
+            <a:off x="6263640" y="1234440"/>
+            <a:ext cx="5303520" cy="1828800"/>
+          </a:xfrm>
+          <a:prstGeom prst="roundRect">
+            <a:avLst/>
+          </a:prstGeom>
+          <a:solidFill>
+            <a:srgbClr val="FFFFFF"/>
+          </a:solidFill>
+          <a:ln>
+            <a:solidFill>
+              <a:srgbClr val="DCDCDC"/>
+            </a:solidFill>
+          </a:ln>
+        </p:spPr>
+        <p:style>
+          <a:lnRef idx="1">
+            <a:schemeClr val="accent1"/>
+          </a:lnRef>
+          <a:fillRef idx="3">
+            <a:schemeClr val="accent1"/>
+          </a:fillRef>
+          <a:effectRef idx="2">
+            <a:schemeClr val="accent1"/>
+          </a:effectRef>
+          <a:fontRef idx="minor">
+            <a:schemeClr val="lt1"/>
+          </a:fontRef>
+        </p:style>
+        <p:txBody>
+          <a:bodyPr rtlCol="0" anchor="ctr"/>
+          <a:lstStyle/>
+          <a:p>
+            <a:pPr algn="ctr"/>
+            <a:endParaRPr/>
+          </a:p>
+        </p:txBody>
+      </p:sp>
+      <p:sp>
+        <p:nvSpPr>
+          <p:cNvPr id="9" name="Rectangle 8"/>
+          <p:cNvSpPr/>
+          <p:nvPr/>
+        </p:nvSpPr>
+        <p:spPr>
+          <a:xfrm>
+            <a:off x="6263640" y="1234440"/>
+            <a:ext cx="91440" cy="1828800"/>
+          </a:xfrm>
+          <a:prstGeom prst="rect">
+            <a:avLst/>
+          </a:prstGeom>
+          <a:solidFill>
+            <a:srgbClr val="02C39A"/>
+          </a:solidFill>
+          <a:ln>
+            <a:noFill/>
+          </a:ln>
+        </p:spPr>
+        <p:style>
+          <a:lnRef idx="1">
+            <a:schemeClr val="accent1"/>
+          </a:lnRef>
+          <a:fillRef idx="3">
+            <a:schemeClr val="accent1"/>
+          </a:fillRef>
+          <a:effectRef idx="2">
+            <a:schemeClr val="accent1"/>
+          </a:effectRef>
+          <a:fontRef idx="minor">
+            <a:schemeClr val="lt1"/>
+          </a:fontRef>
+        </p:style>
+        <p:txBody>
+          <a:bodyPr rtlCol="0" anchor="ctr"/>
+          <a:lstStyle/>
+          <a:p>
+            <a:pPr algn="ctr"/>
+            <a:endParaRPr/>
+          </a:p>
+        </p:txBody>
+      </p:sp>
+      <p:sp>
+        <p:nvSpPr>
+          <p:cNvPr id="10" name="TextBox 9"/>
+          <p:cNvSpPr txBox="1"/>
+          <p:nvPr/>
+        </p:nvSpPr>
+        <p:spPr>
+          <a:xfrm>
+            <a:off x="6446520" y="1344168"/>
+            <a:ext cx="4983480" cy="1664208"/>
+          </a:xfrm>
+          <a:prstGeom prst="rect">
+            <a:avLst/>
+          </a:prstGeom>
+          <a:noFill/>
+        </p:spPr>
+        <p:txBody>
+          <a:bodyPr wrap="square" lIns="0" rIns="0">
+            <a:spAutoFit/>
+          </a:bodyPr>
+          <a:lstStyle/>
+          <a:p>
+            <a:pPr>
+              <a:defRPr sz="1500" b="1">
+                <a:solidFill>
+                  <a:srgbClr val="1E2761"/>
+                </a:solidFill>
+                <a:latin typeface="Aptos Display"/>
+              </a:defRPr>
+            </a:pPr>
+            <a:r>
+              <a:t>Why it helps</a:t>
             </a:r>
           </a:p>
           <a:p>
@@ -6161,25 +6195,25 @@
               </a:defRPr>
             </a:pPr>
             <a:r>
-              <a:t>• Data overview</a:t>
+              <a:t>• Validation checks</a:t>
             </a:r>
             <a:br/>
             <a:r>
-              <a:t>• Target model</a:t>
-            </a:r>
-          </a:p>
-        </p:txBody>
-      </p:sp>
-      <p:sp>
-        <p:nvSpPr>
-          <p:cNvPr id="8" name="Rounded Rectangle 7"/>
+              <a:t>• Optional commercial-enhanced path</a:t>
+            </a:r>
+          </a:p>
+        </p:txBody>
+      </p:sp>
+      <p:sp>
+        <p:nvSpPr>
+          <p:cNvPr id="11" name="Rounded Rectangle 10"/>
           <p:cNvSpPr/>
           <p:nvPr/>
         </p:nvSpPr>
         <p:spPr>
           <a:xfrm>
-            <a:off x="6263640" y="1234440"/>
-            <a:ext cx="5303520" cy="1828800"/>
+            <a:off x="822960" y="4160520"/>
+            <a:ext cx="10424160" cy="868680"/>
           </a:xfrm>
           <a:prstGeom prst="roundRect">
             <a:avLst/>
@@ -6218,20 +6252,20 @@
       </p:sp>
       <p:sp>
         <p:nvSpPr>
-          <p:cNvPr id="9" name="Rectangle 8"/>
+          <p:cNvPr id="12" name="Rectangle 11"/>
           <p:cNvSpPr/>
           <p:nvPr/>
         </p:nvSpPr>
         <p:spPr>
           <a:xfrm>
-            <a:off x="6263640" y="1234440"/>
-            <a:ext cx="91440" cy="1828800"/>
+            <a:off x="822960" y="4160520"/>
+            <a:ext cx="91440" cy="868680"/>
           </a:xfrm>
           <a:prstGeom prst="rect">
             <a:avLst/>
           </a:prstGeom>
           <a:solidFill>
-            <a:srgbClr val="02C39A"/>
+            <a:srgbClr val="F9B700"/>
           </a:solidFill>
           <a:ln>
             <a:noFill/>
@@ -6262,14 +6296,14 @@
       </p:sp>
       <p:sp>
         <p:nvSpPr>
-          <p:cNvPr id="10" name="TextBox 9"/>
+          <p:cNvPr id="13" name="TextBox 12"/>
           <p:cNvSpPr txBox="1"/>
           <p:nvPr/>
         </p:nvSpPr>
         <p:spPr>
           <a:xfrm>
-            <a:off x="6446520" y="1344168"/>
-            <a:ext cx="4983480" cy="1664208"/>
+            <a:off x="1005840" y="4270248"/>
+            <a:ext cx="10104120" cy="704088"/>
           </a:xfrm>
           <a:prstGeom prst="rect">
             <a:avLst/>
@@ -6291,169 +6325,7 @@
               </a:defRPr>
             </a:pPr>
             <a:r>
-              <a:t>Why it helps</a:t>
-            </a:r>
-          </a:p>
-          <a:p>
-            <a:pPr>
-              <a:spcBef>
-                <a:spcPts val="400"/>
-              </a:spcBef>
-              <a:defRPr sz="1050">
-                <a:solidFill>
-                  <a:srgbClr val="242424"/>
-                </a:solidFill>
-                <a:latin typeface="Aptos"/>
-              </a:defRPr>
-            </a:pPr>
-            <a:r>
-              <a:t>• Validation checks</a:t>
-            </a:r>
-            <a:br/>
-            <a:r>
-              <a:t>• Optional commercial-enhanced path</a:t>
-            </a:r>
-          </a:p>
-        </p:txBody>
-      </p:sp>
-      <p:sp>
-        <p:nvSpPr>
-          <p:cNvPr id="11" name="Rounded Rectangle 10"/>
-          <p:cNvSpPr/>
-          <p:nvPr/>
-        </p:nvSpPr>
-        <p:spPr>
-          <a:xfrm>
-            <a:off x="822960" y="4160520"/>
-            <a:ext cx="10424160" cy="868680"/>
-          </a:xfrm>
-          <a:prstGeom prst="roundRect">
-            <a:avLst/>
-          </a:prstGeom>
-          <a:solidFill>
-            <a:srgbClr val="FFFFFF"/>
-          </a:solidFill>
-          <a:ln>
-            <a:solidFill>
-              <a:srgbClr val="DCDCDC"/>
-            </a:solidFill>
-          </a:ln>
-        </p:spPr>
-        <p:style>
-          <a:lnRef idx="1">
-            <a:schemeClr val="accent1"/>
-          </a:lnRef>
-          <a:fillRef idx="3">
-            <a:schemeClr val="accent1"/>
-          </a:fillRef>
-          <a:effectRef idx="2">
-            <a:schemeClr val="accent1"/>
-          </a:effectRef>
-          <a:fontRef idx="minor">
-            <a:schemeClr val="lt1"/>
-          </a:fontRef>
-        </p:style>
-        <p:txBody>
-          <a:bodyPr rtlCol="0" anchor="ctr"/>
-          <a:lstStyle/>
-          <a:p>
-            <a:pPr algn="ctr"/>
-            <a:endParaRPr/>
-          </a:p>
-        </p:txBody>
-      </p:sp>
-      <p:sp>
-        <p:nvSpPr>
-          <p:cNvPr id="12" name="Rectangle 11"/>
-          <p:cNvSpPr/>
-          <p:nvPr/>
-        </p:nvSpPr>
-        <p:spPr>
-          <a:xfrm>
-            <a:off x="822960" y="4160520"/>
-            <a:ext cx="91440" cy="868680"/>
-          </a:xfrm>
-          <a:prstGeom prst="rect">
-            <a:avLst/>
-          </a:prstGeom>
-          <a:solidFill>
-            <a:srgbClr val="F9B700"/>
-          </a:solidFill>
-          <a:ln>
-            <a:noFill/>
-          </a:ln>
-        </p:spPr>
-        <p:style>
-          <a:lnRef idx="1">
-            <a:schemeClr val="accent1"/>
-          </a:lnRef>
-          <a:fillRef idx="3">
-            <a:schemeClr val="accent1"/>
-          </a:fillRef>
-          <a:effectRef idx="2">
-            <a:schemeClr val="accent1"/>
-          </a:effectRef>
-          <a:fontRef idx="minor">
-            <a:schemeClr val="lt1"/>
-          </a:fontRef>
-        </p:style>
-        <p:txBody>
-          <a:bodyPr rtlCol="0" anchor="ctr"/>
-          <a:lstStyle/>
-          <a:p>
-            <a:pPr algn="ctr"/>
-            <a:endParaRPr/>
-          </a:p>
-        </p:txBody>
-      </p:sp>
-      <p:sp>
-        <p:nvSpPr>
-          <p:cNvPr id="13" name="TextBox 12"/>
-          <p:cNvSpPr txBox="1"/>
-          <p:nvPr/>
-        </p:nvSpPr>
-        <p:spPr>
-          <a:xfrm>
-            <a:off x="1005840" y="4270248"/>
-            <a:ext cx="10104120" cy="704088"/>
-          </a:xfrm>
-          <a:prstGeom prst="rect">
-            <a:avLst/>
-          </a:prstGeom>
-          <a:noFill/>
-        </p:spPr>
-        <p:txBody>
-          <a:bodyPr wrap="square" lIns="0" rIns="0">
-            <a:spAutoFit/>
-          </a:bodyPr>
-          <a:lstStyle/>
-          <a:p>
-            <a:pPr>
-              <a:defRPr sz="1500" b="1">
-                <a:solidFill>
-                  <a:srgbClr val="1E2761"/>
-                </a:solidFill>
-                <a:latin typeface="Aptos Display"/>
-              </a:defRPr>
-            </a:pPr>
-            <a:r>
-              <a:t>Lab connection</a:t>
-            </a:r>
-          </a:p>
-          <a:p>
-            <a:pPr>
-              <a:spcBef>
-                <a:spcPts val="400"/>
-              </a:spcBef>
-              <a:defRPr sz="1050">
-                <a:solidFill>
-                  <a:srgbClr val="242424"/>
-                </a:solidFill>
-                <a:latin typeface="Aptos"/>
-              </a:defRPr>
-            </a:pPr>
-            <a:r>
-              <a:t>Coverage: Partial. Use the lab README to demonstrate or discuss this topic. Review terms: checks, commercial, enhanced, overview, walkthrough.</a:t>
+              <a:t>In the lab, you will apply this pattern, validate the expected behavior, and discuss where it fits in a real Power BI solution.</a:t>
             </a:r>
           </a:p>
         </p:txBody>
@@ -6600,42 +6472,6 @@
       </p:sp>
       <p:sp>
         <p:nvSpPr>
-          <p:cNvPr id="4" name="TextBox 3"/>
-          <p:cNvSpPr txBox="1"/>
-          <p:nvPr/>
-        </p:nvSpPr>
-        <p:spPr>
-          <a:xfrm>
-            <a:off x="530352" y="914400"/>
-            <a:ext cx="10515600" cy="320040"/>
-          </a:xfrm>
-          <a:prstGeom prst="rect">
-            <a:avLst/>
-          </a:prstGeom>
-          <a:noFill/>
-        </p:spPr>
-        <p:txBody>
-          <a:bodyPr wrap="none">
-            <a:spAutoFit/>
-          </a:bodyPr>
-          <a:lstStyle/>
-          <a:p>
-            <a:pPr>
-              <a:defRPr sz="1200">
-                <a:solidFill>
-                  <a:srgbClr val="5C5C5C"/>
-                </a:solidFill>
-                <a:latin typeface="Aptos"/>
-              </a:defRPr>
-            </a:pPr>
-            <a:r>
-              <a:t>Talking points, learner value, and lab connection</a:t>
-            </a:r>
-          </a:p>
-        </p:txBody>
-      </p:sp>
-      <p:sp>
-        <p:nvSpPr>
           <p:cNvPr id="5" name="Rounded Rectangle 4"/>
           <p:cNvSpPr/>
           <p:nvPr/>
@@ -6755,7 +6591,141 @@
               </a:defRPr>
             </a:pPr>
             <a:r>
-              <a:t>Talking points</a:t>
+              <a:t>Key ideas</a:t>
+            </a:r>
+            <a:br/>
+            <a:r>
+              <a:t>• Design tradeoffs</a:t>
+            </a:r>
+            <a:br/>
+            <a:r>
+              <a:t>• Gov readiness</a:t>
+            </a:r>
+          </a:p>
+        </p:txBody>
+      </p:sp>
+      <p:sp>
+        <p:nvSpPr>
+          <p:cNvPr id="8" name="Rounded Rectangle 7"/>
+          <p:cNvSpPr/>
+          <p:nvPr/>
+        </p:nvSpPr>
+        <p:spPr>
+          <a:xfrm>
+            <a:off x="6263640" y="1234440"/>
+            <a:ext cx="5303520" cy="1828800"/>
+          </a:xfrm>
+          <a:prstGeom prst="roundRect">
+            <a:avLst/>
+          </a:prstGeom>
+          <a:solidFill>
+            <a:srgbClr val="FFFFFF"/>
+          </a:solidFill>
+          <a:ln>
+            <a:solidFill>
+              <a:srgbClr val="DCDCDC"/>
+            </a:solidFill>
+          </a:ln>
+        </p:spPr>
+        <p:style>
+          <a:lnRef idx="1">
+            <a:schemeClr val="accent1"/>
+          </a:lnRef>
+          <a:fillRef idx="3">
+            <a:schemeClr val="accent1"/>
+          </a:fillRef>
+          <a:effectRef idx="2">
+            <a:schemeClr val="accent1"/>
+          </a:effectRef>
+          <a:fontRef idx="minor">
+            <a:schemeClr val="lt1"/>
+          </a:fontRef>
+        </p:style>
+        <p:txBody>
+          <a:bodyPr rtlCol="0" anchor="ctr"/>
+          <a:lstStyle/>
+          <a:p>
+            <a:pPr algn="ctr"/>
+            <a:endParaRPr/>
+          </a:p>
+        </p:txBody>
+      </p:sp>
+      <p:sp>
+        <p:nvSpPr>
+          <p:cNvPr id="9" name="Rectangle 8"/>
+          <p:cNvSpPr/>
+          <p:nvPr/>
+        </p:nvSpPr>
+        <p:spPr>
+          <a:xfrm>
+            <a:off x="6263640" y="1234440"/>
+            <a:ext cx="91440" cy="1828800"/>
+          </a:xfrm>
+          <a:prstGeom prst="rect">
+            <a:avLst/>
+          </a:prstGeom>
+          <a:solidFill>
+            <a:srgbClr val="02C39A"/>
+          </a:solidFill>
+          <a:ln>
+            <a:noFill/>
+          </a:ln>
+        </p:spPr>
+        <p:style>
+          <a:lnRef idx="1">
+            <a:schemeClr val="accent1"/>
+          </a:lnRef>
+          <a:fillRef idx="3">
+            <a:schemeClr val="accent1"/>
+          </a:fillRef>
+          <a:effectRef idx="2">
+            <a:schemeClr val="accent1"/>
+          </a:effectRef>
+          <a:fontRef idx="minor">
+            <a:schemeClr val="lt1"/>
+          </a:fontRef>
+        </p:style>
+        <p:txBody>
+          <a:bodyPr rtlCol="0" anchor="ctr"/>
+          <a:lstStyle/>
+          <a:p>
+            <a:pPr algn="ctr"/>
+            <a:endParaRPr/>
+          </a:p>
+        </p:txBody>
+      </p:sp>
+      <p:sp>
+        <p:nvSpPr>
+          <p:cNvPr id="10" name="TextBox 9"/>
+          <p:cNvSpPr txBox="1"/>
+          <p:nvPr/>
+        </p:nvSpPr>
+        <p:spPr>
+          <a:xfrm>
+            <a:off x="6446520" y="1344168"/>
+            <a:ext cx="4983480" cy="1664208"/>
+          </a:xfrm>
+          <a:prstGeom prst="rect">
+            <a:avLst/>
+          </a:prstGeom>
+          <a:noFill/>
+        </p:spPr>
+        <p:txBody>
+          <a:bodyPr wrap="square" lIns="0" rIns="0">
+            <a:spAutoFit/>
+          </a:bodyPr>
+          <a:lstStyle/>
+          <a:p>
+            <a:pPr>
+              <a:defRPr sz="1500" b="1">
+                <a:solidFill>
+                  <a:srgbClr val="1E2761"/>
+                </a:solidFill>
+                <a:latin typeface="Aptos Display"/>
+              </a:defRPr>
+            </a:pPr>
+            <a:r>
+              <a:t>Why it helps</a:t>
             </a:r>
           </a:p>
           <a:p>
@@ -6771,25 +6741,21 @@
               </a:defRPr>
             </a:pPr>
             <a:r>
-              <a:t>• Design tradeoffs</a:t>
-            </a:r>
-            <a:br/>
-            <a:r>
-              <a:t>• Gov readiness</a:t>
-            </a:r>
-          </a:p>
-        </p:txBody>
-      </p:sp>
-      <p:sp>
-        <p:nvSpPr>
-          <p:cNvPr id="8" name="Rounded Rectangle 7"/>
+              <a:t>• Production review checklist</a:t>
+            </a:r>
+          </a:p>
+        </p:txBody>
+      </p:sp>
+      <p:sp>
+        <p:nvSpPr>
+          <p:cNvPr id="11" name="Rounded Rectangle 10"/>
           <p:cNvSpPr/>
           <p:nvPr/>
         </p:nvSpPr>
         <p:spPr>
           <a:xfrm>
-            <a:off x="6263640" y="1234440"/>
-            <a:ext cx="5303520" cy="1828800"/>
+            <a:off x="822960" y="4160520"/>
+            <a:ext cx="10424160" cy="868680"/>
           </a:xfrm>
           <a:prstGeom prst="roundRect">
             <a:avLst/>
@@ -6828,20 +6794,20 @@
       </p:sp>
       <p:sp>
         <p:nvSpPr>
-          <p:cNvPr id="9" name="Rectangle 8"/>
+          <p:cNvPr id="12" name="Rectangle 11"/>
           <p:cNvSpPr/>
           <p:nvPr/>
         </p:nvSpPr>
         <p:spPr>
           <a:xfrm>
-            <a:off x="6263640" y="1234440"/>
-            <a:ext cx="91440" cy="1828800"/>
+            <a:off x="822960" y="4160520"/>
+            <a:ext cx="91440" cy="868680"/>
           </a:xfrm>
           <a:prstGeom prst="rect">
             <a:avLst/>
           </a:prstGeom>
           <a:solidFill>
-            <a:srgbClr val="02C39A"/>
+            <a:srgbClr val="F9B700"/>
           </a:solidFill>
           <a:ln>
             <a:noFill/>
@@ -6872,14 +6838,14 @@
       </p:sp>
       <p:sp>
         <p:nvSpPr>
-          <p:cNvPr id="10" name="TextBox 9"/>
+          <p:cNvPr id="13" name="TextBox 12"/>
           <p:cNvSpPr txBox="1"/>
           <p:nvPr/>
         </p:nvSpPr>
         <p:spPr>
           <a:xfrm>
-            <a:off x="6446520" y="1344168"/>
-            <a:ext cx="4983480" cy="1664208"/>
+            <a:off x="1005840" y="4270248"/>
+            <a:ext cx="10104120" cy="704088"/>
           </a:xfrm>
           <a:prstGeom prst="rect">
             <a:avLst/>
@@ -6901,165 +6867,7 @@
               </a:defRPr>
             </a:pPr>
             <a:r>
-              <a:t>Why it helps</a:t>
-            </a:r>
-          </a:p>
-          <a:p>
-            <a:pPr>
-              <a:spcBef>
-                <a:spcPts val="400"/>
-              </a:spcBef>
-              <a:defRPr sz="1050">
-                <a:solidFill>
-                  <a:srgbClr val="242424"/>
-                </a:solidFill>
-                <a:latin typeface="Aptos"/>
-              </a:defRPr>
-            </a:pPr>
-            <a:r>
-              <a:t>• Production review checklist</a:t>
-            </a:r>
-          </a:p>
-        </p:txBody>
-      </p:sp>
-      <p:sp>
-        <p:nvSpPr>
-          <p:cNvPr id="11" name="Rounded Rectangle 10"/>
-          <p:cNvSpPr/>
-          <p:nvPr/>
-        </p:nvSpPr>
-        <p:spPr>
-          <a:xfrm>
-            <a:off x="822960" y="4160520"/>
-            <a:ext cx="10424160" cy="868680"/>
-          </a:xfrm>
-          <a:prstGeom prst="roundRect">
-            <a:avLst/>
-          </a:prstGeom>
-          <a:solidFill>
-            <a:srgbClr val="FFFFFF"/>
-          </a:solidFill>
-          <a:ln>
-            <a:solidFill>
-              <a:srgbClr val="DCDCDC"/>
-            </a:solidFill>
-          </a:ln>
-        </p:spPr>
-        <p:style>
-          <a:lnRef idx="1">
-            <a:schemeClr val="accent1"/>
-          </a:lnRef>
-          <a:fillRef idx="3">
-            <a:schemeClr val="accent1"/>
-          </a:fillRef>
-          <a:effectRef idx="2">
-            <a:schemeClr val="accent1"/>
-          </a:effectRef>
-          <a:fontRef idx="minor">
-            <a:schemeClr val="lt1"/>
-          </a:fontRef>
-        </p:style>
-        <p:txBody>
-          <a:bodyPr rtlCol="0" anchor="ctr"/>
-          <a:lstStyle/>
-          <a:p>
-            <a:pPr algn="ctr"/>
-            <a:endParaRPr/>
-          </a:p>
-        </p:txBody>
-      </p:sp>
-      <p:sp>
-        <p:nvSpPr>
-          <p:cNvPr id="12" name="Rectangle 11"/>
-          <p:cNvSpPr/>
-          <p:nvPr/>
-        </p:nvSpPr>
-        <p:spPr>
-          <a:xfrm>
-            <a:off x="822960" y="4160520"/>
-            <a:ext cx="91440" cy="868680"/>
-          </a:xfrm>
-          <a:prstGeom prst="rect">
-            <a:avLst/>
-          </a:prstGeom>
-          <a:solidFill>
-            <a:srgbClr val="F9B700"/>
-          </a:solidFill>
-          <a:ln>
-            <a:noFill/>
-          </a:ln>
-        </p:spPr>
-        <p:style>
-          <a:lnRef idx="1">
-            <a:schemeClr val="accent1"/>
-          </a:lnRef>
-          <a:fillRef idx="3">
-            <a:schemeClr val="accent1"/>
-          </a:fillRef>
-          <a:effectRef idx="2">
-            <a:schemeClr val="accent1"/>
-          </a:effectRef>
-          <a:fontRef idx="minor">
-            <a:schemeClr val="lt1"/>
-          </a:fontRef>
-        </p:style>
-        <p:txBody>
-          <a:bodyPr rtlCol="0" anchor="ctr"/>
-          <a:lstStyle/>
-          <a:p>
-            <a:pPr algn="ctr"/>
-            <a:endParaRPr/>
-          </a:p>
-        </p:txBody>
-      </p:sp>
-      <p:sp>
-        <p:nvSpPr>
-          <p:cNvPr id="13" name="TextBox 12"/>
-          <p:cNvSpPr txBox="1"/>
-          <p:nvPr/>
-        </p:nvSpPr>
-        <p:spPr>
-          <a:xfrm>
-            <a:off x="1005840" y="4270248"/>
-            <a:ext cx="10104120" cy="704088"/>
-          </a:xfrm>
-          <a:prstGeom prst="rect">
-            <a:avLst/>
-          </a:prstGeom>
-          <a:noFill/>
-        </p:spPr>
-        <p:txBody>
-          <a:bodyPr wrap="square" lIns="0" rIns="0">
-            <a:spAutoFit/>
-          </a:bodyPr>
-          <a:lstStyle/>
-          <a:p>
-            <a:pPr>
-              <a:defRPr sz="1500" b="1">
-                <a:solidFill>
-                  <a:srgbClr val="1E2761"/>
-                </a:solidFill>
-                <a:latin typeface="Aptos Display"/>
-              </a:defRPr>
-            </a:pPr>
-            <a:r>
-              <a:t>Lab connection</a:t>
-            </a:r>
-          </a:p>
-          <a:p>
-            <a:pPr>
-              <a:spcBef>
-                <a:spcPts val="400"/>
-              </a:spcBef>
-              <a:defRPr sz="1050">
-                <a:solidFill>
-                  <a:srgbClr val="242424"/>
-                </a:solidFill>
-                <a:latin typeface="Aptos"/>
-              </a:defRPr>
-            </a:pPr>
-            <a:r>
-              <a:t>Coverage: Covered. Use the lab README to demonstrate or discuss this topic. Review terms: discussion, knowledge, production.</a:t>
+              <a:t>In the lab, you will apply this pattern, validate the expected behavior, and discuss where it fits in a real Power BI solution.</a:t>
             </a:r>
           </a:p>
         </p:txBody>
@@ -8095,42 +7903,6 @@
       </p:sp>
       <p:sp>
         <p:nvSpPr>
-          <p:cNvPr id="4" name="TextBox 3"/>
-          <p:cNvSpPr txBox="1"/>
-          <p:nvPr/>
-        </p:nvSpPr>
-        <p:spPr>
-          <a:xfrm>
-            <a:off x="530352" y="914400"/>
-            <a:ext cx="10515600" cy="320040"/>
-          </a:xfrm>
-          <a:prstGeom prst="rect">
-            <a:avLst/>
-          </a:prstGeom>
-          <a:noFill/>
-        </p:spPr>
-        <p:txBody>
-          <a:bodyPr wrap="none">
-            <a:spAutoFit/>
-          </a:bodyPr>
-          <a:lstStyle/>
-          <a:p>
-            <a:pPr>
-              <a:defRPr sz="1200">
-                <a:solidFill>
-                  <a:srgbClr val="5C5C5C"/>
-                </a:solidFill>
-                <a:latin typeface="Aptos"/>
-              </a:defRPr>
-            </a:pPr>
-            <a:r>
-              <a:t>Use this to introduce the section before hands-on labs.</a:t>
-            </a:r>
-          </a:p>
-        </p:txBody>
-      </p:sp>
-      <p:sp>
-        <p:nvSpPr>
           <p:cNvPr id="5" name="Rounded Rectangle 4"/>
           <p:cNvSpPr/>
           <p:nvPr/>
@@ -9407,42 +9179,6 @@
       </p:sp>
       <p:sp>
         <p:nvSpPr>
-          <p:cNvPr id="4" name="TextBox 3"/>
-          <p:cNvSpPr txBox="1"/>
-          <p:nvPr/>
-        </p:nvSpPr>
-        <p:spPr>
-          <a:xfrm>
-            <a:off x="530352" y="914400"/>
-            <a:ext cx="10515600" cy="320040"/>
-          </a:xfrm>
-          <a:prstGeom prst="rect">
-            <a:avLst/>
-          </a:prstGeom>
-          <a:noFill/>
-        </p:spPr>
-        <p:txBody>
-          <a:bodyPr wrap="none">
-            <a:spAutoFit/>
-          </a:bodyPr>
-          <a:lstStyle/>
-          <a:p>
-            <a:pPr>
-              <a:defRPr sz="1200">
-                <a:solidFill>
-                  <a:srgbClr val="5C5C5C"/>
-                </a:solidFill>
-                <a:latin typeface="Aptos"/>
-              </a:defRPr>
-            </a:pPr>
-            <a:r>
-              <a:t>Talking points, learner value, and lab connection</a:t>
-            </a:r>
-          </a:p>
-        </p:txBody>
-      </p:sp>
-      <p:sp>
-        <p:nvSpPr>
           <p:cNvPr id="5" name="Rounded Rectangle 4"/>
           <p:cNvSpPr/>
           <p:nvPr/>
@@ -9562,7 +9298,141 @@
               </a:defRPr>
             </a:pPr>
             <a:r>
-              <a:t>Talking points</a:t>
+              <a:t>Key ideas</a:t>
+            </a:r>
+            <a:br/>
+            <a:r>
+              <a:t>• Advanced Power BI starts with the model.</a:t>
+            </a:r>
+            <a:br/>
+            <a:r>
+              <a:t>• Poor models create slow reports, complex DAX, and inconsistent metrics.</a:t>
+            </a:r>
+          </a:p>
+        </p:txBody>
+      </p:sp>
+      <p:sp>
+        <p:nvSpPr>
+          <p:cNvPr id="8" name="Rounded Rectangle 7"/>
+          <p:cNvSpPr/>
+          <p:nvPr/>
+        </p:nvSpPr>
+        <p:spPr>
+          <a:xfrm>
+            <a:off x="6263640" y="1234440"/>
+            <a:ext cx="5303520" cy="1828800"/>
+          </a:xfrm>
+          <a:prstGeom prst="roundRect">
+            <a:avLst/>
+          </a:prstGeom>
+          <a:solidFill>
+            <a:srgbClr val="FFFFFF"/>
+          </a:solidFill>
+          <a:ln>
+            <a:solidFill>
+              <a:srgbClr val="DCDCDC"/>
+            </a:solidFill>
+          </a:ln>
+        </p:spPr>
+        <p:style>
+          <a:lnRef idx="1">
+            <a:schemeClr val="accent1"/>
+          </a:lnRef>
+          <a:fillRef idx="3">
+            <a:schemeClr val="accent1"/>
+          </a:fillRef>
+          <a:effectRef idx="2">
+            <a:schemeClr val="accent1"/>
+          </a:effectRef>
+          <a:fontRef idx="minor">
+            <a:schemeClr val="lt1"/>
+          </a:fontRef>
+        </p:style>
+        <p:txBody>
+          <a:bodyPr rtlCol="0" anchor="ctr"/>
+          <a:lstStyle/>
+          <a:p>
+            <a:pPr algn="ctr"/>
+            <a:endParaRPr/>
+          </a:p>
+        </p:txBody>
+      </p:sp>
+      <p:sp>
+        <p:nvSpPr>
+          <p:cNvPr id="9" name="Rectangle 8"/>
+          <p:cNvSpPr/>
+          <p:nvPr/>
+        </p:nvSpPr>
+        <p:spPr>
+          <a:xfrm>
+            <a:off x="6263640" y="1234440"/>
+            <a:ext cx="91440" cy="1828800"/>
+          </a:xfrm>
+          <a:prstGeom prst="rect">
+            <a:avLst/>
+          </a:prstGeom>
+          <a:solidFill>
+            <a:srgbClr val="02C39A"/>
+          </a:solidFill>
+          <a:ln>
+            <a:noFill/>
+          </a:ln>
+        </p:spPr>
+        <p:style>
+          <a:lnRef idx="1">
+            <a:schemeClr val="accent1"/>
+          </a:lnRef>
+          <a:fillRef idx="3">
+            <a:schemeClr val="accent1"/>
+          </a:fillRef>
+          <a:effectRef idx="2">
+            <a:schemeClr val="accent1"/>
+          </a:effectRef>
+          <a:fontRef idx="minor">
+            <a:schemeClr val="lt1"/>
+          </a:fontRef>
+        </p:style>
+        <p:txBody>
+          <a:bodyPr rtlCol="0" anchor="ctr"/>
+          <a:lstStyle/>
+          <a:p>
+            <a:pPr algn="ctr"/>
+            <a:endParaRPr/>
+          </a:p>
+        </p:txBody>
+      </p:sp>
+      <p:sp>
+        <p:nvSpPr>
+          <p:cNvPr id="10" name="TextBox 9"/>
+          <p:cNvSpPr txBox="1"/>
+          <p:nvPr/>
+        </p:nvSpPr>
+        <p:spPr>
+          <a:xfrm>
+            <a:off x="6446520" y="1344168"/>
+            <a:ext cx="4983480" cy="1664208"/>
+          </a:xfrm>
+          <a:prstGeom prst="rect">
+            <a:avLst/>
+          </a:prstGeom>
+          <a:noFill/>
+        </p:spPr>
+        <p:txBody>
+          <a:bodyPr wrap="square" lIns="0" rIns="0">
+            <a:spAutoFit/>
+          </a:bodyPr>
+          <a:lstStyle/>
+          <a:p>
+            <a:pPr>
+              <a:defRPr sz="1500" b="1">
+                <a:solidFill>
+                  <a:srgbClr val="1E2761"/>
+                </a:solidFill>
+                <a:latin typeface="Aptos Display"/>
+              </a:defRPr>
+            </a:pPr>
+            <a:r>
+              <a:t>Why it helps</a:t>
             </a:r>
           </a:p>
           <a:p>
@@ -9578,25 +9448,21 @@
               </a:defRPr>
             </a:pPr>
             <a:r>
-              <a:t>• Advanced Power BI starts with the model.</a:t>
-            </a:r>
-            <a:br/>
-            <a:r>
-              <a:t>• Poor models create slow reports, complex DAX, and inconsistent metrics.</a:t>
-            </a:r>
-          </a:p>
-        </p:txBody>
-      </p:sp>
-      <p:sp>
-        <p:nvSpPr>
-          <p:cNvPr id="8" name="Rounded Rectangle 7"/>
+              <a:t>• Enterprise models should be reusable, governed, and understandable.</a:t>
+            </a:r>
+          </a:p>
+        </p:txBody>
+      </p:sp>
+      <p:sp>
+        <p:nvSpPr>
+          <p:cNvPr id="11" name="Rounded Rectangle 10"/>
           <p:cNvSpPr/>
           <p:nvPr/>
         </p:nvSpPr>
         <p:spPr>
           <a:xfrm>
-            <a:off x="6263640" y="1234440"/>
-            <a:ext cx="5303520" cy="1828800"/>
+            <a:off x="822960" y="4160520"/>
+            <a:ext cx="10424160" cy="868680"/>
           </a:xfrm>
           <a:prstGeom prst="roundRect">
             <a:avLst/>
@@ -9635,20 +9501,20 @@
       </p:sp>
       <p:sp>
         <p:nvSpPr>
-          <p:cNvPr id="9" name="Rectangle 8"/>
+          <p:cNvPr id="12" name="Rectangle 11"/>
           <p:cNvSpPr/>
           <p:nvPr/>
         </p:nvSpPr>
         <p:spPr>
           <a:xfrm>
-            <a:off x="6263640" y="1234440"/>
-            <a:ext cx="91440" cy="1828800"/>
+            <a:off x="822960" y="4160520"/>
+            <a:ext cx="91440" cy="868680"/>
           </a:xfrm>
           <a:prstGeom prst="rect">
             <a:avLst/>
           </a:prstGeom>
           <a:solidFill>
-            <a:srgbClr val="02C39A"/>
+            <a:srgbClr val="F9B700"/>
           </a:solidFill>
           <a:ln>
             <a:noFill/>
@@ -9679,14 +9545,14 @@
       </p:sp>
       <p:sp>
         <p:nvSpPr>
-          <p:cNvPr id="10" name="TextBox 9"/>
+          <p:cNvPr id="13" name="TextBox 12"/>
           <p:cNvSpPr txBox="1"/>
           <p:nvPr/>
         </p:nvSpPr>
         <p:spPr>
           <a:xfrm>
-            <a:off x="6446520" y="1344168"/>
-            <a:ext cx="4983480" cy="1664208"/>
+            <a:off x="1005840" y="4270248"/>
+            <a:ext cx="10104120" cy="704088"/>
           </a:xfrm>
           <a:prstGeom prst="rect">
             <a:avLst/>
@@ -9708,165 +9574,7 @@
               </a:defRPr>
             </a:pPr>
             <a:r>
-              <a:t>Why it helps</a:t>
-            </a:r>
-          </a:p>
-          <a:p>
-            <a:pPr>
-              <a:spcBef>
-                <a:spcPts val="400"/>
-              </a:spcBef>
-              <a:defRPr sz="1050">
-                <a:solidFill>
-                  <a:srgbClr val="242424"/>
-                </a:solidFill>
-                <a:latin typeface="Aptos"/>
-              </a:defRPr>
-            </a:pPr>
-            <a:r>
-              <a:t>• Enterprise models should be reusable, governed, and understandable.</a:t>
-            </a:r>
-          </a:p>
-        </p:txBody>
-      </p:sp>
-      <p:sp>
-        <p:nvSpPr>
-          <p:cNvPr id="11" name="Rounded Rectangle 10"/>
-          <p:cNvSpPr/>
-          <p:nvPr/>
-        </p:nvSpPr>
-        <p:spPr>
-          <a:xfrm>
-            <a:off x="822960" y="4160520"/>
-            <a:ext cx="10424160" cy="868680"/>
-          </a:xfrm>
-          <a:prstGeom prst="roundRect">
-            <a:avLst/>
-          </a:prstGeom>
-          <a:solidFill>
-            <a:srgbClr val="FFFFFF"/>
-          </a:solidFill>
-          <a:ln>
-            <a:solidFill>
-              <a:srgbClr val="DCDCDC"/>
-            </a:solidFill>
-          </a:ln>
-        </p:spPr>
-        <p:style>
-          <a:lnRef idx="1">
-            <a:schemeClr val="accent1"/>
-          </a:lnRef>
-          <a:fillRef idx="3">
-            <a:schemeClr val="accent1"/>
-          </a:fillRef>
-          <a:effectRef idx="2">
-            <a:schemeClr val="accent1"/>
-          </a:effectRef>
-          <a:fontRef idx="minor">
-            <a:schemeClr val="lt1"/>
-          </a:fontRef>
-        </p:style>
-        <p:txBody>
-          <a:bodyPr rtlCol="0" anchor="ctr"/>
-          <a:lstStyle/>
-          <a:p>
-            <a:pPr algn="ctr"/>
-            <a:endParaRPr/>
-          </a:p>
-        </p:txBody>
-      </p:sp>
-      <p:sp>
-        <p:nvSpPr>
-          <p:cNvPr id="12" name="Rectangle 11"/>
-          <p:cNvSpPr/>
-          <p:nvPr/>
-        </p:nvSpPr>
-        <p:spPr>
-          <a:xfrm>
-            <a:off x="822960" y="4160520"/>
-            <a:ext cx="91440" cy="868680"/>
-          </a:xfrm>
-          <a:prstGeom prst="rect">
-            <a:avLst/>
-          </a:prstGeom>
-          <a:solidFill>
-            <a:srgbClr val="F9B700"/>
-          </a:solidFill>
-          <a:ln>
-            <a:noFill/>
-          </a:ln>
-        </p:spPr>
-        <p:style>
-          <a:lnRef idx="1">
-            <a:schemeClr val="accent1"/>
-          </a:lnRef>
-          <a:fillRef idx="3">
-            <a:schemeClr val="accent1"/>
-          </a:fillRef>
-          <a:effectRef idx="2">
-            <a:schemeClr val="accent1"/>
-          </a:effectRef>
-          <a:fontRef idx="minor">
-            <a:schemeClr val="lt1"/>
-          </a:fontRef>
-        </p:style>
-        <p:txBody>
-          <a:bodyPr rtlCol="0" anchor="ctr"/>
-          <a:lstStyle/>
-          <a:p>
-            <a:pPr algn="ctr"/>
-            <a:endParaRPr/>
-          </a:p>
-        </p:txBody>
-      </p:sp>
-      <p:sp>
-        <p:nvSpPr>
-          <p:cNvPr id="13" name="TextBox 12"/>
-          <p:cNvSpPr txBox="1"/>
-          <p:nvPr/>
-        </p:nvSpPr>
-        <p:spPr>
-          <a:xfrm>
-            <a:off x="1005840" y="4270248"/>
-            <a:ext cx="10104120" cy="704088"/>
-          </a:xfrm>
-          <a:prstGeom prst="rect">
-            <a:avLst/>
-          </a:prstGeom>
-          <a:noFill/>
-        </p:spPr>
-        <p:txBody>
-          <a:bodyPr wrap="square" lIns="0" rIns="0">
-            <a:spAutoFit/>
-          </a:bodyPr>
-          <a:lstStyle/>
-          <a:p>
-            <a:pPr>
-              <a:defRPr sz="1500" b="1">
-                <a:solidFill>
-                  <a:srgbClr val="1E2761"/>
-                </a:solidFill>
-                <a:latin typeface="Aptos Display"/>
-              </a:defRPr>
-            </a:pPr>
-            <a:r>
-              <a:t>Lab connection</a:t>
-            </a:r>
-          </a:p>
-          <a:p>
-            <a:pPr>
-              <a:spcBef>
-                <a:spcPts val="400"/>
-              </a:spcBef>
-              <a:defRPr sz="1050">
-                <a:solidFill>
-                  <a:srgbClr val="242424"/>
-                </a:solidFill>
-                <a:latin typeface="Aptos"/>
-              </a:defRPr>
-            </a:pPr>
-            <a:r>
-              <a:t>Coverage: Covered. Use the lab README to demonstrate or discuss this topic. Review terms: complex, governed, inconsistent, matters, reports.</a:t>
+              <a:t>In the lab, you will apply this pattern, validate the expected behavior, and discuss where it fits in a real Power BI solution.</a:t>
             </a:r>
           </a:p>
         </p:txBody>
@@ -10013,42 +9721,6 @@
       </p:sp>
       <p:sp>
         <p:nvSpPr>
-          <p:cNvPr id="4" name="TextBox 3"/>
-          <p:cNvSpPr txBox="1"/>
-          <p:nvPr/>
-        </p:nvSpPr>
-        <p:spPr>
-          <a:xfrm>
-            <a:off x="530352" y="914400"/>
-            <a:ext cx="10515600" cy="320040"/>
-          </a:xfrm>
-          <a:prstGeom prst="rect">
-            <a:avLst/>
-          </a:prstGeom>
-          <a:noFill/>
-        </p:spPr>
-        <p:txBody>
-          <a:bodyPr wrap="none">
-            <a:spAutoFit/>
-          </a:bodyPr>
-          <a:lstStyle/>
-          <a:p>
-            <a:pPr>
-              <a:defRPr sz="1200">
-                <a:solidFill>
-                  <a:srgbClr val="5C5C5C"/>
-                </a:solidFill>
-                <a:latin typeface="Aptos"/>
-              </a:defRPr>
-            </a:pPr>
-            <a:r>
-              <a:t>Talking points, learner value, and lab connection</a:t>
-            </a:r>
-          </a:p>
-        </p:txBody>
-      </p:sp>
-      <p:sp>
-        <p:nvSpPr>
           <p:cNvPr id="5" name="Rounded Rectangle 4"/>
           <p:cNvSpPr/>
           <p:nvPr/>
@@ -10168,7 +9840,141 @@
               </a:defRPr>
             </a:pPr>
             <a:r>
-              <a:t>Talking points</a:t>
+              <a:t>Key ideas</a:t>
+            </a:r>
+            <a:br/>
+            <a:r>
+              <a:t>• Reporting exports vs. analytical models</a:t>
+            </a:r>
+            <a:br/>
+            <a:r>
+              <a:t>• Repeated text attributes</a:t>
+            </a:r>
+          </a:p>
+        </p:txBody>
+      </p:sp>
+      <p:sp>
+        <p:nvSpPr>
+          <p:cNvPr id="8" name="Rounded Rectangle 7"/>
+          <p:cNvSpPr/>
+          <p:nvPr/>
+        </p:nvSpPr>
+        <p:spPr>
+          <a:xfrm>
+            <a:off x="6263640" y="1234440"/>
+            <a:ext cx="5303520" cy="1828800"/>
+          </a:xfrm>
+          <a:prstGeom prst="roundRect">
+            <a:avLst/>
+          </a:prstGeom>
+          <a:solidFill>
+            <a:srgbClr val="FFFFFF"/>
+          </a:solidFill>
+          <a:ln>
+            <a:solidFill>
+              <a:srgbClr val="DCDCDC"/>
+            </a:solidFill>
+          </a:ln>
+        </p:spPr>
+        <p:style>
+          <a:lnRef idx="1">
+            <a:schemeClr val="accent1"/>
+          </a:lnRef>
+          <a:fillRef idx="3">
+            <a:schemeClr val="accent1"/>
+          </a:fillRef>
+          <a:effectRef idx="2">
+            <a:schemeClr val="accent1"/>
+          </a:effectRef>
+          <a:fontRef idx="minor">
+            <a:schemeClr val="lt1"/>
+          </a:fontRef>
+        </p:style>
+        <p:txBody>
+          <a:bodyPr rtlCol="0" anchor="ctr"/>
+          <a:lstStyle/>
+          <a:p>
+            <a:pPr algn="ctr"/>
+            <a:endParaRPr/>
+          </a:p>
+        </p:txBody>
+      </p:sp>
+      <p:sp>
+        <p:nvSpPr>
+          <p:cNvPr id="9" name="Rectangle 8"/>
+          <p:cNvSpPr/>
+          <p:nvPr/>
+        </p:nvSpPr>
+        <p:spPr>
+          <a:xfrm>
+            <a:off x="6263640" y="1234440"/>
+            <a:ext cx="91440" cy="1828800"/>
+          </a:xfrm>
+          <a:prstGeom prst="rect">
+            <a:avLst/>
+          </a:prstGeom>
+          <a:solidFill>
+            <a:srgbClr val="02C39A"/>
+          </a:solidFill>
+          <a:ln>
+            <a:noFill/>
+          </a:ln>
+        </p:spPr>
+        <p:style>
+          <a:lnRef idx="1">
+            <a:schemeClr val="accent1"/>
+          </a:lnRef>
+          <a:fillRef idx="3">
+            <a:schemeClr val="accent1"/>
+          </a:fillRef>
+          <a:effectRef idx="2">
+            <a:schemeClr val="accent1"/>
+          </a:effectRef>
+          <a:fontRef idx="minor">
+            <a:schemeClr val="lt1"/>
+          </a:fontRef>
+        </p:style>
+        <p:txBody>
+          <a:bodyPr rtlCol="0" anchor="ctr"/>
+          <a:lstStyle/>
+          <a:p>
+            <a:pPr algn="ctr"/>
+            <a:endParaRPr/>
+          </a:p>
+        </p:txBody>
+      </p:sp>
+      <p:sp>
+        <p:nvSpPr>
+          <p:cNvPr id="10" name="TextBox 9"/>
+          <p:cNvSpPr txBox="1"/>
+          <p:nvPr/>
+        </p:nvSpPr>
+        <p:spPr>
+          <a:xfrm>
+            <a:off x="6446520" y="1344168"/>
+            <a:ext cx="4983480" cy="1664208"/>
+          </a:xfrm>
+          <a:prstGeom prst="rect">
+            <a:avLst/>
+          </a:prstGeom>
+          <a:noFill/>
+        </p:spPr>
+        <p:txBody>
+          <a:bodyPr wrap="square" lIns="0" rIns="0">
+            <a:spAutoFit/>
+          </a:bodyPr>
+          <a:lstStyle/>
+          <a:p>
+            <a:pPr>
+              <a:defRPr sz="1500" b="1">
+                <a:solidFill>
+                  <a:srgbClr val="1E2761"/>
+                </a:solidFill>
+                <a:latin typeface="Aptos Display"/>
+              </a:defRPr>
+            </a:pPr>
+            <a:r>
+              <a:t>Why it helps</a:t>
             </a:r>
           </a:p>
           <a:p>
@@ -10184,25 +9990,25 @@
               </a:defRPr>
             </a:pPr>
             <a:r>
-              <a:t>• Reporting exports vs. analytical models</a:t>
+              <a:t>• Hidden grain problems</a:t>
             </a:r>
             <a:br/>
             <a:r>
-              <a:t>• Repeated text attributes</a:t>
-            </a:r>
-          </a:p>
-        </p:txBody>
-      </p:sp>
-      <p:sp>
-        <p:nvSpPr>
-          <p:cNvPr id="8" name="Rounded Rectangle 7"/>
+              <a:t>• Fact and dimension separation</a:t>
+            </a:r>
+          </a:p>
+        </p:txBody>
+      </p:sp>
+      <p:sp>
+        <p:nvSpPr>
+          <p:cNvPr id="11" name="Rounded Rectangle 10"/>
           <p:cNvSpPr/>
           <p:nvPr/>
         </p:nvSpPr>
         <p:spPr>
           <a:xfrm>
-            <a:off x="6263640" y="1234440"/>
-            <a:ext cx="5303520" cy="1828800"/>
+            <a:off x="822960" y="4160520"/>
+            <a:ext cx="10424160" cy="868680"/>
           </a:xfrm>
           <a:prstGeom prst="roundRect">
             <a:avLst/>
@@ -10241,20 +10047,20 @@
       </p:sp>
       <p:sp>
         <p:nvSpPr>
-          <p:cNvPr id="9" name="Rectangle 8"/>
+          <p:cNvPr id="12" name="Rectangle 11"/>
           <p:cNvSpPr/>
           <p:nvPr/>
         </p:nvSpPr>
         <p:spPr>
           <a:xfrm>
-            <a:off x="6263640" y="1234440"/>
-            <a:ext cx="91440" cy="1828800"/>
+            <a:off x="822960" y="4160520"/>
+            <a:ext cx="91440" cy="868680"/>
           </a:xfrm>
           <a:prstGeom prst="rect">
             <a:avLst/>
           </a:prstGeom>
           <a:solidFill>
-            <a:srgbClr val="02C39A"/>
+            <a:srgbClr val="F9B700"/>
           </a:solidFill>
           <a:ln>
             <a:noFill/>
@@ -10285,14 +10091,14 @@
       </p:sp>
       <p:sp>
         <p:nvSpPr>
-          <p:cNvPr id="10" name="TextBox 9"/>
+          <p:cNvPr id="13" name="TextBox 12"/>
           <p:cNvSpPr txBox="1"/>
           <p:nvPr/>
         </p:nvSpPr>
         <p:spPr>
           <a:xfrm>
-            <a:off x="6446520" y="1344168"/>
-            <a:ext cx="4983480" cy="1664208"/>
+            <a:off x="1005840" y="4270248"/>
+            <a:ext cx="10104120" cy="704088"/>
           </a:xfrm>
           <a:prstGeom prst="rect">
             <a:avLst/>
@@ -10314,169 +10120,7 @@
               </a:defRPr>
             </a:pPr>
             <a:r>
-              <a:t>Why it helps</a:t>
-            </a:r>
-          </a:p>
-          <a:p>
-            <a:pPr>
-              <a:spcBef>
-                <a:spcPts val="400"/>
-              </a:spcBef>
-              <a:defRPr sz="1050">
-                <a:solidFill>
-                  <a:srgbClr val="242424"/>
-                </a:solidFill>
-                <a:latin typeface="Aptos"/>
-              </a:defRPr>
-            </a:pPr>
-            <a:r>
-              <a:t>• Hidden grain problems</a:t>
-            </a:r>
-            <a:br/>
-            <a:r>
-              <a:t>• Fact and dimension separation</a:t>
-            </a:r>
-          </a:p>
-        </p:txBody>
-      </p:sp>
-      <p:sp>
-        <p:nvSpPr>
-          <p:cNvPr id="11" name="Rounded Rectangle 10"/>
-          <p:cNvSpPr/>
-          <p:nvPr/>
-        </p:nvSpPr>
-        <p:spPr>
-          <a:xfrm>
-            <a:off x="822960" y="4160520"/>
-            <a:ext cx="10424160" cy="868680"/>
-          </a:xfrm>
-          <a:prstGeom prst="roundRect">
-            <a:avLst/>
-          </a:prstGeom>
-          <a:solidFill>
-            <a:srgbClr val="FFFFFF"/>
-          </a:solidFill>
-          <a:ln>
-            <a:solidFill>
-              <a:srgbClr val="DCDCDC"/>
-            </a:solidFill>
-          </a:ln>
-        </p:spPr>
-        <p:style>
-          <a:lnRef idx="1">
-            <a:schemeClr val="accent1"/>
-          </a:lnRef>
-          <a:fillRef idx="3">
-            <a:schemeClr val="accent1"/>
-          </a:fillRef>
-          <a:effectRef idx="2">
-            <a:schemeClr val="accent1"/>
-          </a:effectRef>
-          <a:fontRef idx="minor">
-            <a:schemeClr val="lt1"/>
-          </a:fontRef>
-        </p:style>
-        <p:txBody>
-          <a:bodyPr rtlCol="0" anchor="ctr"/>
-          <a:lstStyle/>
-          <a:p>
-            <a:pPr algn="ctr"/>
-            <a:endParaRPr/>
-          </a:p>
-        </p:txBody>
-      </p:sp>
-      <p:sp>
-        <p:nvSpPr>
-          <p:cNvPr id="12" name="Rectangle 11"/>
-          <p:cNvSpPr/>
-          <p:nvPr/>
-        </p:nvSpPr>
-        <p:spPr>
-          <a:xfrm>
-            <a:off x="822960" y="4160520"/>
-            <a:ext cx="91440" cy="868680"/>
-          </a:xfrm>
-          <a:prstGeom prst="rect">
-            <a:avLst/>
-          </a:prstGeom>
-          <a:solidFill>
-            <a:srgbClr val="F9B700"/>
-          </a:solidFill>
-          <a:ln>
-            <a:noFill/>
-          </a:ln>
-        </p:spPr>
-        <p:style>
-          <a:lnRef idx="1">
-            <a:schemeClr val="accent1"/>
-          </a:lnRef>
-          <a:fillRef idx="3">
-            <a:schemeClr val="accent1"/>
-          </a:fillRef>
-          <a:effectRef idx="2">
-            <a:schemeClr val="accent1"/>
-          </a:effectRef>
-          <a:fontRef idx="minor">
-            <a:schemeClr val="lt1"/>
-          </a:fontRef>
-        </p:style>
-        <p:txBody>
-          <a:bodyPr rtlCol="0" anchor="ctr"/>
-          <a:lstStyle/>
-          <a:p>
-            <a:pPr algn="ctr"/>
-            <a:endParaRPr/>
-          </a:p>
-        </p:txBody>
-      </p:sp>
-      <p:sp>
-        <p:nvSpPr>
-          <p:cNvPr id="13" name="TextBox 12"/>
-          <p:cNvSpPr txBox="1"/>
-          <p:nvPr/>
-        </p:nvSpPr>
-        <p:spPr>
-          <a:xfrm>
-            <a:off x="1005840" y="4270248"/>
-            <a:ext cx="10104120" cy="704088"/>
-          </a:xfrm>
-          <a:prstGeom prst="rect">
-            <a:avLst/>
-          </a:prstGeom>
-          <a:noFill/>
-        </p:spPr>
-        <p:txBody>
-          <a:bodyPr wrap="square" lIns="0" rIns="0">
-            <a:spAutoFit/>
-          </a:bodyPr>
-          <a:lstStyle/>
-          <a:p>
-            <a:pPr>
-              <a:defRPr sz="1500" b="1">
-                <a:solidFill>
-                  <a:srgbClr val="1E2761"/>
-                </a:solidFill>
-                <a:latin typeface="Aptos Display"/>
-              </a:defRPr>
-            </a:pPr>
-            <a:r>
-              <a:t>Lab connection</a:t>
-            </a:r>
-          </a:p>
-          <a:p>
-            <a:pPr>
-              <a:spcBef>
-                <a:spcPts val="400"/>
-              </a:spcBef>
-              <a:defRPr sz="1050">
-                <a:solidFill>
-                  <a:srgbClr val="242424"/>
-                </a:solidFill>
-                <a:latin typeface="Aptos"/>
-              </a:defRPr>
-            </a:pPr>
-            <a:r>
-              <a:t>Coverage: Partial. Use the lab README to demonstrate or discuss this topic. Review terms: analytical, exports, hidden, problems, repeated.</a:t>
+              <a:t>In the lab, you will apply this pattern, validate the expected behavior, and discuss where it fits in a real Power BI solution.</a:t>
             </a:r>
           </a:p>
         </p:txBody>
@@ -10623,42 +10267,6 @@
       </p:sp>
       <p:sp>
         <p:nvSpPr>
-          <p:cNvPr id="4" name="TextBox 3"/>
-          <p:cNvSpPr txBox="1"/>
-          <p:nvPr/>
-        </p:nvSpPr>
-        <p:spPr>
-          <a:xfrm>
-            <a:off x="530352" y="914400"/>
-            <a:ext cx="10515600" cy="320040"/>
-          </a:xfrm>
-          <a:prstGeom prst="rect">
-            <a:avLst/>
-          </a:prstGeom>
-          <a:noFill/>
-        </p:spPr>
-        <p:txBody>
-          <a:bodyPr wrap="none">
-            <a:spAutoFit/>
-          </a:bodyPr>
-          <a:lstStyle/>
-          <a:p>
-            <a:pPr>
-              <a:defRPr sz="1200">
-                <a:solidFill>
-                  <a:srgbClr val="5C5C5C"/>
-                </a:solidFill>
-                <a:latin typeface="Aptos"/>
-              </a:defRPr>
-            </a:pPr>
-            <a:r>
-              <a:t>Talking points, learner value, and lab connection</a:t>
-            </a:r>
-          </a:p>
-        </p:txBody>
-      </p:sp>
-      <p:sp>
-        <p:nvSpPr>
           <p:cNvPr id="5" name="Rounded Rectangle 4"/>
           <p:cNvSpPr/>
           <p:nvPr/>
@@ -10778,7 +10386,145 @@
               </a:defRPr>
             </a:pPr>
             <a:r>
-              <a:t>Talking points</a:t>
+              <a:t>Key ideas</a:t>
+            </a:r>
+            <a:br/>
+            <a:r>
+              <a:t>• Fact table grain</a:t>
+            </a:r>
+            <a:br/>
+            <a:r>
+              <a:t>• Dimension attributes</a:t>
+            </a:r>
+            <a:br/>
+            <a:r>
+              <a:t>• Surrogate/business keys</a:t>
+            </a:r>
+          </a:p>
+        </p:txBody>
+      </p:sp>
+      <p:sp>
+        <p:nvSpPr>
+          <p:cNvPr id="8" name="Rounded Rectangle 7"/>
+          <p:cNvSpPr/>
+          <p:nvPr/>
+        </p:nvSpPr>
+        <p:spPr>
+          <a:xfrm>
+            <a:off x="6263640" y="1234440"/>
+            <a:ext cx="5303520" cy="1828800"/>
+          </a:xfrm>
+          <a:prstGeom prst="roundRect">
+            <a:avLst/>
+          </a:prstGeom>
+          <a:solidFill>
+            <a:srgbClr val="FFFFFF"/>
+          </a:solidFill>
+          <a:ln>
+            <a:solidFill>
+              <a:srgbClr val="DCDCDC"/>
+            </a:solidFill>
+          </a:ln>
+        </p:spPr>
+        <p:style>
+          <a:lnRef idx="1">
+            <a:schemeClr val="accent1"/>
+          </a:lnRef>
+          <a:fillRef idx="3">
+            <a:schemeClr val="accent1"/>
+          </a:fillRef>
+          <a:effectRef idx="2">
+            <a:schemeClr val="accent1"/>
+          </a:effectRef>
+          <a:fontRef idx="minor">
+            <a:schemeClr val="lt1"/>
+          </a:fontRef>
+        </p:style>
+        <p:txBody>
+          <a:bodyPr rtlCol="0" anchor="ctr"/>
+          <a:lstStyle/>
+          <a:p>
+            <a:pPr algn="ctr"/>
+            <a:endParaRPr/>
+          </a:p>
+        </p:txBody>
+      </p:sp>
+      <p:sp>
+        <p:nvSpPr>
+          <p:cNvPr id="9" name="Rectangle 8"/>
+          <p:cNvSpPr/>
+          <p:nvPr/>
+        </p:nvSpPr>
+        <p:spPr>
+          <a:xfrm>
+            <a:off x="6263640" y="1234440"/>
+            <a:ext cx="91440" cy="1828800"/>
+          </a:xfrm>
+          <a:prstGeom prst="rect">
+            <a:avLst/>
+          </a:prstGeom>
+          <a:solidFill>
+            <a:srgbClr val="02C39A"/>
+          </a:solidFill>
+          <a:ln>
+            <a:noFill/>
+          </a:ln>
+        </p:spPr>
+        <p:style>
+          <a:lnRef idx="1">
+            <a:schemeClr val="accent1"/>
+          </a:lnRef>
+          <a:fillRef idx="3">
+            <a:schemeClr val="accent1"/>
+          </a:fillRef>
+          <a:effectRef idx="2">
+            <a:schemeClr val="accent1"/>
+          </a:effectRef>
+          <a:fontRef idx="minor">
+            <a:schemeClr val="lt1"/>
+          </a:fontRef>
+        </p:style>
+        <p:txBody>
+          <a:bodyPr rtlCol="0" anchor="ctr"/>
+          <a:lstStyle/>
+          <a:p>
+            <a:pPr algn="ctr"/>
+            <a:endParaRPr/>
+          </a:p>
+        </p:txBody>
+      </p:sp>
+      <p:sp>
+        <p:nvSpPr>
+          <p:cNvPr id="10" name="TextBox 9"/>
+          <p:cNvSpPr txBox="1"/>
+          <p:nvPr/>
+        </p:nvSpPr>
+        <p:spPr>
+          <a:xfrm>
+            <a:off x="6446520" y="1344168"/>
+            <a:ext cx="4983480" cy="1664208"/>
+          </a:xfrm>
+          <a:prstGeom prst="rect">
+            <a:avLst/>
+          </a:prstGeom>
+          <a:noFill/>
+        </p:spPr>
+        <p:txBody>
+          <a:bodyPr wrap="square" lIns="0" rIns="0">
+            <a:spAutoFit/>
+          </a:bodyPr>
+          <a:lstStyle/>
+          <a:p>
+            <a:pPr>
+              <a:defRPr sz="1500" b="1">
+                <a:solidFill>
+                  <a:srgbClr val="1E2761"/>
+                </a:solidFill>
+                <a:latin typeface="Aptos Display"/>
+              </a:defRPr>
+            </a:pPr>
+            <a:r>
+              <a:t>Why it helps</a:t>
             </a:r>
           </a:p>
           <a:p>
@@ -10794,29 +10540,25 @@
               </a:defRPr>
             </a:pPr>
             <a:r>
-              <a:t>• Fact table grain</a:t>
+              <a:t>• Conformed dimensions</a:t>
             </a:r>
             <a:br/>
             <a:r>
-              <a:t>• Dimension attributes</a:t>
-            </a:r>
-            <a:br/>
-            <a:r>
-              <a:t>• Surrogate/business keys</a:t>
-            </a:r>
-          </a:p>
-        </p:txBody>
-      </p:sp>
-      <p:sp>
-        <p:nvSpPr>
-          <p:cNvPr id="8" name="Rounded Rectangle 7"/>
+              <a:t>• Model readability</a:t>
+            </a:r>
+          </a:p>
+        </p:txBody>
+      </p:sp>
+      <p:sp>
+        <p:nvSpPr>
+          <p:cNvPr id="11" name="Rounded Rectangle 10"/>
           <p:cNvSpPr/>
           <p:nvPr/>
         </p:nvSpPr>
         <p:spPr>
           <a:xfrm>
-            <a:off x="6263640" y="1234440"/>
-            <a:ext cx="5303520" cy="1828800"/>
+            <a:off x="822960" y="4160520"/>
+            <a:ext cx="10424160" cy="868680"/>
           </a:xfrm>
           <a:prstGeom prst="roundRect">
             <a:avLst/>
@@ -10855,20 +10597,20 @@
       </p:sp>
       <p:sp>
         <p:nvSpPr>
-          <p:cNvPr id="9" name="Rectangle 8"/>
+          <p:cNvPr id="12" name="Rectangle 11"/>
           <p:cNvSpPr/>
           <p:nvPr/>
         </p:nvSpPr>
         <p:spPr>
           <a:xfrm>
-            <a:off x="6263640" y="1234440"/>
-            <a:ext cx="91440" cy="1828800"/>
+            <a:off x="822960" y="4160520"/>
+            <a:ext cx="91440" cy="868680"/>
           </a:xfrm>
           <a:prstGeom prst="rect">
             <a:avLst/>
           </a:prstGeom>
           <a:solidFill>
-            <a:srgbClr val="02C39A"/>
+            <a:srgbClr val="F9B700"/>
           </a:solidFill>
           <a:ln>
             <a:noFill/>
@@ -10899,14 +10641,14 @@
       </p:sp>
       <p:sp>
         <p:nvSpPr>
-          <p:cNvPr id="10" name="TextBox 9"/>
+          <p:cNvPr id="13" name="TextBox 12"/>
           <p:cNvSpPr txBox="1"/>
           <p:nvPr/>
         </p:nvSpPr>
         <p:spPr>
           <a:xfrm>
-            <a:off x="6446520" y="1344168"/>
-            <a:ext cx="4983480" cy="1664208"/>
+            <a:off x="1005840" y="4270248"/>
+            <a:ext cx="10104120" cy="704088"/>
           </a:xfrm>
           <a:prstGeom prst="rect">
             <a:avLst/>
@@ -10928,169 +10670,7 @@
               </a:defRPr>
             </a:pPr>
             <a:r>
-              <a:t>Why it helps</a:t>
-            </a:r>
-          </a:p>
-          <a:p>
-            <a:pPr>
-              <a:spcBef>
-                <a:spcPts val="400"/>
-              </a:spcBef>
-              <a:defRPr sz="1050">
-                <a:solidFill>
-                  <a:srgbClr val="242424"/>
-                </a:solidFill>
-                <a:latin typeface="Aptos"/>
-              </a:defRPr>
-            </a:pPr>
-            <a:r>
-              <a:t>• Conformed dimensions</a:t>
-            </a:r>
-            <a:br/>
-            <a:r>
-              <a:t>• Model readability</a:t>
-            </a:r>
-          </a:p>
-        </p:txBody>
-      </p:sp>
-      <p:sp>
-        <p:nvSpPr>
-          <p:cNvPr id="11" name="Rounded Rectangle 10"/>
-          <p:cNvSpPr/>
-          <p:nvPr/>
-        </p:nvSpPr>
-        <p:spPr>
-          <a:xfrm>
-            <a:off x="822960" y="4160520"/>
-            <a:ext cx="10424160" cy="868680"/>
-          </a:xfrm>
-          <a:prstGeom prst="roundRect">
-            <a:avLst/>
-          </a:prstGeom>
-          <a:solidFill>
-            <a:srgbClr val="FFFFFF"/>
-          </a:solidFill>
-          <a:ln>
-            <a:solidFill>
-              <a:srgbClr val="DCDCDC"/>
-            </a:solidFill>
-          </a:ln>
-        </p:spPr>
-        <p:style>
-          <a:lnRef idx="1">
-            <a:schemeClr val="accent1"/>
-          </a:lnRef>
-          <a:fillRef idx="3">
-            <a:schemeClr val="accent1"/>
-          </a:fillRef>
-          <a:effectRef idx="2">
-            <a:schemeClr val="accent1"/>
-          </a:effectRef>
-          <a:fontRef idx="minor">
-            <a:schemeClr val="lt1"/>
-          </a:fontRef>
-        </p:style>
-        <p:txBody>
-          <a:bodyPr rtlCol="0" anchor="ctr"/>
-          <a:lstStyle/>
-          <a:p>
-            <a:pPr algn="ctr"/>
-            <a:endParaRPr/>
-          </a:p>
-        </p:txBody>
-      </p:sp>
-      <p:sp>
-        <p:nvSpPr>
-          <p:cNvPr id="12" name="Rectangle 11"/>
-          <p:cNvSpPr/>
-          <p:nvPr/>
-        </p:nvSpPr>
-        <p:spPr>
-          <a:xfrm>
-            <a:off x="822960" y="4160520"/>
-            <a:ext cx="91440" cy="868680"/>
-          </a:xfrm>
-          <a:prstGeom prst="rect">
-            <a:avLst/>
-          </a:prstGeom>
-          <a:solidFill>
-            <a:srgbClr val="F9B700"/>
-          </a:solidFill>
-          <a:ln>
-            <a:noFill/>
-          </a:ln>
-        </p:spPr>
-        <p:style>
-          <a:lnRef idx="1">
-            <a:schemeClr val="accent1"/>
-          </a:lnRef>
-          <a:fillRef idx="3">
-            <a:schemeClr val="accent1"/>
-          </a:fillRef>
-          <a:effectRef idx="2">
-            <a:schemeClr val="accent1"/>
-          </a:effectRef>
-          <a:fontRef idx="minor">
-            <a:schemeClr val="lt1"/>
-          </a:fontRef>
-        </p:style>
-        <p:txBody>
-          <a:bodyPr rtlCol="0" anchor="ctr"/>
-          <a:lstStyle/>
-          <a:p>
-            <a:pPr algn="ctr"/>
-            <a:endParaRPr/>
-          </a:p>
-        </p:txBody>
-      </p:sp>
-      <p:sp>
-        <p:nvSpPr>
-          <p:cNvPr id="13" name="TextBox 12"/>
-          <p:cNvSpPr txBox="1"/>
-          <p:nvPr/>
-        </p:nvSpPr>
-        <p:spPr>
-          <a:xfrm>
-            <a:off x="1005840" y="4270248"/>
-            <a:ext cx="10104120" cy="704088"/>
-          </a:xfrm>
-          <a:prstGeom prst="rect">
-            <a:avLst/>
-          </a:prstGeom>
-          <a:noFill/>
-        </p:spPr>
-        <p:txBody>
-          <a:bodyPr wrap="square" lIns="0" rIns="0">
-            <a:spAutoFit/>
-          </a:bodyPr>
-          <a:lstStyle/>
-          <a:p>
-            <a:pPr>
-              <a:defRPr sz="1500" b="1">
-                <a:solidFill>
-                  <a:srgbClr val="1E2761"/>
-                </a:solidFill>
-                <a:latin typeface="Aptos Display"/>
-              </a:defRPr>
-            </a:pPr>
-            <a:r>
-              <a:t>Lab connection</a:t>
-            </a:r>
-          </a:p>
-          <a:p>
-            <a:pPr>
-              <a:spcBef>
-                <a:spcPts val="400"/>
-              </a:spcBef>
-              <a:defRPr sz="1050">
-                <a:solidFill>
-                  <a:srgbClr val="242424"/>
-                </a:solidFill>
-                <a:latin typeface="Aptos"/>
-              </a:defRPr>
-            </a:pPr>
-            <a:r>
-              <a:t>Coverage: Covered. Use the lab README to demonstrate or discuss this topic. Review terms: conformed, readability, surrogate.</a:t>
+              <a:t>In the lab, you will apply this pattern, validate the expected behavior, and discuss where it fits in a real Power BI solution.</a:t>
             </a:r>
           </a:p>
         </p:txBody>
@@ -11237,42 +10817,6 @@
       </p:sp>
       <p:sp>
         <p:nvSpPr>
-          <p:cNvPr id="4" name="TextBox 3"/>
-          <p:cNvSpPr txBox="1"/>
-          <p:nvPr/>
-        </p:nvSpPr>
-        <p:spPr>
-          <a:xfrm>
-            <a:off x="530352" y="914400"/>
-            <a:ext cx="10515600" cy="320040"/>
-          </a:xfrm>
-          <a:prstGeom prst="rect">
-            <a:avLst/>
-          </a:prstGeom>
-          <a:noFill/>
-        </p:spPr>
-        <p:txBody>
-          <a:bodyPr wrap="none">
-            <a:spAutoFit/>
-          </a:bodyPr>
-          <a:lstStyle/>
-          <a:p>
-            <a:pPr>
-              <a:defRPr sz="1200">
-                <a:solidFill>
-                  <a:srgbClr val="5C5C5C"/>
-                </a:solidFill>
-                <a:latin typeface="Aptos"/>
-              </a:defRPr>
-            </a:pPr>
-            <a:r>
-              <a:t>Talking points, learner value, and lab connection</a:t>
-            </a:r>
-          </a:p>
-        </p:txBody>
-      </p:sp>
-      <p:sp>
-        <p:nvSpPr>
           <p:cNvPr id="5" name="Rounded Rectangle 4"/>
           <p:cNvSpPr/>
           <p:nvPr/>
@@ -11392,7 +10936,145 @@
               </a:defRPr>
             </a:pPr>
             <a:r>
-              <a:t>Talking points</a:t>
+              <a:t>Key ideas</a:t>
+            </a:r>
+            <a:br/>
+            <a:r>
+              <a:t>• One-to-many relationships</a:t>
+            </a:r>
+            <a:br/>
+            <a:r>
+              <a:t>• Cardinality</a:t>
+            </a:r>
+            <a:br/>
+            <a:r>
+              <a:t>• Single-direction filtering</a:t>
+            </a:r>
+          </a:p>
+        </p:txBody>
+      </p:sp>
+      <p:sp>
+        <p:nvSpPr>
+          <p:cNvPr id="8" name="Rounded Rectangle 7"/>
+          <p:cNvSpPr/>
+          <p:nvPr/>
+        </p:nvSpPr>
+        <p:spPr>
+          <a:xfrm>
+            <a:off x="6263640" y="1234440"/>
+            <a:ext cx="5303520" cy="1828800"/>
+          </a:xfrm>
+          <a:prstGeom prst="roundRect">
+            <a:avLst/>
+          </a:prstGeom>
+          <a:solidFill>
+            <a:srgbClr val="FFFFFF"/>
+          </a:solidFill>
+          <a:ln>
+            <a:solidFill>
+              <a:srgbClr val="DCDCDC"/>
+            </a:solidFill>
+          </a:ln>
+        </p:spPr>
+        <p:style>
+          <a:lnRef idx="1">
+            <a:schemeClr val="accent1"/>
+          </a:lnRef>
+          <a:fillRef idx="3">
+            <a:schemeClr val="accent1"/>
+          </a:fillRef>
+          <a:effectRef idx="2">
+            <a:schemeClr val="accent1"/>
+          </a:effectRef>
+          <a:fontRef idx="minor">
+            <a:schemeClr val="lt1"/>
+          </a:fontRef>
+        </p:style>
+        <p:txBody>
+          <a:bodyPr rtlCol="0" anchor="ctr"/>
+          <a:lstStyle/>
+          <a:p>
+            <a:pPr algn="ctr"/>
+            <a:endParaRPr/>
+          </a:p>
+        </p:txBody>
+      </p:sp>
+      <p:sp>
+        <p:nvSpPr>
+          <p:cNvPr id="9" name="Rectangle 8"/>
+          <p:cNvSpPr/>
+          <p:nvPr/>
+        </p:nvSpPr>
+        <p:spPr>
+          <a:xfrm>
+            <a:off x="6263640" y="1234440"/>
+            <a:ext cx="91440" cy="1828800"/>
+          </a:xfrm>
+          <a:prstGeom prst="rect">
+            <a:avLst/>
+          </a:prstGeom>
+          <a:solidFill>
+            <a:srgbClr val="02C39A"/>
+          </a:solidFill>
+          <a:ln>
+            <a:noFill/>
+          </a:ln>
+        </p:spPr>
+        <p:style>
+          <a:lnRef idx="1">
+            <a:schemeClr val="accent1"/>
+          </a:lnRef>
+          <a:fillRef idx="3">
+            <a:schemeClr val="accent1"/>
+          </a:fillRef>
+          <a:effectRef idx="2">
+            <a:schemeClr val="accent1"/>
+          </a:effectRef>
+          <a:fontRef idx="minor">
+            <a:schemeClr val="lt1"/>
+          </a:fontRef>
+        </p:style>
+        <p:txBody>
+          <a:bodyPr rtlCol="0" anchor="ctr"/>
+          <a:lstStyle/>
+          <a:p>
+            <a:pPr algn="ctr"/>
+            <a:endParaRPr/>
+          </a:p>
+        </p:txBody>
+      </p:sp>
+      <p:sp>
+        <p:nvSpPr>
+          <p:cNvPr id="10" name="TextBox 9"/>
+          <p:cNvSpPr txBox="1"/>
+          <p:nvPr/>
+        </p:nvSpPr>
+        <p:spPr>
+          <a:xfrm>
+            <a:off x="6446520" y="1344168"/>
+            <a:ext cx="4983480" cy="1664208"/>
+          </a:xfrm>
+          <a:prstGeom prst="rect">
+            <a:avLst/>
+          </a:prstGeom>
+          <a:noFill/>
+        </p:spPr>
+        <p:txBody>
+          <a:bodyPr wrap="square" lIns="0" rIns="0">
+            <a:spAutoFit/>
+          </a:bodyPr>
+          <a:lstStyle/>
+          <a:p>
+            <a:pPr>
+              <a:defRPr sz="1500" b="1">
+                <a:solidFill>
+                  <a:srgbClr val="1E2761"/>
+                </a:solidFill>
+                <a:latin typeface="Aptos Display"/>
+              </a:defRPr>
+            </a:pPr>
+            <a:r>
+              <a:t>Why it helps</a:t>
             </a:r>
           </a:p>
           <a:p>
@@ -11408,29 +11090,25 @@
               </a:defRPr>
             </a:pPr>
             <a:r>
-              <a:t>• One-to-many relationships</a:t>
+              <a:t>• Ambiguity and bi-directional filters</a:t>
             </a:r>
             <a:br/>
             <a:r>
-              <a:t>• Cardinality</a:t>
-            </a:r>
-            <a:br/>
-            <a:r>
-              <a:t>• Single-direction filtering</a:t>
-            </a:r>
-          </a:p>
-        </p:txBody>
-      </p:sp>
-      <p:sp>
-        <p:nvSpPr>
-          <p:cNvPr id="8" name="Rounded Rectangle 7"/>
+              <a:t>• Many-to-many risks</a:t>
+            </a:r>
+          </a:p>
+        </p:txBody>
+      </p:sp>
+      <p:sp>
+        <p:nvSpPr>
+          <p:cNvPr id="11" name="Rounded Rectangle 10"/>
           <p:cNvSpPr/>
           <p:nvPr/>
         </p:nvSpPr>
         <p:spPr>
           <a:xfrm>
-            <a:off x="6263640" y="1234440"/>
-            <a:ext cx="5303520" cy="1828800"/>
+            <a:off x="822960" y="4160520"/>
+            <a:ext cx="10424160" cy="868680"/>
           </a:xfrm>
           <a:prstGeom prst="roundRect">
             <a:avLst/>
@@ -11469,20 +11147,20 @@
       </p:sp>
       <p:sp>
         <p:nvSpPr>
-          <p:cNvPr id="9" name="Rectangle 8"/>
+          <p:cNvPr id="12" name="Rectangle 11"/>
           <p:cNvSpPr/>
           <p:nvPr/>
         </p:nvSpPr>
         <p:spPr>
           <a:xfrm>
-            <a:off x="6263640" y="1234440"/>
-            <a:ext cx="91440" cy="1828800"/>
+            <a:off x="822960" y="4160520"/>
+            <a:ext cx="91440" cy="868680"/>
           </a:xfrm>
           <a:prstGeom prst="rect">
             <a:avLst/>
           </a:prstGeom>
           <a:solidFill>
-            <a:srgbClr val="02C39A"/>
+            <a:srgbClr val="F9B700"/>
           </a:solidFill>
           <a:ln>
             <a:noFill/>
@@ -11513,14 +11191,14 @@
       </p:sp>
       <p:sp>
         <p:nvSpPr>
-          <p:cNvPr id="10" name="TextBox 9"/>
+          <p:cNvPr id="13" name="TextBox 12"/>
           <p:cNvSpPr txBox="1"/>
           <p:nvPr/>
         </p:nvSpPr>
         <p:spPr>
           <a:xfrm>
-            <a:off x="6446520" y="1344168"/>
-            <a:ext cx="4983480" cy="1664208"/>
+            <a:off x="1005840" y="4270248"/>
+            <a:ext cx="10104120" cy="704088"/>
           </a:xfrm>
           <a:prstGeom prst="rect">
             <a:avLst/>
@@ -11542,169 +11220,7 @@
               </a:defRPr>
             </a:pPr>
             <a:r>
-              <a:t>Why it helps</a:t>
-            </a:r>
-          </a:p>
-          <a:p>
-            <a:pPr>
-              <a:spcBef>
-                <a:spcPts val="400"/>
-              </a:spcBef>
-              <a:defRPr sz="1050">
-                <a:solidFill>
-                  <a:srgbClr val="242424"/>
-                </a:solidFill>
-                <a:latin typeface="Aptos"/>
-              </a:defRPr>
-            </a:pPr>
-            <a:r>
-              <a:t>• Ambiguity and bi-directional filters</a:t>
-            </a:r>
-            <a:br/>
-            <a:r>
-              <a:t>• Many-to-many risks</a:t>
-            </a:r>
-          </a:p>
-        </p:txBody>
-      </p:sp>
-      <p:sp>
-        <p:nvSpPr>
-          <p:cNvPr id="11" name="Rounded Rectangle 10"/>
-          <p:cNvSpPr/>
-          <p:nvPr/>
-        </p:nvSpPr>
-        <p:spPr>
-          <a:xfrm>
-            <a:off x="822960" y="4160520"/>
-            <a:ext cx="10424160" cy="868680"/>
-          </a:xfrm>
-          <a:prstGeom prst="roundRect">
-            <a:avLst/>
-          </a:prstGeom>
-          <a:solidFill>
-            <a:srgbClr val="FFFFFF"/>
-          </a:solidFill>
-          <a:ln>
-            <a:solidFill>
-              <a:srgbClr val="DCDCDC"/>
-            </a:solidFill>
-          </a:ln>
-        </p:spPr>
-        <p:style>
-          <a:lnRef idx="1">
-            <a:schemeClr val="accent1"/>
-          </a:lnRef>
-          <a:fillRef idx="3">
-            <a:schemeClr val="accent1"/>
-          </a:fillRef>
-          <a:effectRef idx="2">
-            <a:schemeClr val="accent1"/>
-          </a:effectRef>
-          <a:fontRef idx="minor">
-            <a:schemeClr val="lt1"/>
-          </a:fontRef>
-        </p:style>
-        <p:txBody>
-          <a:bodyPr rtlCol="0" anchor="ctr"/>
-          <a:lstStyle/>
-          <a:p>
-            <a:pPr algn="ctr"/>
-            <a:endParaRPr/>
-          </a:p>
-        </p:txBody>
-      </p:sp>
-      <p:sp>
-        <p:nvSpPr>
-          <p:cNvPr id="12" name="Rectangle 11"/>
-          <p:cNvSpPr/>
-          <p:nvPr/>
-        </p:nvSpPr>
-        <p:spPr>
-          <a:xfrm>
-            <a:off x="822960" y="4160520"/>
-            <a:ext cx="91440" cy="868680"/>
-          </a:xfrm>
-          <a:prstGeom prst="rect">
-            <a:avLst/>
-          </a:prstGeom>
-          <a:solidFill>
-            <a:srgbClr val="F9B700"/>
-          </a:solidFill>
-          <a:ln>
-            <a:noFill/>
-          </a:ln>
-        </p:spPr>
-        <p:style>
-          <a:lnRef idx="1">
-            <a:schemeClr val="accent1"/>
-          </a:lnRef>
-          <a:fillRef idx="3">
-            <a:schemeClr val="accent1"/>
-          </a:fillRef>
-          <a:effectRef idx="2">
-            <a:schemeClr val="accent1"/>
-          </a:effectRef>
-          <a:fontRef idx="minor">
-            <a:schemeClr val="lt1"/>
-          </a:fontRef>
-        </p:style>
-        <p:txBody>
-          <a:bodyPr rtlCol="0" anchor="ctr"/>
-          <a:lstStyle/>
-          <a:p>
-            <a:pPr algn="ctr"/>
-            <a:endParaRPr/>
-          </a:p>
-        </p:txBody>
-      </p:sp>
-      <p:sp>
-        <p:nvSpPr>
-          <p:cNvPr id="13" name="TextBox 12"/>
-          <p:cNvSpPr txBox="1"/>
-          <p:nvPr/>
-        </p:nvSpPr>
-        <p:spPr>
-          <a:xfrm>
-            <a:off x="1005840" y="4270248"/>
-            <a:ext cx="10104120" cy="704088"/>
-          </a:xfrm>
-          <a:prstGeom prst="rect">
-            <a:avLst/>
-          </a:prstGeom>
-          <a:noFill/>
-        </p:spPr>
-        <p:txBody>
-          <a:bodyPr wrap="square" lIns="0" rIns="0">
-            <a:spAutoFit/>
-          </a:bodyPr>
-          <a:lstStyle/>
-          <a:p>
-            <a:pPr>
-              <a:defRPr sz="1500" b="1">
-                <a:solidFill>
-                  <a:srgbClr val="1E2761"/>
-                </a:solidFill>
-                <a:latin typeface="Aptos Display"/>
-              </a:defRPr>
-            </a:pPr>
-            <a:r>
-              <a:t>Lab connection</a:t>
-            </a:r>
-          </a:p>
-          <a:p>
-            <a:pPr>
-              <a:spcBef>
-                <a:spcPts val="400"/>
-              </a:spcBef>
-              <a:defRPr sz="1050">
-                <a:solidFill>
-                  <a:srgbClr val="242424"/>
-                </a:solidFill>
-                <a:latin typeface="Aptos"/>
-              </a:defRPr>
-            </a:pPr>
-            <a:r>
-              <a:t>Coverage: Covered. Use the lab README to demonstrate or discuss this topic. Review terms: risks.</a:t>
+              <a:t>In the lab, you will apply this pattern, validate the expected behavior, and discuss where it fits in a real Power BI solution.</a:t>
             </a:r>
           </a:p>
         </p:txBody>
@@ -11851,42 +11367,6 @@
       </p:sp>
       <p:sp>
         <p:nvSpPr>
-          <p:cNvPr id="4" name="TextBox 3"/>
-          <p:cNvSpPr txBox="1"/>
-          <p:nvPr/>
-        </p:nvSpPr>
-        <p:spPr>
-          <a:xfrm>
-            <a:off x="530352" y="914400"/>
-            <a:ext cx="10515600" cy="320040"/>
-          </a:xfrm>
-          <a:prstGeom prst="rect">
-            <a:avLst/>
-          </a:prstGeom>
-          <a:noFill/>
-        </p:spPr>
-        <p:txBody>
-          <a:bodyPr wrap="none">
-            <a:spAutoFit/>
-          </a:bodyPr>
-          <a:lstStyle/>
-          <a:p>
-            <a:pPr>
-              <a:defRPr sz="1200">
-                <a:solidFill>
-                  <a:srgbClr val="5C5C5C"/>
-                </a:solidFill>
-                <a:latin typeface="Aptos"/>
-              </a:defRPr>
-            </a:pPr>
-            <a:r>
-              <a:t>Talking points, learner value, and lab connection</a:t>
-            </a:r>
-          </a:p>
-        </p:txBody>
-      </p:sp>
-      <p:sp>
-        <p:nvSpPr>
           <p:cNvPr id="5" name="Rounded Rectangle 4"/>
           <p:cNvSpPr/>
           <p:nvPr/>
@@ -12006,7 +11486,141 @@
               </a:defRPr>
             </a:pPr>
             <a:r>
-              <a:t>Talking points</a:t>
+              <a:t>Key ideas</a:t>
+            </a:r>
+            <a:br/>
+            <a:r>
+              <a:t>• Order date, ship date, invoice date</a:t>
+            </a:r>
+            <a:br/>
+            <a:r>
+              <a:t>• Duplicated dimensions vs. inactive relationships</a:t>
+            </a:r>
+          </a:p>
+        </p:txBody>
+      </p:sp>
+      <p:sp>
+        <p:nvSpPr>
+          <p:cNvPr id="8" name="Rounded Rectangle 7"/>
+          <p:cNvSpPr/>
+          <p:nvPr/>
+        </p:nvSpPr>
+        <p:spPr>
+          <a:xfrm>
+            <a:off x="6263640" y="1234440"/>
+            <a:ext cx="5303520" cy="1828800"/>
+          </a:xfrm>
+          <a:prstGeom prst="roundRect">
+            <a:avLst/>
+          </a:prstGeom>
+          <a:solidFill>
+            <a:srgbClr val="FFFFFF"/>
+          </a:solidFill>
+          <a:ln>
+            <a:solidFill>
+              <a:srgbClr val="DCDCDC"/>
+            </a:solidFill>
+          </a:ln>
+        </p:spPr>
+        <p:style>
+          <a:lnRef idx="1">
+            <a:schemeClr val="accent1"/>
+          </a:lnRef>
+          <a:fillRef idx="3">
+            <a:schemeClr val="accent1"/>
+          </a:fillRef>
+          <a:effectRef idx="2">
+            <a:schemeClr val="accent1"/>
+          </a:effectRef>
+          <a:fontRef idx="minor">
+            <a:schemeClr val="lt1"/>
+          </a:fontRef>
+        </p:style>
+        <p:txBody>
+          <a:bodyPr rtlCol="0" anchor="ctr"/>
+          <a:lstStyle/>
+          <a:p>
+            <a:pPr algn="ctr"/>
+            <a:endParaRPr/>
+          </a:p>
+        </p:txBody>
+      </p:sp>
+      <p:sp>
+        <p:nvSpPr>
+          <p:cNvPr id="9" name="Rectangle 8"/>
+          <p:cNvSpPr/>
+          <p:nvPr/>
+        </p:nvSpPr>
+        <p:spPr>
+          <a:xfrm>
+            <a:off x="6263640" y="1234440"/>
+            <a:ext cx="91440" cy="1828800"/>
+          </a:xfrm>
+          <a:prstGeom prst="rect">
+            <a:avLst/>
+          </a:prstGeom>
+          <a:solidFill>
+            <a:srgbClr val="02C39A"/>
+          </a:solidFill>
+          <a:ln>
+            <a:noFill/>
+          </a:ln>
+        </p:spPr>
+        <p:style>
+          <a:lnRef idx="1">
+            <a:schemeClr val="accent1"/>
+          </a:lnRef>
+          <a:fillRef idx="3">
+            <a:schemeClr val="accent1"/>
+          </a:fillRef>
+          <a:effectRef idx="2">
+            <a:schemeClr val="accent1"/>
+          </a:effectRef>
+          <a:fontRef idx="minor">
+            <a:schemeClr val="lt1"/>
+          </a:fontRef>
+        </p:style>
+        <p:txBody>
+          <a:bodyPr rtlCol="0" anchor="ctr"/>
+          <a:lstStyle/>
+          <a:p>
+            <a:pPr algn="ctr"/>
+            <a:endParaRPr/>
+          </a:p>
+        </p:txBody>
+      </p:sp>
+      <p:sp>
+        <p:nvSpPr>
+          <p:cNvPr id="10" name="TextBox 9"/>
+          <p:cNvSpPr txBox="1"/>
+          <p:nvPr/>
+        </p:nvSpPr>
+        <p:spPr>
+          <a:xfrm>
+            <a:off x="6446520" y="1344168"/>
+            <a:ext cx="4983480" cy="1664208"/>
+          </a:xfrm>
+          <a:prstGeom prst="rect">
+            <a:avLst/>
+          </a:prstGeom>
+          <a:noFill/>
+        </p:spPr>
+        <p:txBody>
+          <a:bodyPr wrap="square" lIns="0" rIns="0">
+            <a:spAutoFit/>
+          </a:bodyPr>
+          <a:lstStyle/>
+          <a:p>
+            <a:pPr>
+              <a:defRPr sz="1500" b="1">
+                <a:solidFill>
+                  <a:srgbClr val="1E2761"/>
+                </a:solidFill>
+                <a:latin typeface="Aptos Display"/>
+              </a:defRPr>
+            </a:pPr>
+            <a:r>
+              <a:t>Why it helps</a:t>
             </a:r>
           </a:p>
           <a:p>
@@ -12022,25 +11636,21 @@
               </a:defRPr>
             </a:pPr>
             <a:r>
-              <a:t>• Order date, ship date, invoice date</a:t>
-            </a:r>
-            <a:br/>
-            <a:r>
-              <a:t>• Duplicated dimensions vs. inactive relationships</a:t>
-            </a:r>
-          </a:p>
-        </p:txBody>
-      </p:sp>
-      <p:sp>
-        <p:nvSpPr>
-          <p:cNvPr id="8" name="Rounded Rectangle 7"/>
+              <a:t>• `USERELATIONSHIP` pattern overview</a:t>
+            </a:r>
+          </a:p>
+        </p:txBody>
+      </p:sp>
+      <p:sp>
+        <p:nvSpPr>
+          <p:cNvPr id="11" name="Rounded Rectangle 10"/>
           <p:cNvSpPr/>
           <p:nvPr/>
         </p:nvSpPr>
         <p:spPr>
           <a:xfrm>
-            <a:off x="6263640" y="1234440"/>
-            <a:ext cx="5303520" cy="1828800"/>
+            <a:off x="822960" y="4160520"/>
+            <a:ext cx="10424160" cy="868680"/>
           </a:xfrm>
           <a:prstGeom prst="roundRect">
             <a:avLst/>
@@ -12079,20 +11689,20 @@
       </p:sp>
       <p:sp>
         <p:nvSpPr>
-          <p:cNvPr id="9" name="Rectangle 8"/>
+          <p:cNvPr id="12" name="Rectangle 11"/>
           <p:cNvSpPr/>
           <p:nvPr/>
         </p:nvSpPr>
         <p:spPr>
           <a:xfrm>
-            <a:off x="6263640" y="1234440"/>
-            <a:ext cx="91440" cy="1828800"/>
+            <a:off x="822960" y="4160520"/>
+            <a:ext cx="91440" cy="868680"/>
           </a:xfrm>
           <a:prstGeom prst="rect">
             <a:avLst/>
           </a:prstGeom>
           <a:solidFill>
-            <a:srgbClr val="02C39A"/>
+            <a:srgbClr val="F9B700"/>
           </a:solidFill>
           <a:ln>
             <a:noFill/>
@@ -12123,14 +11733,14 @@
       </p:sp>
       <p:sp>
         <p:nvSpPr>
-          <p:cNvPr id="10" name="TextBox 9"/>
+          <p:cNvPr id="13" name="TextBox 12"/>
           <p:cNvSpPr txBox="1"/>
           <p:nvPr/>
         </p:nvSpPr>
         <p:spPr>
           <a:xfrm>
-            <a:off x="6446520" y="1344168"/>
-            <a:ext cx="4983480" cy="1664208"/>
+            <a:off x="1005840" y="4270248"/>
+            <a:ext cx="10104120" cy="704088"/>
           </a:xfrm>
           <a:prstGeom prst="rect">
             <a:avLst/>
@@ -12152,165 +11762,7 @@
               </a:defRPr>
             </a:pPr>
             <a:r>
-              <a:t>Why it helps</a:t>
-            </a:r>
-          </a:p>
-          <a:p>
-            <a:pPr>
-              <a:spcBef>
-                <a:spcPts val="400"/>
-              </a:spcBef>
-              <a:defRPr sz="1050">
-                <a:solidFill>
-                  <a:srgbClr val="242424"/>
-                </a:solidFill>
-                <a:latin typeface="Aptos"/>
-              </a:defRPr>
-            </a:pPr>
-            <a:r>
-              <a:t>• `USERELATIONSHIP` pattern overview</a:t>
-            </a:r>
-          </a:p>
-        </p:txBody>
-      </p:sp>
-      <p:sp>
-        <p:nvSpPr>
-          <p:cNvPr id="11" name="Rounded Rectangle 10"/>
-          <p:cNvSpPr/>
-          <p:nvPr/>
-        </p:nvSpPr>
-        <p:spPr>
-          <a:xfrm>
-            <a:off x="822960" y="4160520"/>
-            <a:ext cx="10424160" cy="868680"/>
-          </a:xfrm>
-          <a:prstGeom prst="roundRect">
-            <a:avLst/>
-          </a:prstGeom>
-          <a:solidFill>
-            <a:srgbClr val="FFFFFF"/>
-          </a:solidFill>
-          <a:ln>
-            <a:solidFill>
-              <a:srgbClr val="DCDCDC"/>
-            </a:solidFill>
-          </a:ln>
-        </p:spPr>
-        <p:style>
-          <a:lnRef idx="1">
-            <a:schemeClr val="accent1"/>
-          </a:lnRef>
-          <a:fillRef idx="3">
-            <a:schemeClr val="accent1"/>
-          </a:fillRef>
-          <a:effectRef idx="2">
-            <a:schemeClr val="accent1"/>
-          </a:effectRef>
-          <a:fontRef idx="minor">
-            <a:schemeClr val="lt1"/>
-          </a:fontRef>
-        </p:style>
-        <p:txBody>
-          <a:bodyPr rtlCol="0" anchor="ctr"/>
-          <a:lstStyle/>
-          <a:p>
-            <a:pPr algn="ctr"/>
-            <a:endParaRPr/>
-          </a:p>
-        </p:txBody>
-      </p:sp>
-      <p:sp>
-        <p:nvSpPr>
-          <p:cNvPr id="12" name="Rectangle 11"/>
-          <p:cNvSpPr/>
-          <p:nvPr/>
-        </p:nvSpPr>
-        <p:spPr>
-          <a:xfrm>
-            <a:off x="822960" y="4160520"/>
-            <a:ext cx="91440" cy="868680"/>
-          </a:xfrm>
-          <a:prstGeom prst="rect">
-            <a:avLst/>
-          </a:prstGeom>
-          <a:solidFill>
-            <a:srgbClr val="F9B700"/>
-          </a:solidFill>
-          <a:ln>
-            <a:noFill/>
-          </a:ln>
-        </p:spPr>
-        <p:style>
-          <a:lnRef idx="1">
-            <a:schemeClr val="accent1"/>
-          </a:lnRef>
-          <a:fillRef idx="3">
-            <a:schemeClr val="accent1"/>
-          </a:fillRef>
-          <a:effectRef idx="2">
-            <a:schemeClr val="accent1"/>
-          </a:effectRef>
-          <a:fontRef idx="minor">
-            <a:schemeClr val="lt1"/>
-          </a:fontRef>
-        </p:style>
-        <p:txBody>
-          <a:bodyPr rtlCol="0" anchor="ctr"/>
-          <a:lstStyle/>
-          <a:p>
-            <a:pPr algn="ctr"/>
-            <a:endParaRPr/>
-          </a:p>
-        </p:txBody>
-      </p:sp>
-      <p:sp>
-        <p:nvSpPr>
-          <p:cNvPr id="13" name="TextBox 12"/>
-          <p:cNvSpPr txBox="1"/>
-          <p:nvPr/>
-        </p:nvSpPr>
-        <p:spPr>
-          <a:xfrm>
-            <a:off x="1005840" y="4270248"/>
-            <a:ext cx="10104120" cy="704088"/>
-          </a:xfrm>
-          <a:prstGeom prst="rect">
-            <a:avLst/>
-          </a:prstGeom>
-          <a:noFill/>
-        </p:spPr>
-        <p:txBody>
-          <a:bodyPr wrap="square" lIns="0" rIns="0">
-            <a:spAutoFit/>
-          </a:bodyPr>
-          <a:lstStyle/>
-          <a:p>
-            <a:pPr>
-              <a:defRPr sz="1500" b="1">
-                <a:solidFill>
-                  <a:srgbClr val="1E2761"/>
-                </a:solidFill>
-                <a:latin typeface="Aptos Display"/>
-              </a:defRPr>
-            </a:pPr>
-            <a:r>
-              <a:t>Lab connection</a:t>
-            </a:r>
-          </a:p>
-          <a:p>
-            <a:pPr>
-              <a:spcBef>
-                <a:spcPts val="400"/>
-              </a:spcBef>
-              <a:defRPr sz="1050">
-                <a:solidFill>
-                  <a:srgbClr val="242424"/>
-                </a:solidFill>
-                <a:latin typeface="Aptos"/>
-              </a:defRPr>
-            </a:pPr>
-            <a:r>
-              <a:t>Coverage: Covered. Use the lab README to demonstrate or discuss this topic. Review terms: duplicated, inactive, overview, userelationship.</a:t>
+              <a:t>In the lab, you will apply this pattern, validate the expected behavior, and discuss where it fits in a real Power BI solution.</a:t>
             </a:r>
           </a:p>
         </p:txBody>
@@ -12457,42 +11909,6 @@
       </p:sp>
       <p:sp>
         <p:nvSpPr>
-          <p:cNvPr id="4" name="TextBox 3"/>
-          <p:cNvSpPr txBox="1"/>
-          <p:nvPr/>
-        </p:nvSpPr>
-        <p:spPr>
-          <a:xfrm>
-            <a:off x="530352" y="914400"/>
-            <a:ext cx="10515600" cy="320040"/>
-          </a:xfrm>
-          <a:prstGeom prst="rect">
-            <a:avLst/>
-          </a:prstGeom>
-          <a:noFill/>
-        </p:spPr>
-        <p:txBody>
-          <a:bodyPr wrap="none">
-            <a:spAutoFit/>
-          </a:bodyPr>
-          <a:lstStyle/>
-          <a:p>
-            <a:pPr>
-              <a:defRPr sz="1200">
-                <a:solidFill>
-                  <a:srgbClr val="5C5C5C"/>
-                </a:solidFill>
-                <a:latin typeface="Aptos"/>
-              </a:defRPr>
-            </a:pPr>
-            <a:r>
-              <a:t>Talking points, learner value, and lab connection</a:t>
-            </a:r>
-          </a:p>
-        </p:txBody>
-      </p:sp>
-      <p:sp>
-        <p:nvSpPr>
           <p:cNvPr id="5" name="Rounded Rectangle 4"/>
           <p:cNvSpPr/>
           <p:nvPr/>
@@ -12612,7 +12028,141 @@
               </a:defRPr>
             </a:pPr>
             <a:r>
-              <a:t>Talking points</a:t>
+              <a:t>Key ideas</a:t>
+            </a:r>
+            <a:br/>
+            <a:r>
+              <a:t>• Multi-valued attributes</a:t>
+            </a:r>
+            <a:br/>
+            <a:r>
+              <a:t>• Customer-to-segment example</a:t>
+            </a:r>
+          </a:p>
+        </p:txBody>
+      </p:sp>
+      <p:sp>
+        <p:nvSpPr>
+          <p:cNvPr id="8" name="Rounded Rectangle 7"/>
+          <p:cNvSpPr/>
+          <p:nvPr/>
+        </p:nvSpPr>
+        <p:spPr>
+          <a:xfrm>
+            <a:off x="6263640" y="1234440"/>
+            <a:ext cx="5303520" cy="1828800"/>
+          </a:xfrm>
+          <a:prstGeom prst="roundRect">
+            <a:avLst/>
+          </a:prstGeom>
+          <a:solidFill>
+            <a:srgbClr val="FFFFFF"/>
+          </a:solidFill>
+          <a:ln>
+            <a:solidFill>
+              <a:srgbClr val="DCDCDC"/>
+            </a:solidFill>
+          </a:ln>
+        </p:spPr>
+        <p:style>
+          <a:lnRef idx="1">
+            <a:schemeClr val="accent1"/>
+          </a:lnRef>
+          <a:fillRef idx="3">
+            <a:schemeClr val="accent1"/>
+          </a:fillRef>
+          <a:effectRef idx="2">
+            <a:schemeClr val="accent1"/>
+          </a:effectRef>
+          <a:fontRef idx="minor">
+            <a:schemeClr val="lt1"/>
+          </a:fontRef>
+        </p:style>
+        <p:txBody>
+          <a:bodyPr rtlCol="0" anchor="ctr"/>
+          <a:lstStyle/>
+          <a:p>
+            <a:pPr algn="ctr"/>
+            <a:endParaRPr/>
+          </a:p>
+        </p:txBody>
+      </p:sp>
+      <p:sp>
+        <p:nvSpPr>
+          <p:cNvPr id="9" name="Rectangle 8"/>
+          <p:cNvSpPr/>
+          <p:nvPr/>
+        </p:nvSpPr>
+        <p:spPr>
+          <a:xfrm>
+            <a:off x="6263640" y="1234440"/>
+            <a:ext cx="91440" cy="1828800"/>
+          </a:xfrm>
+          <a:prstGeom prst="rect">
+            <a:avLst/>
+          </a:prstGeom>
+          <a:solidFill>
+            <a:srgbClr val="02C39A"/>
+          </a:solidFill>
+          <a:ln>
+            <a:noFill/>
+          </a:ln>
+        </p:spPr>
+        <p:style>
+          <a:lnRef idx="1">
+            <a:schemeClr val="accent1"/>
+          </a:lnRef>
+          <a:fillRef idx="3">
+            <a:schemeClr val="accent1"/>
+          </a:fillRef>
+          <a:effectRef idx="2">
+            <a:schemeClr val="accent1"/>
+          </a:effectRef>
+          <a:fontRef idx="minor">
+            <a:schemeClr val="lt1"/>
+          </a:fontRef>
+        </p:style>
+        <p:txBody>
+          <a:bodyPr rtlCol="0" anchor="ctr"/>
+          <a:lstStyle/>
+          <a:p>
+            <a:pPr algn="ctr"/>
+            <a:endParaRPr/>
+          </a:p>
+        </p:txBody>
+      </p:sp>
+      <p:sp>
+        <p:nvSpPr>
+          <p:cNvPr id="10" name="TextBox 9"/>
+          <p:cNvSpPr txBox="1"/>
+          <p:nvPr/>
+        </p:nvSpPr>
+        <p:spPr>
+          <a:xfrm>
+            <a:off x="6446520" y="1344168"/>
+            <a:ext cx="4983480" cy="1664208"/>
+          </a:xfrm>
+          <a:prstGeom prst="rect">
+            <a:avLst/>
+          </a:prstGeom>
+          <a:noFill/>
+        </p:spPr>
+        <p:txBody>
+          <a:bodyPr wrap="square" lIns="0" rIns="0">
+            <a:spAutoFit/>
+          </a:bodyPr>
+          <a:lstStyle/>
+          <a:p>
+            <a:pPr>
+              <a:defRPr sz="1500" b="1">
+                <a:solidFill>
+                  <a:srgbClr val="1E2761"/>
+                </a:solidFill>
+                <a:latin typeface="Aptos Display"/>
+              </a:defRPr>
+            </a:pPr>
+            <a:r>
+              <a:t>Why it helps</a:t>
             </a:r>
           </a:p>
           <a:p>
@@ -12628,25 +12178,25 @@
               </a:defRPr>
             </a:pPr>
             <a:r>
-              <a:t>• Multi-valued attributes</a:t>
+              <a:t>• Bridge table grain</a:t>
             </a:r>
             <a:br/>
             <a:r>
-              <a:t>• Customer-to-segment example</a:t>
-            </a:r>
-          </a:p>
-        </p:txBody>
-      </p:sp>
-      <p:sp>
-        <p:nvSpPr>
-          <p:cNvPr id="8" name="Rounded Rectangle 7"/>
+              <a:t>• Filter direction considerations</a:t>
+            </a:r>
+          </a:p>
+        </p:txBody>
+      </p:sp>
+      <p:sp>
+        <p:nvSpPr>
+          <p:cNvPr id="11" name="Rounded Rectangle 10"/>
           <p:cNvSpPr/>
           <p:nvPr/>
         </p:nvSpPr>
         <p:spPr>
           <a:xfrm>
-            <a:off x="6263640" y="1234440"/>
-            <a:ext cx="5303520" cy="1828800"/>
+            <a:off x="822960" y="4160520"/>
+            <a:ext cx="10424160" cy="868680"/>
           </a:xfrm>
           <a:prstGeom prst="roundRect">
             <a:avLst/>
@@ -12685,20 +12235,20 @@
       </p:sp>
       <p:sp>
         <p:nvSpPr>
-          <p:cNvPr id="9" name="Rectangle 8"/>
+          <p:cNvPr id="12" name="Rectangle 11"/>
           <p:cNvSpPr/>
           <p:nvPr/>
         </p:nvSpPr>
         <p:spPr>
           <a:xfrm>
-            <a:off x="6263640" y="1234440"/>
-            <a:ext cx="91440" cy="1828800"/>
+            <a:off x="822960" y="4160520"/>
+            <a:ext cx="91440" cy="868680"/>
           </a:xfrm>
           <a:prstGeom prst="rect">
             <a:avLst/>
           </a:prstGeom>
           <a:solidFill>
-            <a:srgbClr val="02C39A"/>
+            <a:srgbClr val="F9B700"/>
           </a:solidFill>
           <a:ln>
             <a:noFill/>
@@ -12729,14 +12279,14 @@
       </p:sp>
       <p:sp>
         <p:nvSpPr>
-          <p:cNvPr id="10" name="TextBox 9"/>
+          <p:cNvPr id="13" name="TextBox 12"/>
           <p:cNvSpPr txBox="1"/>
           <p:nvPr/>
         </p:nvSpPr>
         <p:spPr>
           <a:xfrm>
-            <a:off x="6446520" y="1344168"/>
-            <a:ext cx="4983480" cy="1664208"/>
+            <a:off x="1005840" y="4270248"/>
+            <a:ext cx="10104120" cy="704088"/>
           </a:xfrm>
           <a:prstGeom prst="rect">
             <a:avLst/>
@@ -12758,169 +12308,7 @@
               </a:defRPr>
             </a:pPr>
             <a:r>
-              <a:t>Why it helps</a:t>
-            </a:r>
-          </a:p>
-          <a:p>
-            <a:pPr>
-              <a:spcBef>
-                <a:spcPts val="400"/>
-              </a:spcBef>
-              <a:defRPr sz="1050">
-                <a:solidFill>
-                  <a:srgbClr val="242424"/>
-                </a:solidFill>
-                <a:latin typeface="Aptos"/>
-              </a:defRPr>
-            </a:pPr>
-            <a:r>
-              <a:t>• Bridge table grain</a:t>
-            </a:r>
-            <a:br/>
-            <a:r>
-              <a:t>• Filter direction considerations</a:t>
-            </a:r>
-          </a:p>
-        </p:txBody>
-      </p:sp>
-      <p:sp>
-        <p:nvSpPr>
-          <p:cNvPr id="11" name="Rounded Rectangle 10"/>
-          <p:cNvSpPr/>
-          <p:nvPr/>
-        </p:nvSpPr>
-        <p:spPr>
-          <a:xfrm>
-            <a:off x="822960" y="4160520"/>
-            <a:ext cx="10424160" cy="868680"/>
-          </a:xfrm>
-          <a:prstGeom prst="roundRect">
-            <a:avLst/>
-          </a:prstGeom>
-          <a:solidFill>
-            <a:srgbClr val="FFFFFF"/>
-          </a:solidFill>
-          <a:ln>
-            <a:solidFill>
-              <a:srgbClr val="DCDCDC"/>
-            </a:solidFill>
-          </a:ln>
-        </p:spPr>
-        <p:style>
-          <a:lnRef idx="1">
-            <a:schemeClr val="accent1"/>
-          </a:lnRef>
-          <a:fillRef idx="3">
-            <a:schemeClr val="accent1"/>
-          </a:fillRef>
-          <a:effectRef idx="2">
-            <a:schemeClr val="accent1"/>
-          </a:effectRef>
-          <a:fontRef idx="minor">
-            <a:schemeClr val="lt1"/>
-          </a:fontRef>
-        </p:style>
-        <p:txBody>
-          <a:bodyPr rtlCol="0" anchor="ctr"/>
-          <a:lstStyle/>
-          <a:p>
-            <a:pPr algn="ctr"/>
-            <a:endParaRPr/>
-          </a:p>
-        </p:txBody>
-      </p:sp>
-      <p:sp>
-        <p:nvSpPr>
-          <p:cNvPr id="12" name="Rectangle 11"/>
-          <p:cNvSpPr/>
-          <p:nvPr/>
-        </p:nvSpPr>
-        <p:spPr>
-          <a:xfrm>
-            <a:off x="822960" y="4160520"/>
-            <a:ext cx="91440" cy="868680"/>
-          </a:xfrm>
-          <a:prstGeom prst="rect">
-            <a:avLst/>
-          </a:prstGeom>
-          <a:solidFill>
-            <a:srgbClr val="F9B700"/>
-          </a:solidFill>
-          <a:ln>
-            <a:noFill/>
-          </a:ln>
-        </p:spPr>
-        <p:style>
-          <a:lnRef idx="1">
-            <a:schemeClr val="accent1"/>
-          </a:lnRef>
-          <a:fillRef idx="3">
-            <a:schemeClr val="accent1"/>
-          </a:fillRef>
-          <a:effectRef idx="2">
-            <a:schemeClr val="accent1"/>
-          </a:effectRef>
-          <a:fontRef idx="minor">
-            <a:schemeClr val="lt1"/>
-          </a:fontRef>
-        </p:style>
-        <p:txBody>
-          <a:bodyPr rtlCol="0" anchor="ctr"/>
-          <a:lstStyle/>
-          <a:p>
-            <a:pPr algn="ctr"/>
-            <a:endParaRPr/>
-          </a:p>
-        </p:txBody>
-      </p:sp>
-      <p:sp>
-        <p:nvSpPr>
-          <p:cNvPr id="13" name="TextBox 12"/>
-          <p:cNvSpPr txBox="1"/>
-          <p:nvPr/>
-        </p:nvSpPr>
-        <p:spPr>
-          <a:xfrm>
-            <a:off x="1005840" y="4270248"/>
-            <a:ext cx="10104120" cy="704088"/>
-          </a:xfrm>
-          <a:prstGeom prst="rect">
-            <a:avLst/>
-          </a:prstGeom>
-          <a:noFill/>
-        </p:spPr>
-        <p:txBody>
-          <a:bodyPr wrap="square" lIns="0" rIns="0">
-            <a:spAutoFit/>
-          </a:bodyPr>
-          <a:lstStyle/>
-          <a:p>
-            <a:pPr>
-              <a:defRPr sz="1500" b="1">
-                <a:solidFill>
-                  <a:srgbClr val="1E2761"/>
-                </a:solidFill>
-                <a:latin typeface="Aptos Display"/>
-              </a:defRPr>
-            </a:pPr>
-            <a:r>
-              <a:t>Lab connection</a:t>
-            </a:r>
-          </a:p>
-          <a:p>
-            <a:pPr>
-              <a:spcBef>
-                <a:spcPts val="400"/>
-              </a:spcBef>
-              <a:defRPr sz="1050">
-                <a:solidFill>
-                  <a:srgbClr val="242424"/>
-                </a:solidFill>
-                <a:latin typeface="Aptos"/>
-              </a:defRPr>
-            </a:pPr>
-            <a:r>
-              <a:t>Coverage: Covered. Use the lab README to demonstrate or discuss this topic. Review terms: considerations.</a:t>
+              <a:t>In the lab, you will apply this pattern, validate the expected behavior, and discuss where it fits in a real Power BI solution.</a:t>
             </a:r>
           </a:p>
         </p:txBody>
@@ -13067,42 +12455,6 @@
       </p:sp>
       <p:sp>
         <p:nvSpPr>
-          <p:cNvPr id="4" name="TextBox 3"/>
-          <p:cNvSpPr txBox="1"/>
-          <p:nvPr/>
-        </p:nvSpPr>
-        <p:spPr>
-          <a:xfrm>
-            <a:off x="530352" y="914400"/>
-            <a:ext cx="10515600" cy="320040"/>
-          </a:xfrm>
-          <a:prstGeom prst="rect">
-            <a:avLst/>
-          </a:prstGeom>
-          <a:noFill/>
-        </p:spPr>
-        <p:txBody>
-          <a:bodyPr wrap="none">
-            <a:spAutoFit/>
-          </a:bodyPr>
-          <a:lstStyle/>
-          <a:p>
-            <a:pPr>
-              <a:defRPr sz="1200">
-                <a:solidFill>
-                  <a:srgbClr val="5C5C5C"/>
-                </a:solidFill>
-                <a:latin typeface="Aptos"/>
-              </a:defRPr>
-            </a:pPr>
-            <a:r>
-              <a:t>Talking points, learner value, and lab connection</a:t>
-            </a:r>
-          </a:p>
-        </p:txBody>
-      </p:sp>
-      <p:sp>
-        <p:nvSpPr>
           <p:cNvPr id="5" name="Rounded Rectangle 4"/>
           <p:cNvSpPr/>
           <p:nvPr/>
@@ -13222,7 +12574,145 @@
               </a:defRPr>
             </a:pPr>
             <a:r>
-              <a:t>Talking points</a:t>
+              <a:t>Key ideas</a:t>
+            </a:r>
+            <a:br/>
+            <a:r>
+              <a:t>• Import</a:t>
+            </a:r>
+            <a:br/>
+            <a:r>
+              <a:t>• DirectQuery</a:t>
+            </a:r>
+            <a:br/>
+            <a:r>
+              <a:t>• Dual</a:t>
+            </a:r>
+          </a:p>
+        </p:txBody>
+      </p:sp>
+      <p:sp>
+        <p:nvSpPr>
+          <p:cNvPr id="8" name="Rounded Rectangle 7"/>
+          <p:cNvSpPr/>
+          <p:nvPr/>
+        </p:nvSpPr>
+        <p:spPr>
+          <a:xfrm>
+            <a:off x="6263640" y="1234440"/>
+            <a:ext cx="5303520" cy="1828800"/>
+          </a:xfrm>
+          <a:prstGeom prst="roundRect">
+            <a:avLst/>
+          </a:prstGeom>
+          <a:solidFill>
+            <a:srgbClr val="FFFFFF"/>
+          </a:solidFill>
+          <a:ln>
+            <a:solidFill>
+              <a:srgbClr val="DCDCDC"/>
+            </a:solidFill>
+          </a:ln>
+        </p:spPr>
+        <p:style>
+          <a:lnRef idx="1">
+            <a:schemeClr val="accent1"/>
+          </a:lnRef>
+          <a:fillRef idx="3">
+            <a:schemeClr val="accent1"/>
+          </a:fillRef>
+          <a:effectRef idx="2">
+            <a:schemeClr val="accent1"/>
+          </a:effectRef>
+          <a:fontRef idx="minor">
+            <a:schemeClr val="lt1"/>
+          </a:fontRef>
+        </p:style>
+        <p:txBody>
+          <a:bodyPr rtlCol="0" anchor="ctr"/>
+          <a:lstStyle/>
+          <a:p>
+            <a:pPr algn="ctr"/>
+            <a:endParaRPr/>
+          </a:p>
+        </p:txBody>
+      </p:sp>
+      <p:sp>
+        <p:nvSpPr>
+          <p:cNvPr id="9" name="Rectangle 8"/>
+          <p:cNvSpPr/>
+          <p:nvPr/>
+        </p:nvSpPr>
+        <p:spPr>
+          <a:xfrm>
+            <a:off x="6263640" y="1234440"/>
+            <a:ext cx="91440" cy="1828800"/>
+          </a:xfrm>
+          <a:prstGeom prst="rect">
+            <a:avLst/>
+          </a:prstGeom>
+          <a:solidFill>
+            <a:srgbClr val="02C39A"/>
+          </a:solidFill>
+          <a:ln>
+            <a:noFill/>
+          </a:ln>
+        </p:spPr>
+        <p:style>
+          <a:lnRef idx="1">
+            <a:schemeClr val="accent1"/>
+          </a:lnRef>
+          <a:fillRef idx="3">
+            <a:schemeClr val="accent1"/>
+          </a:fillRef>
+          <a:effectRef idx="2">
+            <a:schemeClr val="accent1"/>
+          </a:effectRef>
+          <a:fontRef idx="minor">
+            <a:schemeClr val="lt1"/>
+          </a:fontRef>
+        </p:style>
+        <p:txBody>
+          <a:bodyPr rtlCol="0" anchor="ctr"/>
+          <a:lstStyle/>
+          <a:p>
+            <a:pPr algn="ctr"/>
+            <a:endParaRPr/>
+          </a:p>
+        </p:txBody>
+      </p:sp>
+      <p:sp>
+        <p:nvSpPr>
+          <p:cNvPr id="10" name="TextBox 9"/>
+          <p:cNvSpPr txBox="1"/>
+          <p:nvPr/>
+        </p:nvSpPr>
+        <p:spPr>
+          <a:xfrm>
+            <a:off x="6446520" y="1344168"/>
+            <a:ext cx="4983480" cy="1664208"/>
+          </a:xfrm>
+          <a:prstGeom prst="rect">
+            <a:avLst/>
+          </a:prstGeom>
+          <a:noFill/>
+        </p:spPr>
+        <p:txBody>
+          <a:bodyPr wrap="square" lIns="0" rIns="0">
+            <a:spAutoFit/>
+          </a:bodyPr>
+          <a:lstStyle/>
+          <a:p>
+            <a:pPr>
+              <a:defRPr sz="1500" b="1">
+                <a:solidFill>
+                  <a:srgbClr val="1E2761"/>
+                </a:solidFill>
+                <a:latin typeface="Aptos Display"/>
+              </a:defRPr>
+            </a:pPr>
+            <a:r>
+              <a:t>Why it helps</a:t>
             </a:r>
           </a:p>
           <a:p>
@@ -13238,29 +12728,25 @@
               </a:defRPr>
             </a:pPr>
             <a:r>
-              <a:t>• Import</a:t>
+              <a:t>• Composite models</a:t>
             </a:r>
             <a:br/>
             <a:r>
-              <a:t>• DirectQuery</a:t>
-            </a:r>
-            <a:br/>
-            <a:r>
-              <a:t>• Dual</a:t>
-            </a:r>
-          </a:p>
-        </p:txBody>
-      </p:sp>
-      <p:sp>
-        <p:nvSpPr>
-          <p:cNvPr id="8" name="Rounded Rectangle 7"/>
+              <a:t>• Hybrid table concept</a:t>
+            </a:r>
+          </a:p>
+        </p:txBody>
+      </p:sp>
+      <p:sp>
+        <p:nvSpPr>
+          <p:cNvPr id="11" name="Rounded Rectangle 10"/>
           <p:cNvSpPr/>
           <p:nvPr/>
         </p:nvSpPr>
         <p:spPr>
           <a:xfrm>
-            <a:off x="6263640" y="1234440"/>
-            <a:ext cx="5303520" cy="1828800"/>
+            <a:off x="822960" y="4160520"/>
+            <a:ext cx="10424160" cy="868680"/>
           </a:xfrm>
           <a:prstGeom prst="roundRect">
             <a:avLst/>
@@ -13299,20 +12785,20 @@
       </p:sp>
       <p:sp>
         <p:nvSpPr>
-          <p:cNvPr id="9" name="Rectangle 8"/>
+          <p:cNvPr id="12" name="Rectangle 11"/>
           <p:cNvSpPr/>
           <p:nvPr/>
         </p:nvSpPr>
         <p:spPr>
           <a:xfrm>
-            <a:off x="6263640" y="1234440"/>
-            <a:ext cx="91440" cy="1828800"/>
+            <a:off x="822960" y="4160520"/>
+            <a:ext cx="91440" cy="868680"/>
           </a:xfrm>
           <a:prstGeom prst="rect">
             <a:avLst/>
           </a:prstGeom>
           <a:solidFill>
-            <a:srgbClr val="02C39A"/>
+            <a:srgbClr val="F9B700"/>
           </a:solidFill>
           <a:ln>
             <a:noFill/>
@@ -13343,14 +12829,14 @@
       </p:sp>
       <p:sp>
         <p:nvSpPr>
-          <p:cNvPr id="10" name="TextBox 9"/>
+          <p:cNvPr id="13" name="TextBox 12"/>
           <p:cNvSpPr txBox="1"/>
           <p:nvPr/>
         </p:nvSpPr>
         <p:spPr>
           <a:xfrm>
-            <a:off x="6446520" y="1344168"/>
-            <a:ext cx="4983480" cy="1664208"/>
+            <a:off x="1005840" y="4270248"/>
+            <a:ext cx="10104120" cy="704088"/>
           </a:xfrm>
           <a:prstGeom prst="rect">
             <a:avLst/>
@@ -13372,169 +12858,7 @@
               </a:defRPr>
             </a:pPr>
             <a:r>
-              <a:t>Why it helps</a:t>
-            </a:r>
-          </a:p>
-          <a:p>
-            <a:pPr>
-              <a:spcBef>
-                <a:spcPts val="400"/>
-              </a:spcBef>
-              <a:defRPr sz="1050">
-                <a:solidFill>
-                  <a:srgbClr val="242424"/>
-                </a:solidFill>
-                <a:latin typeface="Aptos"/>
-              </a:defRPr>
-            </a:pPr>
-            <a:r>
-              <a:t>• Composite models</a:t>
-            </a:r>
-            <a:br/>
-            <a:r>
-              <a:t>• Hybrid table concept</a:t>
-            </a:r>
-          </a:p>
-        </p:txBody>
-      </p:sp>
-      <p:sp>
-        <p:nvSpPr>
-          <p:cNvPr id="11" name="Rounded Rectangle 10"/>
-          <p:cNvSpPr/>
-          <p:nvPr/>
-        </p:nvSpPr>
-        <p:spPr>
-          <a:xfrm>
-            <a:off x="822960" y="4160520"/>
-            <a:ext cx="10424160" cy="868680"/>
-          </a:xfrm>
-          <a:prstGeom prst="roundRect">
-            <a:avLst/>
-          </a:prstGeom>
-          <a:solidFill>
-            <a:srgbClr val="FFFFFF"/>
-          </a:solidFill>
-          <a:ln>
-            <a:solidFill>
-              <a:srgbClr val="DCDCDC"/>
-            </a:solidFill>
-          </a:ln>
-        </p:spPr>
-        <p:style>
-          <a:lnRef idx="1">
-            <a:schemeClr val="accent1"/>
-          </a:lnRef>
-          <a:fillRef idx="3">
-            <a:schemeClr val="accent1"/>
-          </a:fillRef>
-          <a:effectRef idx="2">
-            <a:schemeClr val="accent1"/>
-          </a:effectRef>
-          <a:fontRef idx="minor">
-            <a:schemeClr val="lt1"/>
-          </a:fontRef>
-        </p:style>
-        <p:txBody>
-          <a:bodyPr rtlCol="0" anchor="ctr"/>
-          <a:lstStyle/>
-          <a:p>
-            <a:pPr algn="ctr"/>
-            <a:endParaRPr/>
-          </a:p>
-        </p:txBody>
-      </p:sp>
-      <p:sp>
-        <p:nvSpPr>
-          <p:cNvPr id="12" name="Rectangle 11"/>
-          <p:cNvSpPr/>
-          <p:nvPr/>
-        </p:nvSpPr>
-        <p:spPr>
-          <a:xfrm>
-            <a:off x="822960" y="4160520"/>
-            <a:ext cx="91440" cy="868680"/>
-          </a:xfrm>
-          <a:prstGeom prst="rect">
-            <a:avLst/>
-          </a:prstGeom>
-          <a:solidFill>
-            <a:srgbClr val="F9B700"/>
-          </a:solidFill>
-          <a:ln>
-            <a:noFill/>
-          </a:ln>
-        </p:spPr>
-        <p:style>
-          <a:lnRef idx="1">
-            <a:schemeClr val="accent1"/>
-          </a:lnRef>
-          <a:fillRef idx="3">
-            <a:schemeClr val="accent1"/>
-          </a:fillRef>
-          <a:effectRef idx="2">
-            <a:schemeClr val="accent1"/>
-          </a:effectRef>
-          <a:fontRef idx="minor">
-            <a:schemeClr val="lt1"/>
-          </a:fontRef>
-        </p:style>
-        <p:txBody>
-          <a:bodyPr rtlCol="0" anchor="ctr"/>
-          <a:lstStyle/>
-          <a:p>
-            <a:pPr algn="ctr"/>
-            <a:endParaRPr/>
-          </a:p>
-        </p:txBody>
-      </p:sp>
-      <p:sp>
-        <p:nvSpPr>
-          <p:cNvPr id="13" name="TextBox 12"/>
-          <p:cNvSpPr txBox="1"/>
-          <p:nvPr/>
-        </p:nvSpPr>
-        <p:spPr>
-          <a:xfrm>
-            <a:off x="1005840" y="4270248"/>
-            <a:ext cx="10104120" cy="704088"/>
-          </a:xfrm>
-          <a:prstGeom prst="rect">
-            <a:avLst/>
-          </a:prstGeom>
-          <a:noFill/>
-        </p:spPr>
-        <p:txBody>
-          <a:bodyPr wrap="square" lIns="0" rIns="0">
-            <a:spAutoFit/>
-          </a:bodyPr>
-          <a:lstStyle/>
-          <a:p>
-            <a:pPr>
-              <a:defRPr sz="1500" b="1">
-                <a:solidFill>
-                  <a:srgbClr val="1E2761"/>
-                </a:solidFill>
-                <a:latin typeface="Aptos Display"/>
-              </a:defRPr>
-            </a:pPr>
-            <a:r>
-              <a:t>Lab connection</a:t>
-            </a:r>
-          </a:p>
-          <a:p>
-            <a:pPr>
-              <a:spcBef>
-                <a:spcPts val="400"/>
-              </a:spcBef>
-              <a:defRPr sz="1050">
-                <a:solidFill>
-                  <a:srgbClr val="242424"/>
-                </a:solidFill>
-                <a:latin typeface="Aptos"/>
-              </a:defRPr>
-            </a:pPr>
-            <a:r>
-              <a:t>Coverage: Covered. Use the lab README to demonstrate or discuss this topic. Review terms: modes, requirements.</a:t>
+              <a:t>In the lab, you will apply this pattern, validate the expected behavior, and discuss where it fits in a real Power BI solution.</a:t>
             </a:r>
           </a:p>
         </p:txBody>

</xml_diff>